<commit_message>
Making seperate folder to keep all the graph plots and updating the presentation.
</commit_message>
<xml_diff>
--- a/Flapping wing design/Wing_Morphology.pptx
+++ b/Flapping wing design/Wing_Morphology.pptx
@@ -5,7 +5,7 @@
     <p:sldMasterId id="2147483676" r:id="rId1"/>
   </p:sldMasterIdLst>
   <p:notesMasterIdLst>
-    <p:notesMasterId r:id="rId23"/>
+    <p:notesMasterId r:id="rId34"/>
   </p:notesMasterIdLst>
   <p:sldIdLst>
     <p:sldId id="256" r:id="rId2"/>
@@ -22,13 +22,24 @@
     <p:sldId id="271" r:id="rId13"/>
     <p:sldId id="272" r:id="rId14"/>
     <p:sldId id="277" r:id="rId15"/>
-    <p:sldId id="273" r:id="rId16"/>
-    <p:sldId id="274" r:id="rId17"/>
-    <p:sldId id="278" r:id="rId18"/>
-    <p:sldId id="275" r:id="rId19"/>
-    <p:sldId id="276" r:id="rId20"/>
-    <p:sldId id="279" r:id="rId21"/>
-    <p:sldId id="265" r:id="rId22"/>
+    <p:sldId id="280" r:id="rId16"/>
+    <p:sldId id="284" r:id="rId17"/>
+    <p:sldId id="281" r:id="rId18"/>
+    <p:sldId id="282" r:id="rId19"/>
+    <p:sldId id="283" r:id="rId20"/>
+    <p:sldId id="285" r:id="rId21"/>
+    <p:sldId id="273" r:id="rId22"/>
+    <p:sldId id="274" r:id="rId23"/>
+    <p:sldId id="278" r:id="rId24"/>
+    <p:sldId id="286" r:id="rId25"/>
+    <p:sldId id="289" r:id="rId26"/>
+    <p:sldId id="287" r:id="rId27"/>
+    <p:sldId id="288" r:id="rId28"/>
+    <p:sldId id="290" r:id="rId29"/>
+    <p:sldId id="275" r:id="rId30"/>
+    <p:sldId id="276" r:id="rId31"/>
+    <p:sldId id="279" r:id="rId32"/>
+    <p:sldId id="265" r:id="rId33"/>
   </p:sldIdLst>
   <p:sldSz cx="9144000" cy="5143500" type="screen16x9"/>
   <p:notesSz cx="5143500" cy="9144000"/>
@@ -913,7 +924,7 @@
           <a:p>
             <a:fld id="{F7021451-1387-4CA6-816F-3879F97B5CBC}" type="slidenum">
               <a:rPr lang="en-US"/>
-              <a:t>21</a:t>
+              <a:t>32</a:t>
             </a:fld>
             <a:endParaRPr lang="en-US"/>
           </a:p>
@@ -1063,7 +1074,7 @@
           <a:p>
             <a:fld id="{C764DE79-268F-4C1A-8933-263129D2AF90}" type="datetimeFigureOut">
               <a:rPr lang="en-US" smtClean="0"/>
-              <a:t>6/29/2026</a:t>
+              <a:t>7/2/2026</a:t>
             </a:fld>
             <a:endParaRPr lang="en-US" dirty="0"/>
           </a:p>
@@ -1234,7 +1245,7 @@
           <a:p>
             <a:fld id="{C764DE79-268F-4C1A-8933-263129D2AF90}" type="datetimeFigureOut">
               <a:rPr lang="en-US" smtClean="0"/>
-              <a:t>6/29/2026</a:t>
+              <a:t>7/2/2026</a:t>
             </a:fld>
             <a:endParaRPr lang="en-US" dirty="0"/>
           </a:p>
@@ -1415,7 +1426,7 @@
           <a:p>
             <a:fld id="{C764DE79-268F-4C1A-8933-263129D2AF90}" type="datetimeFigureOut">
               <a:rPr lang="en-US" smtClean="0"/>
-              <a:t>6/29/2026</a:t>
+              <a:t>7/2/2026</a:t>
             </a:fld>
             <a:endParaRPr lang="en-US" dirty="0"/>
           </a:p>
@@ -1621,7 +1632,7 @@
           <a:p>
             <a:fld id="{C764DE79-268F-4C1A-8933-263129D2AF90}" type="datetimeFigureOut">
               <a:rPr lang="en-US" smtClean="0"/>
-              <a:t>6/29/2026</a:t>
+              <a:t>7/2/2026</a:t>
             </a:fld>
             <a:endParaRPr lang="en-US" dirty="0"/>
           </a:p>
@@ -1868,7 +1879,7 @@
           <a:p>
             <a:fld id="{C764DE79-268F-4C1A-8933-263129D2AF90}" type="datetimeFigureOut">
               <a:rPr lang="en-US" smtClean="0"/>
-              <a:t>6/29/2026</a:t>
+              <a:t>7/2/2026</a:t>
             </a:fld>
             <a:endParaRPr lang="en-US" dirty="0"/>
           </a:p>
@@ -2101,7 +2112,7 @@
           <a:p>
             <a:fld id="{C764DE79-268F-4C1A-8933-263129D2AF90}" type="datetimeFigureOut">
               <a:rPr lang="en-US" smtClean="0"/>
-              <a:t>6/29/2026</a:t>
+              <a:t>7/2/2026</a:t>
             </a:fld>
             <a:endParaRPr lang="en-US" dirty="0"/>
           </a:p>
@@ -2469,7 +2480,7 @@
           <a:p>
             <a:fld id="{C764DE79-268F-4C1A-8933-263129D2AF90}" type="datetimeFigureOut">
               <a:rPr lang="en-US" smtClean="0"/>
-              <a:t>6/29/2026</a:t>
+              <a:t>7/2/2026</a:t>
             </a:fld>
             <a:endParaRPr lang="en-US" dirty="0"/>
           </a:p>
@@ -2588,7 +2599,7 @@
           <a:p>
             <a:fld id="{C764DE79-268F-4C1A-8933-263129D2AF90}" type="datetimeFigureOut">
               <a:rPr lang="en-US" smtClean="0"/>
-              <a:t>6/29/2026</a:t>
+              <a:t>7/2/2026</a:t>
             </a:fld>
             <a:endParaRPr lang="en-US" dirty="0"/>
           </a:p>
@@ -2684,7 +2695,7 @@
           <a:p>
             <a:fld id="{C764DE79-268F-4C1A-8933-263129D2AF90}" type="datetimeFigureOut">
               <a:rPr lang="en-US" smtClean="0"/>
-              <a:t>6/29/2026</a:t>
+              <a:t>7/2/2026</a:t>
             </a:fld>
             <a:endParaRPr lang="en-US" dirty="0"/>
           </a:p>
@@ -2962,7 +2973,7 @@
           <a:p>
             <a:fld id="{C764DE79-268F-4C1A-8933-263129D2AF90}" type="datetimeFigureOut">
               <a:rPr lang="en-US" smtClean="0"/>
-              <a:t>6/29/2026</a:t>
+              <a:t>7/2/2026</a:t>
             </a:fld>
             <a:endParaRPr lang="en-US" dirty="0"/>
           </a:p>
@@ -3220,7 +3231,7 @@
           <a:p>
             <a:fld id="{C764DE79-268F-4C1A-8933-263129D2AF90}" type="datetimeFigureOut">
               <a:rPr lang="en-US" smtClean="0"/>
-              <a:t>6/29/2026</a:t>
+              <a:t>7/2/2026</a:t>
             </a:fld>
             <a:endParaRPr lang="en-US" dirty="0"/>
           </a:p>
@@ -3434,7 +3445,7 @@
           <a:p>
             <a:fld id="{C764DE79-268F-4C1A-8933-263129D2AF90}" type="datetimeFigureOut">
               <a:rPr lang="en-US" smtClean="0"/>
-              <a:t>6/29/2026</a:t>
+              <a:t>7/2/2026</a:t>
             </a:fld>
             <a:endParaRPr lang="en-US" dirty="0"/>
           </a:p>
@@ -5429,6 +5440,1258 @@
           <a:chExt cx="0" cy="0"/>
         </a:xfrm>
       </p:grpSpPr>
+      <p:pic>
+        <p:nvPicPr>
+          <p:cNvPr id="3" name="Picture 2">
+            <a:extLst>
+              <a:ext uri="{FF2B5EF4-FFF2-40B4-BE49-F238E27FC236}">
+                <a16:creationId xmlns:a16="http://schemas.microsoft.com/office/drawing/2014/main" id="{5799D866-9ACD-54B8-B7AB-DD00004B6E8C}"/>
+              </a:ext>
+            </a:extLst>
+          </p:cNvPr>
+          <p:cNvPicPr>
+            <a:picLocks noChangeAspect="1"/>
+          </p:cNvPicPr>
+          <p:nvPr/>
+        </p:nvPicPr>
+        <p:blipFill>
+          <a:blip r:embed="rId2"/>
+          <a:stretch>
+            <a:fillRect/>
+          </a:stretch>
+        </p:blipFill>
+        <p:spPr>
+          <a:xfrm>
+            <a:off x="0" y="771525"/>
+            <a:ext cx="9144000" cy="4371975"/>
+          </a:xfrm>
+          <a:prstGeom prst="rect">
+            <a:avLst/>
+          </a:prstGeom>
+        </p:spPr>
+      </p:pic>
+      <p:sp>
+        <p:nvSpPr>
+          <p:cNvPr id="4" name="TextBox 3">
+            <a:extLst>
+              <a:ext uri="{FF2B5EF4-FFF2-40B4-BE49-F238E27FC236}">
+                <a16:creationId xmlns:a16="http://schemas.microsoft.com/office/drawing/2014/main" id="{652ECF0D-883D-ED5C-E59D-C7C47EDDFF44}"/>
+              </a:ext>
+            </a:extLst>
+          </p:cNvPr>
+          <p:cNvSpPr txBox="1"/>
+          <p:nvPr/>
+        </p:nvSpPr>
+        <p:spPr>
+          <a:xfrm>
+            <a:off x="1509302" y="137160"/>
+            <a:ext cx="6125395" cy="461665"/>
+          </a:xfrm>
+          <a:prstGeom prst="rect">
+            <a:avLst/>
+          </a:prstGeom>
+          <a:noFill/>
+        </p:spPr>
+        <p:txBody>
+          <a:bodyPr wrap="none" rtlCol="0">
+            <a:spAutoFit/>
+          </a:bodyPr>
+          <a:lstStyle/>
+          <a:p>
+            <a:r>
+              <a:rPr lang="en-IN" sz="2400" dirty="0"/>
+              <a:t>Rectangular wing profile with leading edge spar</a:t>
+            </a:r>
+          </a:p>
+        </p:txBody>
+      </p:sp>
+    </p:spTree>
+    <p:extLst>
+      <p:ext uri="{BB962C8B-B14F-4D97-AF65-F5344CB8AC3E}">
+        <p14:creationId xmlns:p14="http://schemas.microsoft.com/office/powerpoint/2010/main" val="641054266"/>
+      </p:ext>
+    </p:extLst>
+  </p:cSld>
+  <p:clrMapOvr>
+    <a:masterClrMapping/>
+  </p:clrMapOvr>
+</p:sld>
+</file>
+
+<file path=ppt/slides/slide16.xml><?xml version="1.0" encoding="utf-8"?>
+<p:sld xmlns:a="http://schemas.openxmlformats.org/drawingml/2006/main" xmlns:r="http://schemas.openxmlformats.org/officeDocument/2006/relationships" xmlns:p="http://schemas.openxmlformats.org/presentationml/2006/main">
+  <p:cSld>
+    <p:spTree>
+      <p:nvGrpSpPr>
+        <p:cNvPr id="1" name=""/>
+        <p:cNvGrpSpPr/>
+        <p:nvPr/>
+      </p:nvGrpSpPr>
+      <p:grpSpPr>
+        <a:xfrm>
+          <a:off x="0" y="0"/>
+          <a:ext cx="0" cy="0"/>
+          <a:chOff x="0" y="0"/>
+          <a:chExt cx="0" cy="0"/>
+        </a:xfrm>
+      </p:grpSpPr>
+      <p:pic>
+        <p:nvPicPr>
+          <p:cNvPr id="3" name="Picture 2">
+            <a:extLst>
+              <a:ext uri="{FF2B5EF4-FFF2-40B4-BE49-F238E27FC236}">
+                <a16:creationId xmlns:a16="http://schemas.microsoft.com/office/drawing/2014/main" id="{CED05046-B261-EB6B-9D6B-B463D897B7F0}"/>
+              </a:ext>
+            </a:extLst>
+          </p:cNvPr>
+          <p:cNvPicPr>
+            <a:picLocks noChangeAspect="1"/>
+          </p:cNvPicPr>
+          <p:nvPr/>
+        </p:nvPicPr>
+        <p:blipFill>
+          <a:blip r:embed="rId2"/>
+          <a:stretch>
+            <a:fillRect/>
+          </a:stretch>
+        </p:blipFill>
+        <p:spPr>
+          <a:xfrm>
+            <a:off x="0" y="525780"/>
+            <a:ext cx="9144000" cy="4635344"/>
+          </a:xfrm>
+          <a:prstGeom prst="rect">
+            <a:avLst/>
+          </a:prstGeom>
+        </p:spPr>
+      </p:pic>
+      <p:sp>
+        <p:nvSpPr>
+          <p:cNvPr id="4" name="TextBox 3">
+            <a:extLst>
+              <a:ext uri="{FF2B5EF4-FFF2-40B4-BE49-F238E27FC236}">
+                <a16:creationId xmlns:a16="http://schemas.microsoft.com/office/drawing/2014/main" id="{D91978DC-8948-FD64-2072-60B1B67FD36E}"/>
+              </a:ext>
+            </a:extLst>
+          </p:cNvPr>
+          <p:cNvSpPr txBox="1"/>
+          <p:nvPr/>
+        </p:nvSpPr>
+        <p:spPr>
+          <a:xfrm>
+            <a:off x="4034320" y="45720"/>
+            <a:ext cx="1075359" cy="461665"/>
+          </a:xfrm>
+          <a:prstGeom prst="rect">
+            <a:avLst/>
+          </a:prstGeom>
+          <a:noFill/>
+        </p:spPr>
+        <p:txBody>
+          <a:bodyPr wrap="none" rtlCol="0">
+            <a:spAutoFit/>
+          </a:bodyPr>
+          <a:lstStyle/>
+          <a:p>
+            <a:r>
+              <a:rPr lang="en-IN" sz="2400" dirty="0"/>
+              <a:t>Results</a:t>
+            </a:r>
+          </a:p>
+        </p:txBody>
+      </p:sp>
+    </p:spTree>
+    <p:extLst>
+      <p:ext uri="{BB962C8B-B14F-4D97-AF65-F5344CB8AC3E}">
+        <p14:creationId xmlns:p14="http://schemas.microsoft.com/office/powerpoint/2010/main" val="2180991725"/>
+      </p:ext>
+    </p:extLst>
+  </p:cSld>
+  <p:clrMapOvr>
+    <a:masterClrMapping/>
+  </p:clrMapOvr>
+</p:sld>
+</file>
+
+<file path=ppt/slides/slide17.xml><?xml version="1.0" encoding="utf-8"?>
+<p:sld xmlns:a="http://schemas.openxmlformats.org/drawingml/2006/main" xmlns:r="http://schemas.openxmlformats.org/officeDocument/2006/relationships" xmlns:p="http://schemas.openxmlformats.org/presentationml/2006/main">
+  <p:cSld>
+    <p:spTree>
+      <p:nvGrpSpPr>
+        <p:cNvPr id="1" name=""/>
+        <p:cNvGrpSpPr/>
+        <p:nvPr/>
+      </p:nvGrpSpPr>
+      <p:grpSpPr>
+        <a:xfrm>
+          <a:off x="0" y="0"/>
+          <a:ext cx="0" cy="0"/>
+          <a:chOff x="0" y="0"/>
+          <a:chExt cx="0" cy="0"/>
+        </a:xfrm>
+      </p:grpSpPr>
+      <p:pic>
+        <p:nvPicPr>
+          <p:cNvPr id="3" name="Picture 2">
+            <a:extLst>
+              <a:ext uri="{FF2B5EF4-FFF2-40B4-BE49-F238E27FC236}">
+                <a16:creationId xmlns:a16="http://schemas.microsoft.com/office/drawing/2014/main" id="{A600E64B-582A-1140-E8FC-69E68668F4AC}"/>
+              </a:ext>
+            </a:extLst>
+          </p:cNvPr>
+          <p:cNvPicPr>
+            <a:picLocks noChangeAspect="1"/>
+          </p:cNvPicPr>
+          <p:nvPr/>
+        </p:nvPicPr>
+        <p:blipFill>
+          <a:blip r:embed="rId2"/>
+          <a:stretch>
+            <a:fillRect/>
+          </a:stretch>
+        </p:blipFill>
+        <p:spPr>
+          <a:xfrm>
+            <a:off x="0" y="771525"/>
+            <a:ext cx="9144000" cy="4371975"/>
+          </a:xfrm>
+          <a:prstGeom prst="rect">
+            <a:avLst/>
+          </a:prstGeom>
+        </p:spPr>
+      </p:pic>
+      <p:sp>
+        <p:nvSpPr>
+          <p:cNvPr id="5" name="TextBox 4">
+            <a:extLst>
+              <a:ext uri="{FF2B5EF4-FFF2-40B4-BE49-F238E27FC236}">
+                <a16:creationId xmlns:a16="http://schemas.microsoft.com/office/drawing/2014/main" id="{B5CAE693-D125-DBD9-9919-B0A53AF59132}"/>
+              </a:ext>
+            </a:extLst>
+          </p:cNvPr>
+          <p:cNvSpPr txBox="1"/>
+          <p:nvPr/>
+        </p:nvSpPr>
+        <p:spPr>
+          <a:xfrm>
+            <a:off x="1600353" y="141208"/>
+            <a:ext cx="5943294" cy="461665"/>
+          </a:xfrm>
+          <a:prstGeom prst="rect">
+            <a:avLst/>
+          </a:prstGeom>
+          <a:noFill/>
+        </p:spPr>
+        <p:txBody>
+          <a:bodyPr wrap="none" rtlCol="0">
+            <a:spAutoFit/>
+          </a:bodyPr>
+          <a:lstStyle/>
+          <a:p>
+            <a:r>
+              <a:rPr lang="en-IN" sz="2400" dirty="0"/>
+              <a:t>Triangular wing profile with leading edge spar </a:t>
+            </a:r>
+          </a:p>
+        </p:txBody>
+      </p:sp>
+    </p:spTree>
+    <p:extLst>
+      <p:ext uri="{BB962C8B-B14F-4D97-AF65-F5344CB8AC3E}">
+        <p14:creationId xmlns:p14="http://schemas.microsoft.com/office/powerpoint/2010/main" val="1943633185"/>
+      </p:ext>
+    </p:extLst>
+  </p:cSld>
+  <p:clrMapOvr>
+    <a:masterClrMapping/>
+  </p:clrMapOvr>
+</p:sld>
+</file>
+
+<file path=ppt/slides/slide18.xml><?xml version="1.0" encoding="utf-8"?>
+<p:sld xmlns:a="http://schemas.openxmlformats.org/drawingml/2006/main" xmlns:r="http://schemas.openxmlformats.org/officeDocument/2006/relationships" xmlns:p="http://schemas.openxmlformats.org/presentationml/2006/main">
+  <p:cSld>
+    <p:spTree>
+      <p:nvGrpSpPr>
+        <p:cNvPr id="1" name=""/>
+        <p:cNvGrpSpPr/>
+        <p:nvPr/>
+      </p:nvGrpSpPr>
+      <p:grpSpPr>
+        <a:xfrm>
+          <a:off x="0" y="0"/>
+          <a:ext cx="0" cy="0"/>
+          <a:chOff x="0" y="0"/>
+          <a:chExt cx="0" cy="0"/>
+        </a:xfrm>
+      </p:grpSpPr>
+      <p:pic>
+        <p:nvPicPr>
+          <p:cNvPr id="3" name="Picture 2">
+            <a:extLst>
+              <a:ext uri="{FF2B5EF4-FFF2-40B4-BE49-F238E27FC236}">
+                <a16:creationId xmlns:a16="http://schemas.microsoft.com/office/drawing/2014/main" id="{71F31498-D2D9-E344-DA60-BE641130F731}"/>
+              </a:ext>
+            </a:extLst>
+          </p:cNvPr>
+          <p:cNvPicPr>
+            <a:picLocks noChangeAspect="1"/>
+          </p:cNvPicPr>
+          <p:nvPr/>
+        </p:nvPicPr>
+        <p:blipFill>
+          <a:blip r:embed="rId2"/>
+          <a:stretch>
+            <a:fillRect/>
+          </a:stretch>
+        </p:blipFill>
+        <p:spPr>
+          <a:xfrm>
+            <a:off x="0" y="758732"/>
+            <a:ext cx="9144000" cy="4395876"/>
+          </a:xfrm>
+          <a:prstGeom prst="rect">
+            <a:avLst/>
+          </a:prstGeom>
+        </p:spPr>
+      </p:pic>
+      <p:sp>
+        <p:nvSpPr>
+          <p:cNvPr id="4" name="TextBox 3">
+            <a:extLst>
+              <a:ext uri="{FF2B5EF4-FFF2-40B4-BE49-F238E27FC236}">
+                <a16:creationId xmlns:a16="http://schemas.microsoft.com/office/drawing/2014/main" id="{58F974C8-79CE-D626-0F8B-33658EF1AC66}"/>
+              </a:ext>
+            </a:extLst>
+          </p:cNvPr>
+          <p:cNvSpPr txBox="1"/>
+          <p:nvPr/>
+        </p:nvSpPr>
+        <p:spPr>
+          <a:xfrm>
+            <a:off x="4034320" y="175260"/>
+            <a:ext cx="1075359" cy="461665"/>
+          </a:xfrm>
+          <a:prstGeom prst="rect">
+            <a:avLst/>
+          </a:prstGeom>
+          <a:noFill/>
+        </p:spPr>
+        <p:txBody>
+          <a:bodyPr wrap="none" rtlCol="0">
+            <a:spAutoFit/>
+          </a:bodyPr>
+          <a:lstStyle/>
+          <a:p>
+            <a:r>
+              <a:rPr lang="en-IN" sz="2400" dirty="0"/>
+              <a:t>Results</a:t>
+            </a:r>
+          </a:p>
+        </p:txBody>
+      </p:sp>
+    </p:spTree>
+    <p:extLst>
+      <p:ext uri="{BB962C8B-B14F-4D97-AF65-F5344CB8AC3E}">
+        <p14:creationId xmlns:p14="http://schemas.microsoft.com/office/powerpoint/2010/main" val="869921688"/>
+      </p:ext>
+    </p:extLst>
+  </p:cSld>
+  <p:clrMapOvr>
+    <a:masterClrMapping/>
+  </p:clrMapOvr>
+</p:sld>
+</file>
+
+<file path=ppt/slides/slide19.xml><?xml version="1.0" encoding="utf-8"?>
+<p:sld xmlns:a="http://schemas.openxmlformats.org/drawingml/2006/main" xmlns:r="http://schemas.openxmlformats.org/officeDocument/2006/relationships" xmlns:p="http://schemas.openxmlformats.org/presentationml/2006/main">
+  <p:cSld>
+    <p:spTree>
+      <p:nvGrpSpPr>
+        <p:cNvPr id="1" name=""/>
+        <p:cNvGrpSpPr/>
+        <p:nvPr/>
+      </p:nvGrpSpPr>
+      <p:grpSpPr>
+        <a:xfrm>
+          <a:off x="0" y="0"/>
+          <a:ext cx="0" cy="0"/>
+          <a:chOff x="0" y="0"/>
+          <a:chExt cx="0" cy="0"/>
+        </a:xfrm>
+      </p:grpSpPr>
+      <p:pic>
+        <p:nvPicPr>
+          <p:cNvPr id="3" name="Picture 2">
+            <a:extLst>
+              <a:ext uri="{FF2B5EF4-FFF2-40B4-BE49-F238E27FC236}">
+                <a16:creationId xmlns:a16="http://schemas.microsoft.com/office/drawing/2014/main" id="{BB11318E-6E73-F8EC-4928-85446E9F5708}"/>
+              </a:ext>
+            </a:extLst>
+          </p:cNvPr>
+          <p:cNvPicPr>
+            <a:picLocks noChangeAspect="1"/>
+          </p:cNvPicPr>
+          <p:nvPr/>
+        </p:nvPicPr>
+        <p:blipFill>
+          <a:blip r:embed="rId2"/>
+          <a:stretch>
+            <a:fillRect/>
+          </a:stretch>
+        </p:blipFill>
+        <p:spPr>
+          <a:xfrm>
+            <a:off x="0" y="771525"/>
+            <a:ext cx="9144000" cy="4371975"/>
+          </a:xfrm>
+          <a:prstGeom prst="rect">
+            <a:avLst/>
+          </a:prstGeom>
+        </p:spPr>
+      </p:pic>
+      <p:sp>
+        <p:nvSpPr>
+          <p:cNvPr id="4" name="TextBox 3">
+            <a:extLst>
+              <a:ext uri="{FF2B5EF4-FFF2-40B4-BE49-F238E27FC236}">
+                <a16:creationId xmlns:a16="http://schemas.microsoft.com/office/drawing/2014/main" id="{EFC64EA3-CB67-DDD8-AF8E-94AB57F3C731}"/>
+              </a:ext>
+            </a:extLst>
+          </p:cNvPr>
+          <p:cNvSpPr txBox="1"/>
+          <p:nvPr/>
+        </p:nvSpPr>
+        <p:spPr>
+          <a:xfrm>
+            <a:off x="1816085" y="137160"/>
+            <a:ext cx="5511830" cy="461665"/>
+          </a:xfrm>
+          <a:prstGeom prst="rect">
+            <a:avLst/>
+          </a:prstGeom>
+          <a:noFill/>
+        </p:spPr>
+        <p:txBody>
+          <a:bodyPr wrap="none" rtlCol="0">
+            <a:spAutoFit/>
+          </a:bodyPr>
+          <a:lstStyle/>
+          <a:p>
+            <a:r>
+              <a:rPr lang="en-IN" sz="2400" dirty="0"/>
+              <a:t>Curved wing profile with leading edge spar</a:t>
+            </a:r>
+          </a:p>
+        </p:txBody>
+      </p:sp>
+    </p:spTree>
+    <p:extLst>
+      <p:ext uri="{BB962C8B-B14F-4D97-AF65-F5344CB8AC3E}">
+        <p14:creationId xmlns:p14="http://schemas.microsoft.com/office/powerpoint/2010/main" val="1075780274"/>
+      </p:ext>
+    </p:extLst>
+  </p:cSld>
+  <p:clrMapOvr>
+    <a:masterClrMapping/>
+  </p:clrMapOvr>
+</p:sld>
+</file>
+
+<file path=ppt/slides/slide2.xml><?xml version="1.0" encoding="utf-8"?>
+<p:sld xmlns:a="http://schemas.openxmlformats.org/drawingml/2006/main" xmlns:r="http://schemas.openxmlformats.org/officeDocument/2006/relationships" xmlns:p="http://schemas.openxmlformats.org/presentationml/2006/main">
+  <p:cSld name="Slide 2">
+    <p:bg>
+      <p:bgPr>
+        <a:solidFill>
+          <a:srgbClr val="F7F7F7"/>
+        </a:solidFill>
+        <a:effectLst/>
+      </p:bgPr>
+    </p:bg>
+    <p:spTree>
+      <p:nvGrpSpPr>
+        <p:cNvPr id="1" name=""/>
+        <p:cNvGrpSpPr/>
+        <p:nvPr/>
+      </p:nvGrpSpPr>
+      <p:grpSpPr>
+        <a:xfrm>
+          <a:off x="0" y="0"/>
+          <a:ext cx="0" cy="0"/>
+          <a:chOff x="0" y="0"/>
+          <a:chExt cx="0" cy="0"/>
+        </a:xfrm>
+      </p:grpSpPr>
+      <p:sp>
+        <p:nvSpPr>
+          <p:cNvPr id="2" name="Text 0"/>
+          <p:cNvSpPr/>
+          <p:nvPr/>
+        </p:nvSpPr>
+        <p:spPr>
+          <a:xfrm>
+            <a:off x="365760" y="164592"/>
+            <a:ext cx="2743200" cy="201168"/>
+          </a:xfrm>
+          <a:prstGeom prst="rect">
+            <a:avLst/>
+          </a:prstGeom>
+          <a:noFill/>
+          <a:ln/>
+        </p:spPr>
+        <p:txBody>
+          <a:bodyPr wrap="square" rtlCol="0" anchor="ctr"/>
+          <a:lstStyle/>
+          <a:p>
+            <a:pPr marL="0" indent="0" algn="l">
+              <a:buNone/>
+            </a:pPr>
+            <a:r>
+              <a:rPr lang="en-US" sz="1400" b="1" kern="0" spc="300" dirty="0">
+                <a:solidFill>
+                  <a:srgbClr val="4A90D9"/>
+                </a:solidFill>
+                <a:latin typeface="Calibri" pitchFamily="34" charset="0"/>
+                <a:ea typeface="Calibri" pitchFamily="34" charset="-122"/>
+                <a:cs typeface="Calibri" pitchFamily="34" charset="-120"/>
+              </a:rPr>
+              <a:t>INTRODUCTION</a:t>
+            </a:r>
+            <a:endParaRPr lang="en-US" sz="1400" dirty="0"/>
+          </a:p>
+        </p:txBody>
+      </p:sp>
+      <p:sp>
+        <p:nvSpPr>
+          <p:cNvPr id="3" name="Text 1"/>
+          <p:cNvSpPr/>
+          <p:nvPr/>
+        </p:nvSpPr>
+        <p:spPr>
+          <a:xfrm>
+            <a:off x="365760" y="384048"/>
+            <a:ext cx="8412480" cy="548640"/>
+          </a:xfrm>
+          <a:prstGeom prst="rect">
+            <a:avLst/>
+          </a:prstGeom>
+          <a:noFill/>
+          <a:ln/>
+        </p:spPr>
+        <p:txBody>
+          <a:bodyPr wrap="square" rtlCol="0" anchor="ctr"/>
+          <a:lstStyle/>
+          <a:p>
+            <a:pPr marL="0" indent="0" algn="l">
+              <a:buNone/>
+            </a:pPr>
+            <a:r>
+              <a:rPr lang="en-US" sz="2600" b="1" dirty="0">
+                <a:solidFill>
+                  <a:srgbClr val="1E1E2E"/>
+                </a:solidFill>
+                <a:latin typeface="Calibri" pitchFamily="34" charset="0"/>
+                <a:ea typeface="Calibri" pitchFamily="34" charset="-122"/>
+                <a:cs typeface="Calibri" pitchFamily="34" charset="-120"/>
+              </a:rPr>
+              <a:t>Background &amp; Motivation</a:t>
+            </a:r>
+            <a:endParaRPr lang="en-US" sz="2600" dirty="0"/>
+          </a:p>
+        </p:txBody>
+      </p:sp>
+      <p:sp>
+        <p:nvSpPr>
+          <p:cNvPr id="4" name="Shape 2"/>
+          <p:cNvSpPr/>
+          <p:nvPr/>
+        </p:nvSpPr>
+        <p:spPr>
+          <a:xfrm>
+            <a:off x="365760" y="987552"/>
+            <a:ext cx="8412480" cy="22860"/>
+          </a:xfrm>
+          <a:prstGeom prst="rect">
+            <a:avLst/>
+          </a:prstGeom>
+          <a:solidFill>
+            <a:srgbClr val="4A90D9"/>
+          </a:solidFill>
+          <a:ln w="12700">
+            <a:solidFill>
+              <a:srgbClr val="4A90D9"/>
+            </a:solidFill>
+            <a:prstDash val="solid"/>
+          </a:ln>
+        </p:spPr>
+      </p:sp>
+      <p:sp>
+        <p:nvSpPr>
+          <p:cNvPr id="5" name="Text 3"/>
+          <p:cNvSpPr/>
+          <p:nvPr/>
+        </p:nvSpPr>
+        <p:spPr>
+          <a:xfrm>
+            <a:off x="365760" y="1143000"/>
+            <a:ext cx="4937760" cy="4000500"/>
+          </a:xfrm>
+          <a:prstGeom prst="rect">
+            <a:avLst/>
+          </a:prstGeom>
+          <a:noFill/>
+          <a:ln/>
+        </p:spPr>
+        <p:txBody>
+          <a:bodyPr wrap="square" rtlCol="0" anchor="t"/>
+          <a:lstStyle/>
+          <a:p>
+            <a:pPr marL="0" indent="0" algn="l">
+              <a:buNone/>
+            </a:pPr>
+            <a:r>
+              <a:rPr lang="en-US" sz="1200" b="1" dirty="0">
+                <a:solidFill>
+                  <a:srgbClr val="1E1E2E"/>
+                </a:solidFill>
+                <a:latin typeface="Calibri" pitchFamily="34" charset="0"/>
+                <a:ea typeface="Calibri" pitchFamily="34" charset="-122"/>
+                <a:cs typeface="Calibri" pitchFamily="34" charset="-120"/>
+              </a:rPr>
+              <a:t>What are Micro Air Vehicles (MAVs)?</a:t>
+            </a:r>
+            <a:endParaRPr lang="en-US" sz="1200" dirty="0"/>
+          </a:p>
+          <a:p>
+            <a:pPr marL="0" indent="0" algn="l">
+              <a:buNone/>
+            </a:pPr>
+            <a:r>
+              <a:rPr lang="en-US" sz="1100" dirty="0">
+                <a:solidFill>
+                  <a:srgbClr val="6B7280"/>
+                </a:solidFill>
+                <a:latin typeface="Calibri" pitchFamily="34" charset="0"/>
+                <a:ea typeface="Calibri" pitchFamily="34" charset="-122"/>
+                <a:cs typeface="Calibri" pitchFamily="34" charset="-120"/>
+              </a:rPr>
+              <a:t>Insect-scale robots that use flapping wings for lift and thrust.</a:t>
+            </a:r>
+            <a:endParaRPr lang="en-US" sz="1100" dirty="0"/>
+          </a:p>
+          <a:p>
+            <a:pPr marL="0" indent="0" algn="l">
+              <a:buNone/>
+            </a:pPr>
+            <a:r>
+              <a:rPr lang="en-US" sz="1100" dirty="0">
+                <a:solidFill>
+                  <a:srgbClr val="000000"/>
+                </a:solidFill>
+                <a:latin typeface="Calibri" pitchFamily="34" charset="0"/>
+                <a:ea typeface="Calibri" pitchFamily="34" charset="-122"/>
+                <a:cs typeface="Calibri" pitchFamily="34" charset="-120"/>
+              </a:rPr>
+              <a:t> </a:t>
+            </a:r>
+            <a:endParaRPr lang="en-US" sz="1200" dirty="0"/>
+          </a:p>
+          <a:p>
+            <a:pPr marL="0" indent="0" algn="l">
+              <a:buNone/>
+            </a:pPr>
+            <a:r>
+              <a:rPr lang="en-US" sz="1200" b="1" dirty="0">
+                <a:solidFill>
+                  <a:srgbClr val="1E1E2E"/>
+                </a:solidFill>
+                <a:latin typeface="Calibri" pitchFamily="34" charset="0"/>
+                <a:ea typeface="Calibri" pitchFamily="34" charset="-122"/>
+                <a:cs typeface="Calibri" pitchFamily="34" charset="-120"/>
+              </a:rPr>
+              <a:t>The RoboBee Platform</a:t>
+            </a:r>
+            <a:endParaRPr lang="en-US" sz="1200" dirty="0"/>
+          </a:p>
+          <a:p>
+            <a:pPr marL="0" indent="0" algn="l">
+              <a:buNone/>
+            </a:pPr>
+            <a:r>
+              <a:rPr lang="en-US" sz="1100" dirty="0">
+                <a:solidFill>
+                  <a:srgbClr val="6B7280"/>
+                </a:solidFill>
+                <a:latin typeface="Calibri" pitchFamily="34" charset="0"/>
+                <a:ea typeface="Calibri" pitchFamily="34" charset="-122"/>
+                <a:cs typeface="Calibri" pitchFamily="34" charset="-120"/>
+              </a:rPr>
+              <a:t>Developed at Harvard Microrobotics Lab. Mass ≈ 80 mg.</a:t>
+            </a:r>
+            <a:endParaRPr lang="en-US" sz="1100" dirty="0"/>
+          </a:p>
+          <a:p>
+            <a:pPr marL="0" indent="0" algn="l">
+              <a:buNone/>
+            </a:pPr>
+            <a:r>
+              <a:rPr lang="en-US" sz="1100" dirty="0">
+                <a:solidFill>
+                  <a:srgbClr val="000000"/>
+                </a:solidFill>
+                <a:latin typeface="Calibri" pitchFamily="34" charset="0"/>
+                <a:ea typeface="Calibri" pitchFamily="34" charset="-122"/>
+                <a:cs typeface="Calibri" pitchFamily="34" charset="-120"/>
+              </a:rPr>
+              <a:t> </a:t>
+            </a:r>
+            <a:endParaRPr lang="en-US" sz="1100" dirty="0"/>
+          </a:p>
+          <a:p>
+            <a:pPr marL="0" indent="0" algn="l">
+              <a:buNone/>
+            </a:pPr>
+            <a:r>
+              <a:rPr lang="en-US" sz="1200" b="1" dirty="0">
+                <a:solidFill>
+                  <a:srgbClr val="1E1E2E"/>
+                </a:solidFill>
+                <a:latin typeface="Calibri" pitchFamily="34" charset="0"/>
+                <a:ea typeface="Calibri" pitchFamily="34" charset="-122"/>
+                <a:cs typeface="Calibri" pitchFamily="34" charset="-120"/>
+              </a:rPr>
+              <a:t>Why wing morphology matters?</a:t>
+            </a:r>
+            <a:endParaRPr lang="en-US" sz="1200" dirty="0"/>
+          </a:p>
+          <a:p>
+            <a:pPr marL="0" indent="0" algn="l">
+              <a:buNone/>
+            </a:pPr>
+            <a:r>
+              <a:rPr lang="en-US" sz="1100" dirty="0">
+                <a:solidFill>
+                  <a:srgbClr val="6B7280"/>
+                </a:solidFill>
+                <a:latin typeface="Calibri" pitchFamily="34" charset="0"/>
+                <a:ea typeface="Calibri" pitchFamily="34" charset="-122"/>
+                <a:cs typeface="Calibri" pitchFamily="34" charset="-120"/>
+              </a:rPr>
+              <a:t>Wing geometry directly governs resonance frequency, pitch amplitude, lift generation, and power consumption.</a:t>
+            </a:r>
+            <a:endParaRPr lang="en-US" sz="1100" dirty="0"/>
+          </a:p>
+        </p:txBody>
+      </p:sp>
+      <p:sp>
+        <p:nvSpPr>
+          <p:cNvPr id="7" name="Text 5"/>
+          <p:cNvSpPr/>
+          <p:nvPr/>
+        </p:nvSpPr>
+        <p:spPr>
+          <a:xfrm>
+            <a:off x="5577840" y="1353312"/>
+            <a:ext cx="1600200" cy="457200"/>
+          </a:xfrm>
+          <a:prstGeom prst="rect">
+            <a:avLst/>
+          </a:prstGeom>
+          <a:noFill/>
+          <a:ln/>
+        </p:spPr>
+        <p:txBody>
+          <a:bodyPr wrap="square" rtlCol="0" anchor="ctr"/>
+          <a:lstStyle/>
+          <a:p>
+            <a:pPr marL="0" indent="0" algn="ctr">
+              <a:buNone/>
+            </a:pPr>
+            <a:endParaRPr lang="en-US" sz="1800" dirty="0"/>
+          </a:p>
+        </p:txBody>
+      </p:sp>
+      <p:sp>
+        <p:nvSpPr>
+          <p:cNvPr id="8" name="Text 6"/>
+          <p:cNvSpPr/>
+          <p:nvPr/>
+        </p:nvSpPr>
+        <p:spPr>
+          <a:xfrm>
+            <a:off x="5577840" y="1810512"/>
+            <a:ext cx="1600200" cy="365760"/>
+          </a:xfrm>
+          <a:prstGeom prst="rect">
+            <a:avLst/>
+          </a:prstGeom>
+          <a:noFill/>
+          <a:ln/>
+        </p:spPr>
+        <p:txBody>
+          <a:bodyPr wrap="square" rtlCol="0" anchor="ctr"/>
+          <a:lstStyle/>
+          <a:p>
+            <a:pPr marL="0" indent="0" algn="ctr">
+              <a:buNone/>
+            </a:pPr>
+            <a:endParaRPr lang="en-US" sz="900" dirty="0"/>
+          </a:p>
+        </p:txBody>
+      </p:sp>
+      <p:sp>
+        <p:nvSpPr>
+          <p:cNvPr id="10" name="Text 8"/>
+          <p:cNvSpPr/>
+          <p:nvPr/>
+        </p:nvSpPr>
+        <p:spPr>
+          <a:xfrm>
+            <a:off x="7360920" y="1353312"/>
+            <a:ext cx="1600200" cy="457200"/>
+          </a:xfrm>
+          <a:prstGeom prst="rect">
+            <a:avLst/>
+          </a:prstGeom>
+          <a:noFill/>
+          <a:ln/>
+        </p:spPr>
+        <p:txBody>
+          <a:bodyPr wrap="square" rtlCol="0" anchor="ctr"/>
+          <a:lstStyle/>
+          <a:p>
+            <a:pPr marL="0" indent="0" algn="ctr">
+              <a:buNone/>
+            </a:pPr>
+            <a:endParaRPr lang="en-US" sz="1800" dirty="0"/>
+          </a:p>
+        </p:txBody>
+      </p:sp>
+      <p:sp>
+        <p:nvSpPr>
+          <p:cNvPr id="11" name="Text 9"/>
+          <p:cNvSpPr/>
+          <p:nvPr/>
+        </p:nvSpPr>
+        <p:spPr>
+          <a:xfrm>
+            <a:off x="7360920" y="1810512"/>
+            <a:ext cx="1600200" cy="365760"/>
+          </a:xfrm>
+          <a:prstGeom prst="rect">
+            <a:avLst/>
+          </a:prstGeom>
+          <a:noFill/>
+          <a:ln/>
+        </p:spPr>
+        <p:txBody>
+          <a:bodyPr wrap="square" rtlCol="0" anchor="ctr"/>
+          <a:lstStyle/>
+          <a:p>
+            <a:pPr marL="0" indent="0" algn="ctr">
+              <a:buNone/>
+            </a:pPr>
+            <a:endParaRPr lang="en-US" sz="900" dirty="0"/>
+          </a:p>
+        </p:txBody>
+      </p:sp>
+      <p:sp>
+        <p:nvSpPr>
+          <p:cNvPr id="13" name="Text 11"/>
+          <p:cNvSpPr/>
+          <p:nvPr/>
+        </p:nvSpPr>
+        <p:spPr>
+          <a:xfrm>
+            <a:off x="5577840" y="2770632"/>
+            <a:ext cx="1600200" cy="457200"/>
+          </a:xfrm>
+          <a:prstGeom prst="rect">
+            <a:avLst/>
+          </a:prstGeom>
+          <a:noFill/>
+          <a:ln/>
+        </p:spPr>
+        <p:txBody>
+          <a:bodyPr wrap="square" rtlCol="0" anchor="ctr"/>
+          <a:lstStyle/>
+          <a:p>
+            <a:pPr marL="0" indent="0" algn="ctr">
+              <a:buNone/>
+            </a:pPr>
+            <a:endParaRPr lang="en-US" sz="1800" dirty="0"/>
+          </a:p>
+        </p:txBody>
+      </p:sp>
+      <p:sp>
+        <p:nvSpPr>
+          <p:cNvPr id="14" name="Text 12"/>
+          <p:cNvSpPr/>
+          <p:nvPr/>
+        </p:nvSpPr>
+        <p:spPr>
+          <a:xfrm>
+            <a:off x="5577840" y="3227832"/>
+            <a:ext cx="1600200" cy="365760"/>
+          </a:xfrm>
+          <a:prstGeom prst="rect">
+            <a:avLst/>
+          </a:prstGeom>
+          <a:noFill/>
+          <a:ln/>
+        </p:spPr>
+        <p:txBody>
+          <a:bodyPr wrap="square" rtlCol="0" anchor="ctr"/>
+          <a:lstStyle/>
+          <a:p>
+            <a:pPr marL="0" indent="0" algn="ctr">
+              <a:buNone/>
+            </a:pPr>
+            <a:endParaRPr lang="en-US" sz="900" dirty="0"/>
+          </a:p>
+        </p:txBody>
+      </p:sp>
+      <p:sp>
+        <p:nvSpPr>
+          <p:cNvPr id="16" name="Text 14"/>
+          <p:cNvSpPr/>
+          <p:nvPr/>
+        </p:nvSpPr>
+        <p:spPr>
+          <a:xfrm>
+            <a:off x="7360920" y="2770632"/>
+            <a:ext cx="1600200" cy="457200"/>
+          </a:xfrm>
+          <a:prstGeom prst="rect">
+            <a:avLst/>
+          </a:prstGeom>
+          <a:noFill/>
+          <a:ln/>
+        </p:spPr>
+        <p:txBody>
+          <a:bodyPr wrap="square" rtlCol="0" anchor="ctr"/>
+          <a:lstStyle/>
+          <a:p>
+            <a:pPr marL="0" indent="0" algn="ctr">
+              <a:buNone/>
+            </a:pPr>
+            <a:endParaRPr lang="en-US" sz="1800" dirty="0"/>
+          </a:p>
+        </p:txBody>
+      </p:sp>
+      <p:sp>
+        <p:nvSpPr>
+          <p:cNvPr id="17" name="Text 15"/>
+          <p:cNvSpPr/>
+          <p:nvPr/>
+        </p:nvSpPr>
+        <p:spPr>
+          <a:xfrm>
+            <a:off x="7360920" y="3227832"/>
+            <a:ext cx="1600200" cy="365760"/>
+          </a:xfrm>
+          <a:prstGeom prst="rect">
+            <a:avLst/>
+          </a:prstGeom>
+          <a:noFill/>
+          <a:ln/>
+        </p:spPr>
+        <p:txBody>
+          <a:bodyPr wrap="square" rtlCol="0" anchor="ctr"/>
+          <a:lstStyle/>
+          <a:p>
+            <a:pPr marL="0" indent="0" algn="ctr">
+              <a:buNone/>
+            </a:pPr>
+            <a:endParaRPr lang="en-US" sz="900" dirty="0"/>
+          </a:p>
+        </p:txBody>
+      </p:sp>
+      <p:sp>
+        <p:nvSpPr>
+          <p:cNvPr id="19" name="Text 17"/>
+          <p:cNvSpPr/>
+          <p:nvPr/>
+        </p:nvSpPr>
+        <p:spPr>
+          <a:xfrm>
+            <a:off x="365760" y="4480560"/>
+            <a:ext cx="8412480" cy="502920"/>
+          </a:xfrm>
+          <a:prstGeom prst="rect">
+            <a:avLst/>
+          </a:prstGeom>
+          <a:noFill/>
+          <a:ln/>
+        </p:spPr>
+        <p:txBody>
+          <a:bodyPr wrap="square" rtlCol="0" anchor="ctr"/>
+          <a:lstStyle/>
+          <a:p>
+            <a:pPr marL="0" indent="0" algn="ctr">
+              <a:buNone/>
+            </a:pPr>
+            <a:r>
+              <a:rPr lang="en-US" sz="1050" b="1" dirty="0">
+                <a:solidFill>
+                  <a:srgbClr val="FFFFFF"/>
+                </a:solidFill>
+                <a:latin typeface="Calibri" pitchFamily="34" charset="0"/>
+                <a:ea typeface="Calibri" pitchFamily="34" charset="-122"/>
+                <a:cs typeface="Calibri" pitchFamily="34" charset="-120"/>
+              </a:rPr>
+              <a:t>Goal of Chapter 3: Systematically quantify how 5 wing parameters affect lift, power, and resonance frequency.</a:t>
+            </a:r>
+            <a:endParaRPr lang="en-US" sz="1050" dirty="0"/>
+          </a:p>
+        </p:txBody>
+      </p:sp>
+      <p:pic>
+        <p:nvPicPr>
+          <p:cNvPr id="21" name="Picture 20">
+            <a:extLst>
+              <a:ext uri="{FF2B5EF4-FFF2-40B4-BE49-F238E27FC236}">
+                <a16:creationId xmlns:a16="http://schemas.microsoft.com/office/drawing/2014/main" id="{7311551D-0EC2-7E3E-7C9A-69164E9B2FA9}"/>
+              </a:ext>
+            </a:extLst>
+          </p:cNvPr>
+          <p:cNvPicPr>
+            <a:picLocks noChangeAspect="1"/>
+          </p:cNvPicPr>
+          <p:nvPr/>
+        </p:nvPicPr>
+        <p:blipFill>
+          <a:blip r:embed="rId3"/>
+          <a:stretch>
+            <a:fillRect/>
+          </a:stretch>
+        </p:blipFill>
+        <p:spPr>
+          <a:xfrm>
+            <a:off x="5303520" y="1227680"/>
+            <a:ext cx="3538413" cy="2512671"/>
+          </a:xfrm>
+          <a:prstGeom prst="rect">
+            <a:avLst/>
+          </a:prstGeom>
+        </p:spPr>
+      </p:pic>
+      <p:sp>
+        <p:nvSpPr>
+          <p:cNvPr id="22" name="TextBox 21">
+            <a:extLst>
+              <a:ext uri="{FF2B5EF4-FFF2-40B4-BE49-F238E27FC236}">
+                <a16:creationId xmlns:a16="http://schemas.microsoft.com/office/drawing/2014/main" id="{C10C960B-F728-A0A9-6C3A-E86B976E25E7}"/>
+              </a:ext>
+            </a:extLst>
+          </p:cNvPr>
+          <p:cNvSpPr txBox="1"/>
+          <p:nvPr/>
+        </p:nvSpPr>
+        <p:spPr>
+          <a:xfrm>
+            <a:off x="5140146" y="3825031"/>
+            <a:ext cx="3865161" cy="307777"/>
+          </a:xfrm>
+          <a:prstGeom prst="rect">
+            <a:avLst/>
+          </a:prstGeom>
+          <a:noFill/>
+        </p:spPr>
+        <p:txBody>
+          <a:bodyPr wrap="none" rtlCol="0">
+            <a:spAutoFit/>
+          </a:bodyPr>
+          <a:lstStyle/>
+          <a:p>
+            <a:r>
+              <a:rPr lang="en-IN" sz="1400" dirty="0"/>
+              <a:t>Figure 3.1: Wing driver platform and wing designs.</a:t>
+            </a:r>
+          </a:p>
+        </p:txBody>
+      </p:sp>
+      <p:sp>
+        <p:nvSpPr>
+          <p:cNvPr id="23" name="TextBox 22">
+            <a:extLst>
+              <a:ext uri="{FF2B5EF4-FFF2-40B4-BE49-F238E27FC236}">
+                <a16:creationId xmlns:a16="http://schemas.microsoft.com/office/drawing/2014/main" id="{9426D35C-CA1E-FEF2-32CA-215716C964D8}"/>
+              </a:ext>
+            </a:extLst>
+          </p:cNvPr>
+          <p:cNvSpPr txBox="1"/>
+          <p:nvPr/>
+        </p:nvSpPr>
+        <p:spPr>
+          <a:xfrm>
+            <a:off x="365760" y="2783788"/>
+            <a:ext cx="4604146" cy="615553"/>
+          </a:xfrm>
+          <a:prstGeom prst="rect">
+            <a:avLst/>
+          </a:prstGeom>
+          <a:noFill/>
+        </p:spPr>
+        <p:txBody>
+          <a:bodyPr wrap="none" rtlCol="0">
+            <a:spAutoFit/>
+          </a:bodyPr>
+          <a:lstStyle/>
+          <a:p>
+            <a:r>
+              <a:rPr lang="en-IN" sz="1200" b="1" dirty="0"/>
+              <a:t>Our Aim</a:t>
+            </a:r>
+            <a:br>
+              <a:rPr lang="en-IN" dirty="0"/>
+            </a:br>
+            <a:r>
+              <a:rPr lang="en-IN" sz="1100" dirty="0">
+                <a:solidFill>
+                  <a:schemeClr val="bg1">
+                    <a:lumMod val="50000"/>
+                  </a:schemeClr>
+                </a:solidFill>
+              </a:rPr>
+              <a:t>Improving the robot’s flapping performance and thus payload capacity.</a:t>
+            </a:r>
+          </a:p>
+          <a:p>
+            <a:r>
+              <a:rPr lang="en-IN" sz="1100" dirty="0">
+                <a:solidFill>
+                  <a:schemeClr val="bg1">
+                    <a:lumMod val="50000"/>
+                  </a:schemeClr>
+                </a:solidFill>
+              </a:rPr>
+              <a:t>We demonstrate that wing morphology has large impact on lift enhancement.</a:t>
+            </a:r>
+          </a:p>
+        </p:txBody>
+      </p:sp>
+    </p:spTree>
+  </p:cSld>
+  <p:clrMapOvr>
+    <a:masterClrMapping/>
+  </p:clrMapOvr>
+</p:sld>
+</file>
+
+<file path=ppt/slides/slide20.xml><?xml version="1.0" encoding="utf-8"?>
+<p:sld xmlns:a="http://schemas.openxmlformats.org/drawingml/2006/main" xmlns:r="http://schemas.openxmlformats.org/officeDocument/2006/relationships" xmlns:p="http://schemas.openxmlformats.org/presentationml/2006/main">
+  <p:cSld>
+    <p:spTree>
+      <p:nvGrpSpPr>
+        <p:cNvPr id="1" name=""/>
+        <p:cNvGrpSpPr/>
+        <p:nvPr/>
+      </p:nvGrpSpPr>
+      <p:grpSpPr>
+        <a:xfrm>
+          <a:off x="0" y="0"/>
+          <a:ext cx="0" cy="0"/>
+          <a:chOff x="0" y="0"/>
+          <a:chExt cx="0" cy="0"/>
+        </a:xfrm>
+      </p:grpSpPr>
+      <p:pic>
+        <p:nvPicPr>
+          <p:cNvPr id="3" name="Picture 2">
+            <a:extLst>
+              <a:ext uri="{FF2B5EF4-FFF2-40B4-BE49-F238E27FC236}">
+                <a16:creationId xmlns:a16="http://schemas.microsoft.com/office/drawing/2014/main" id="{97ECC590-050D-3AED-3111-AEE6538D940E}"/>
+              </a:ext>
+            </a:extLst>
+          </p:cNvPr>
+          <p:cNvPicPr>
+            <a:picLocks noChangeAspect="1"/>
+          </p:cNvPicPr>
+          <p:nvPr/>
+        </p:nvPicPr>
+        <p:blipFill>
+          <a:blip r:embed="rId2"/>
+          <a:stretch>
+            <a:fillRect/>
+          </a:stretch>
+        </p:blipFill>
+        <p:spPr>
+          <a:xfrm>
+            <a:off x="0" y="711104"/>
+            <a:ext cx="9144000" cy="4432396"/>
+          </a:xfrm>
+          <a:prstGeom prst="rect">
+            <a:avLst/>
+          </a:prstGeom>
+        </p:spPr>
+      </p:pic>
+      <p:sp>
+        <p:nvSpPr>
+          <p:cNvPr id="4" name="TextBox 3">
+            <a:extLst>
+              <a:ext uri="{FF2B5EF4-FFF2-40B4-BE49-F238E27FC236}">
+                <a16:creationId xmlns:a16="http://schemas.microsoft.com/office/drawing/2014/main" id="{A2711B1D-FACF-62A4-EB7E-CC075C170C45}"/>
+              </a:ext>
+            </a:extLst>
+          </p:cNvPr>
+          <p:cNvSpPr txBox="1"/>
+          <p:nvPr/>
+        </p:nvSpPr>
+        <p:spPr>
+          <a:xfrm>
+            <a:off x="4034320" y="121920"/>
+            <a:ext cx="1075359" cy="461665"/>
+          </a:xfrm>
+          <a:prstGeom prst="rect">
+            <a:avLst/>
+          </a:prstGeom>
+          <a:noFill/>
+        </p:spPr>
+        <p:txBody>
+          <a:bodyPr wrap="none" rtlCol="0">
+            <a:spAutoFit/>
+          </a:bodyPr>
+          <a:lstStyle/>
+          <a:p>
+            <a:r>
+              <a:rPr lang="en-IN" sz="2400" dirty="0"/>
+              <a:t>Results</a:t>
+            </a:r>
+          </a:p>
+        </p:txBody>
+      </p:sp>
+    </p:spTree>
+    <p:extLst>
+      <p:ext uri="{BB962C8B-B14F-4D97-AF65-F5344CB8AC3E}">
+        <p14:creationId xmlns:p14="http://schemas.microsoft.com/office/powerpoint/2010/main" val="1360041968"/>
+      </p:ext>
+    </p:extLst>
+  </p:cSld>
+  <p:clrMapOvr>
+    <a:masterClrMapping/>
+  </p:clrMapOvr>
+</p:sld>
+</file>
+
+<file path=ppt/slides/slide21.xml><?xml version="1.0" encoding="utf-8"?>
+<p:sld xmlns:a="http://schemas.openxmlformats.org/drawingml/2006/main" xmlns:r="http://schemas.openxmlformats.org/officeDocument/2006/relationships" xmlns:p="http://schemas.openxmlformats.org/presentationml/2006/main">
+  <p:cSld>
+    <p:spTree>
+      <p:nvGrpSpPr>
+        <p:cNvPr id="1" name=""/>
+        <p:cNvGrpSpPr/>
+        <p:nvPr/>
+      </p:nvGrpSpPr>
+      <p:grpSpPr>
+        <a:xfrm>
+          <a:off x="0" y="0"/>
+          <a:ext cx="0" cy="0"/>
+          <a:chOff x="0" y="0"/>
+          <a:chExt cx="0" cy="0"/>
+        </a:xfrm>
+      </p:grpSpPr>
       <p:sp>
         <p:nvSpPr>
           <p:cNvPr id="2" name="TextBox 1">
@@ -5508,7 +6771,7 @@
 </p:sld>
 </file>
 
-<file path=ppt/slides/slide16.xml><?xml version="1.0" encoding="utf-8"?>
+<file path=ppt/slides/slide22.xml><?xml version="1.0" encoding="utf-8"?>
 <p:sld xmlns:a="http://schemas.openxmlformats.org/drawingml/2006/main" xmlns:r="http://schemas.openxmlformats.org/officeDocument/2006/relationships" xmlns:p="http://schemas.openxmlformats.org/presentationml/2006/main">
   <p:cSld>
     <p:spTree>
@@ -6036,8 +7299,8 @@
           </p:sp>
         </mc:Fallback>
       </mc:AlternateContent>
-      <mc:AlternateContent xmlns:mc="http://schemas.openxmlformats.org/markup-compatibility/2006">
-        <mc:Choice xmlns:a14="http://schemas.microsoft.com/office/drawing/2010/main" Requires="a14">
+      <mc:AlternateContent xmlns:mc="http://schemas.openxmlformats.org/markup-compatibility/2006" xmlns:a14="http://schemas.microsoft.com/office/drawing/2010/main">
+        <mc:Choice Requires="a14">
           <p:sp>
             <p:nvSpPr>
               <p:cNvPr id="13" name="TextBox 12">
@@ -6284,7 +7547,7 @@
             </p:txBody>
           </p:sp>
         </mc:Choice>
-        <mc:Fallback>
+        <mc:Fallback xmlns="">
           <p:sp>
             <p:nvSpPr>
               <p:cNvPr id="13" name="TextBox 12">
@@ -6329,8 +7592,8 @@
           </p:sp>
         </mc:Fallback>
       </mc:AlternateContent>
-      <mc:AlternateContent xmlns:mc="http://schemas.openxmlformats.org/markup-compatibility/2006">
-        <mc:Choice xmlns:a14="http://schemas.microsoft.com/office/drawing/2010/main" Requires="a14">
+      <mc:AlternateContent xmlns:mc="http://schemas.openxmlformats.org/markup-compatibility/2006" xmlns:a14="http://schemas.microsoft.com/office/drawing/2010/main">
+        <mc:Choice Requires="a14">
           <p:sp>
             <p:nvSpPr>
               <p:cNvPr id="14" name="TextBox 13">
@@ -6405,7 +7668,7 @@
             </p:txBody>
           </p:sp>
         </mc:Choice>
-        <mc:Fallback>
+        <mc:Fallback xmlns="">
           <p:sp>
             <p:nvSpPr>
               <p:cNvPr id="14" name="TextBox 13">
@@ -6450,8 +7713,8 @@
           </p:sp>
         </mc:Fallback>
       </mc:AlternateContent>
-      <mc:AlternateContent xmlns:mc="http://schemas.openxmlformats.org/markup-compatibility/2006">
-        <mc:Choice xmlns:a14="http://schemas.microsoft.com/office/drawing/2010/main" Requires="a14">
+      <mc:AlternateContent xmlns:mc="http://schemas.openxmlformats.org/markup-compatibility/2006" xmlns:a14="http://schemas.microsoft.com/office/drawing/2010/main">
+        <mc:Choice Requires="a14">
           <p:sp>
             <p:nvSpPr>
               <p:cNvPr id="4" name="TextBox 3">
@@ -6480,6 +7743,7 @@
               </a:bodyPr>
               <a:lstStyle/>
               <a:p>
+                <a:pPr/>
                 <a14:m>
                   <m:oMathPara xmlns:m="http://schemas.openxmlformats.org/officeDocument/2006/math">
                     <m:oMathParaPr>
@@ -6489,7 +7753,7 @@
                       <m:sSub>
                         <m:sSubPr>
                           <m:ctrlPr>
-                            <a:rPr lang="en-IN" smtClean="0">
+                            <a:rPr lang="en-IN" i="1" smtClean="0">
                               <a:latin typeface="Cambria Math" panose="02040503050406030204" pitchFamily="18" charset="0"/>
                             </a:rPr>
                           </m:ctrlPr>
@@ -6525,7 +7789,7 @@
             </p:txBody>
           </p:sp>
         </mc:Choice>
-        <mc:Fallback>
+        <mc:Fallback xmlns="">
           <p:sp>
             <p:nvSpPr>
               <p:cNvPr id="4" name="TextBox 3">
@@ -6570,8 +7834,8 @@
           </p:sp>
         </mc:Fallback>
       </mc:AlternateContent>
-      <mc:AlternateContent xmlns:mc="http://schemas.openxmlformats.org/markup-compatibility/2006">
-        <mc:Choice xmlns:a14="http://schemas.microsoft.com/office/drawing/2010/main" Requires="a14">
+      <mc:AlternateContent xmlns:mc="http://schemas.openxmlformats.org/markup-compatibility/2006" xmlns:a14="http://schemas.microsoft.com/office/drawing/2010/main">
+        <mc:Choice Requires="a14">
           <p:sp>
             <p:nvSpPr>
               <p:cNvPr id="5" name="TextBox 4">
@@ -6600,6 +7864,7 @@
               </a:bodyPr>
               <a:lstStyle/>
               <a:p>
+                <a:pPr/>
                 <a14:m>
                   <m:oMathPara xmlns:m="http://schemas.openxmlformats.org/officeDocument/2006/math">
                     <m:oMathParaPr>
@@ -6609,7 +7874,7 @@
                       <m:sSub>
                         <m:sSubPr>
                           <m:ctrlPr>
-                            <a:rPr lang="en-IN" smtClean="0">
+                            <a:rPr lang="en-IN" i="1" smtClean="0">
                               <a:latin typeface="Cambria Math" panose="02040503050406030204" pitchFamily="18" charset="0"/>
                             </a:rPr>
                           </m:ctrlPr>
@@ -6651,7 +7916,7 @@
             </p:txBody>
           </p:sp>
         </mc:Choice>
-        <mc:Fallback>
+        <mc:Fallback xmlns="">
           <p:sp>
             <p:nvSpPr>
               <p:cNvPr id="5" name="TextBox 4">
@@ -6696,8 +7961,8 @@
           </p:sp>
         </mc:Fallback>
       </mc:AlternateContent>
-      <mc:AlternateContent xmlns:mc="http://schemas.openxmlformats.org/markup-compatibility/2006">
-        <mc:Choice xmlns:a14="http://schemas.microsoft.com/office/drawing/2010/main" Requires="a14">
+      <mc:AlternateContent xmlns:mc="http://schemas.openxmlformats.org/markup-compatibility/2006" xmlns:a14="http://schemas.microsoft.com/office/drawing/2010/main">
+        <mc:Choice Requires="a14">
           <p:sp>
             <p:nvSpPr>
               <p:cNvPr id="6" name="TextBox 5">
@@ -6726,6 +7991,7 @@
               </a:bodyPr>
               <a:lstStyle/>
               <a:p>
+                <a:pPr/>
                 <a14:m>
                   <m:oMathPara xmlns:m="http://schemas.openxmlformats.org/officeDocument/2006/math">
                     <m:oMathParaPr>
@@ -6735,7 +8001,7 @@
                       <m:sSub>
                         <m:sSubPr>
                           <m:ctrlPr>
-                            <a:rPr lang="en-IN" smtClean="0">
+                            <a:rPr lang="en-IN" i="1" smtClean="0">
                               <a:latin typeface="Cambria Math" panose="02040503050406030204" pitchFamily="18" charset="0"/>
                             </a:rPr>
                           </m:ctrlPr>
@@ -6789,7 +8055,7 @@
             </p:txBody>
           </p:sp>
         </mc:Choice>
-        <mc:Fallback>
+        <mc:Fallback xmlns="">
           <p:sp>
             <p:nvSpPr>
               <p:cNvPr id="6" name="TextBox 5">
@@ -6834,8 +8100,8 @@
           </p:sp>
         </mc:Fallback>
       </mc:AlternateContent>
-      <mc:AlternateContent xmlns:mc="http://schemas.openxmlformats.org/markup-compatibility/2006">
-        <mc:Choice xmlns:a14="http://schemas.microsoft.com/office/drawing/2010/main" Requires="a14">
+      <mc:AlternateContent xmlns:mc="http://schemas.openxmlformats.org/markup-compatibility/2006" xmlns:a14="http://schemas.microsoft.com/office/drawing/2010/main">
+        <mc:Choice Requires="a14">
           <p:sp>
             <p:nvSpPr>
               <p:cNvPr id="8" name="TextBox 7">
@@ -6864,6 +8130,7 @@
               </a:bodyPr>
               <a:lstStyle/>
               <a:p>
+                <a:pPr/>
                 <a14:m>
                   <m:oMathPara xmlns:m="http://schemas.openxmlformats.org/officeDocument/2006/math">
                     <m:oMathParaPr>
@@ -6897,7 +8164,7 @@
                       <m:sSub>
                         <m:sSubPr>
                           <m:ctrlPr>
-                            <a:rPr lang="en-IN" smtClean="0">
+                            <a:rPr lang="en-IN" i="1" smtClean="0">
                               <a:latin typeface="Cambria Math" panose="02040503050406030204" pitchFamily="18" charset="0"/>
                             </a:rPr>
                           </m:ctrlPr>
@@ -6939,7 +8206,7 @@
             </p:txBody>
           </p:sp>
         </mc:Choice>
-        <mc:Fallback>
+        <mc:Fallback xmlns="">
           <p:sp>
             <p:nvSpPr>
               <p:cNvPr id="8" name="TextBox 7">
@@ -6997,7 +8264,7 @@
 </p:sld>
 </file>
 
-<file path=ppt/slides/slide17.xml><?xml version="1.0" encoding="utf-8"?>
+<file path=ppt/slides/slide23.xml><?xml version="1.0" encoding="utf-8"?>
 <p:sld xmlns:a="http://schemas.openxmlformats.org/drawingml/2006/main" xmlns:r="http://schemas.openxmlformats.org/officeDocument/2006/relationships" xmlns:p="http://schemas.openxmlformats.org/presentationml/2006/main">
   <p:cSld>
     <p:spTree>
@@ -7092,7 +8359,7 @@
 </p:sld>
 </file>
 
-<file path=ppt/slides/slide18.xml><?xml version="1.0" encoding="utf-8"?>
+<file path=ppt/slides/slide24.xml><?xml version="1.0" encoding="utf-8"?>
 <p:sld xmlns:a="http://schemas.openxmlformats.org/drawingml/2006/main" xmlns:r="http://schemas.openxmlformats.org/officeDocument/2006/relationships" xmlns:p="http://schemas.openxmlformats.org/presentationml/2006/main">
   <p:cSld>
     <p:spTree>
@@ -7114,6 +8381,516 @@
           <p:cNvPr id="2" name="TextBox 1">
             <a:extLst>
               <a:ext uri="{FF2B5EF4-FFF2-40B4-BE49-F238E27FC236}">
+                <a16:creationId xmlns:a16="http://schemas.microsoft.com/office/drawing/2014/main" id="{3B4B09AE-140C-400A-4CA8-F4557E87183A}"/>
+              </a:ext>
+            </a:extLst>
+          </p:cNvPr>
+          <p:cNvSpPr txBox="1"/>
+          <p:nvPr/>
+        </p:nvSpPr>
+        <p:spPr>
+          <a:xfrm>
+            <a:off x="719823" y="84654"/>
+            <a:ext cx="7704353" cy="369332"/>
+          </a:xfrm>
+          <a:prstGeom prst="rect">
+            <a:avLst/>
+          </a:prstGeom>
+          <a:noFill/>
+        </p:spPr>
+        <p:txBody>
+          <a:bodyPr wrap="none" rtlCol="0">
+            <a:spAutoFit/>
+          </a:bodyPr>
+          <a:lstStyle/>
+          <a:p>
+            <a:r>
+              <a:rPr lang="en-IN" dirty="0"/>
+              <a:t>Analysis by varying spar/stiffener ratio in vertically straight stiffener wing profile</a:t>
+            </a:r>
+          </a:p>
+        </p:txBody>
+      </p:sp>
+      <p:sp>
+        <p:nvSpPr>
+          <p:cNvPr id="3" name="TextBox 2">
+            <a:extLst>
+              <a:ext uri="{FF2B5EF4-FFF2-40B4-BE49-F238E27FC236}">
+                <a16:creationId xmlns:a16="http://schemas.microsoft.com/office/drawing/2014/main" id="{44C4DA09-5A3A-9A23-3DAD-4EB92FA608F1}"/>
+              </a:ext>
+            </a:extLst>
+          </p:cNvPr>
+          <p:cNvSpPr txBox="1"/>
+          <p:nvPr/>
+        </p:nvSpPr>
+        <p:spPr>
+          <a:xfrm>
+            <a:off x="3383019" y="375166"/>
+            <a:ext cx="2377959" cy="369332"/>
+          </a:xfrm>
+          <a:prstGeom prst="rect">
+            <a:avLst/>
+          </a:prstGeom>
+          <a:noFill/>
+        </p:spPr>
+        <p:txBody>
+          <a:bodyPr wrap="none" rtlCol="0">
+            <a:spAutoFit/>
+          </a:bodyPr>
+          <a:lstStyle/>
+          <a:p>
+            <a:r>
+              <a:rPr lang="en-IN" dirty="0"/>
+              <a:t>spar/stiff = 0.5/2 = 0.25</a:t>
+            </a:r>
+          </a:p>
+        </p:txBody>
+      </p:sp>
+      <p:pic>
+        <p:nvPicPr>
+          <p:cNvPr id="7" name="Picture 6">
+            <a:extLst>
+              <a:ext uri="{FF2B5EF4-FFF2-40B4-BE49-F238E27FC236}">
+                <a16:creationId xmlns:a16="http://schemas.microsoft.com/office/drawing/2014/main" id="{AF1E650F-DA6A-933B-92A6-EC2E5B0BEB1E}"/>
+              </a:ext>
+            </a:extLst>
+          </p:cNvPr>
+          <p:cNvPicPr>
+            <a:picLocks noChangeAspect="1"/>
+          </p:cNvPicPr>
+          <p:nvPr/>
+        </p:nvPicPr>
+        <p:blipFill>
+          <a:blip r:embed="rId2"/>
+          <a:stretch>
+            <a:fillRect/>
+          </a:stretch>
+        </p:blipFill>
+        <p:spPr>
+          <a:xfrm>
+            <a:off x="0" y="771525"/>
+            <a:ext cx="9144000" cy="4371975"/>
+          </a:xfrm>
+          <a:prstGeom prst="rect">
+            <a:avLst/>
+          </a:prstGeom>
+        </p:spPr>
+      </p:pic>
+    </p:spTree>
+    <p:extLst>
+      <p:ext uri="{BB962C8B-B14F-4D97-AF65-F5344CB8AC3E}">
+        <p14:creationId xmlns:p14="http://schemas.microsoft.com/office/powerpoint/2010/main" val="856736580"/>
+      </p:ext>
+    </p:extLst>
+  </p:cSld>
+  <p:clrMapOvr>
+    <a:masterClrMapping/>
+  </p:clrMapOvr>
+</p:sld>
+</file>
+
+<file path=ppt/slides/slide25.xml><?xml version="1.0" encoding="utf-8"?>
+<p:sld xmlns:a="http://schemas.openxmlformats.org/drawingml/2006/main" xmlns:r="http://schemas.openxmlformats.org/officeDocument/2006/relationships" xmlns:p="http://schemas.openxmlformats.org/presentationml/2006/main">
+  <p:cSld>
+    <p:spTree>
+      <p:nvGrpSpPr>
+        <p:cNvPr id="1" name=""/>
+        <p:cNvGrpSpPr/>
+        <p:nvPr/>
+      </p:nvGrpSpPr>
+      <p:grpSpPr>
+        <a:xfrm>
+          <a:off x="0" y="0"/>
+          <a:ext cx="0" cy="0"/>
+          <a:chOff x="0" y="0"/>
+          <a:chExt cx="0" cy="0"/>
+        </a:xfrm>
+      </p:grpSpPr>
+      <p:sp>
+        <p:nvSpPr>
+          <p:cNvPr id="2" name="TextBox 1">
+            <a:extLst>
+              <a:ext uri="{FF2B5EF4-FFF2-40B4-BE49-F238E27FC236}">
+                <a16:creationId xmlns:a16="http://schemas.microsoft.com/office/drawing/2014/main" id="{0A870844-DE1A-EA0B-FEFF-4BA0FBA319FB}"/>
+              </a:ext>
+            </a:extLst>
+          </p:cNvPr>
+          <p:cNvSpPr txBox="1"/>
+          <p:nvPr/>
+        </p:nvSpPr>
+        <p:spPr>
+          <a:xfrm>
+            <a:off x="3593527" y="152400"/>
+            <a:ext cx="1956946" cy="369332"/>
+          </a:xfrm>
+          <a:prstGeom prst="rect">
+            <a:avLst/>
+          </a:prstGeom>
+          <a:noFill/>
+        </p:spPr>
+        <p:txBody>
+          <a:bodyPr wrap="none" rtlCol="0">
+            <a:spAutoFit/>
+          </a:bodyPr>
+          <a:lstStyle/>
+          <a:p>
+            <a:r>
+              <a:rPr lang="en-IN" dirty="0"/>
+              <a:t>Spar/Stiff = ½ = 0.5</a:t>
+            </a:r>
+          </a:p>
+        </p:txBody>
+      </p:sp>
+      <p:pic>
+        <p:nvPicPr>
+          <p:cNvPr id="4" name="Picture 3">
+            <a:extLst>
+              <a:ext uri="{FF2B5EF4-FFF2-40B4-BE49-F238E27FC236}">
+                <a16:creationId xmlns:a16="http://schemas.microsoft.com/office/drawing/2014/main" id="{DC0DA530-0864-D80F-A734-F6381710B3F1}"/>
+              </a:ext>
+            </a:extLst>
+          </p:cNvPr>
+          <p:cNvPicPr>
+            <a:picLocks noChangeAspect="1"/>
+          </p:cNvPicPr>
+          <p:nvPr/>
+        </p:nvPicPr>
+        <p:blipFill>
+          <a:blip r:embed="rId2"/>
+          <a:stretch>
+            <a:fillRect/>
+          </a:stretch>
+        </p:blipFill>
+        <p:spPr>
+          <a:xfrm>
+            <a:off x="0" y="771525"/>
+            <a:ext cx="9144000" cy="4371975"/>
+          </a:xfrm>
+          <a:prstGeom prst="rect">
+            <a:avLst/>
+          </a:prstGeom>
+        </p:spPr>
+      </p:pic>
+    </p:spTree>
+    <p:extLst>
+      <p:ext uri="{BB962C8B-B14F-4D97-AF65-F5344CB8AC3E}">
+        <p14:creationId xmlns:p14="http://schemas.microsoft.com/office/powerpoint/2010/main" val="3248999365"/>
+      </p:ext>
+    </p:extLst>
+  </p:cSld>
+  <p:clrMapOvr>
+    <a:masterClrMapping/>
+  </p:clrMapOvr>
+</p:sld>
+</file>
+
+<file path=ppt/slides/slide26.xml><?xml version="1.0" encoding="utf-8"?>
+<p:sld xmlns:a="http://schemas.openxmlformats.org/drawingml/2006/main" xmlns:r="http://schemas.openxmlformats.org/officeDocument/2006/relationships" xmlns:p="http://schemas.openxmlformats.org/presentationml/2006/main">
+  <p:cSld>
+    <p:spTree>
+      <p:nvGrpSpPr>
+        <p:cNvPr id="1" name=""/>
+        <p:cNvGrpSpPr/>
+        <p:nvPr/>
+      </p:nvGrpSpPr>
+      <p:grpSpPr>
+        <a:xfrm>
+          <a:off x="0" y="0"/>
+          <a:ext cx="0" cy="0"/>
+          <a:chOff x="0" y="0"/>
+          <a:chExt cx="0" cy="0"/>
+        </a:xfrm>
+      </p:grpSpPr>
+      <p:sp>
+        <p:nvSpPr>
+          <p:cNvPr id="2" name="TextBox 1">
+            <a:extLst>
+              <a:ext uri="{FF2B5EF4-FFF2-40B4-BE49-F238E27FC236}">
+                <a16:creationId xmlns:a16="http://schemas.microsoft.com/office/drawing/2014/main" id="{58DA07AB-64E8-05CF-AB11-511571329008}"/>
+              </a:ext>
+            </a:extLst>
+          </p:cNvPr>
+          <p:cNvSpPr txBox="1"/>
+          <p:nvPr/>
+        </p:nvSpPr>
+        <p:spPr>
+          <a:xfrm>
+            <a:off x="3596733" y="213360"/>
+            <a:ext cx="1950534" cy="369332"/>
+          </a:xfrm>
+          <a:prstGeom prst="rect">
+            <a:avLst/>
+          </a:prstGeom>
+          <a:noFill/>
+        </p:spPr>
+        <p:txBody>
+          <a:bodyPr wrap="none" rtlCol="0">
+            <a:spAutoFit/>
+          </a:bodyPr>
+          <a:lstStyle/>
+          <a:p>
+            <a:r>
+              <a:rPr lang="en-IN" dirty="0"/>
+              <a:t>Spar/Stiff = 1/1 = 1</a:t>
+            </a:r>
+          </a:p>
+        </p:txBody>
+      </p:sp>
+      <p:pic>
+        <p:nvPicPr>
+          <p:cNvPr id="4" name="Picture 3">
+            <a:extLst>
+              <a:ext uri="{FF2B5EF4-FFF2-40B4-BE49-F238E27FC236}">
+                <a16:creationId xmlns:a16="http://schemas.microsoft.com/office/drawing/2014/main" id="{CBFBC2CB-801A-5C42-6F79-4ABF518F7B0C}"/>
+              </a:ext>
+            </a:extLst>
+          </p:cNvPr>
+          <p:cNvPicPr>
+            <a:picLocks noChangeAspect="1"/>
+          </p:cNvPicPr>
+          <p:nvPr/>
+        </p:nvPicPr>
+        <p:blipFill>
+          <a:blip r:embed="rId2"/>
+          <a:stretch>
+            <a:fillRect/>
+          </a:stretch>
+        </p:blipFill>
+        <p:spPr>
+          <a:xfrm>
+            <a:off x="0" y="771525"/>
+            <a:ext cx="9144000" cy="4371975"/>
+          </a:xfrm>
+          <a:prstGeom prst="rect">
+            <a:avLst/>
+          </a:prstGeom>
+        </p:spPr>
+      </p:pic>
+    </p:spTree>
+    <p:extLst>
+      <p:ext uri="{BB962C8B-B14F-4D97-AF65-F5344CB8AC3E}">
+        <p14:creationId xmlns:p14="http://schemas.microsoft.com/office/powerpoint/2010/main" val="1976273546"/>
+      </p:ext>
+    </p:extLst>
+  </p:cSld>
+  <p:clrMapOvr>
+    <a:masterClrMapping/>
+  </p:clrMapOvr>
+</p:sld>
+</file>
+
+<file path=ppt/slides/slide27.xml><?xml version="1.0" encoding="utf-8"?>
+<p:sld xmlns:a="http://schemas.openxmlformats.org/drawingml/2006/main" xmlns:r="http://schemas.openxmlformats.org/officeDocument/2006/relationships" xmlns:p="http://schemas.openxmlformats.org/presentationml/2006/main">
+  <p:cSld>
+    <p:spTree>
+      <p:nvGrpSpPr>
+        <p:cNvPr id="1" name=""/>
+        <p:cNvGrpSpPr/>
+        <p:nvPr/>
+      </p:nvGrpSpPr>
+      <p:grpSpPr>
+        <a:xfrm>
+          <a:off x="0" y="0"/>
+          <a:ext cx="0" cy="0"/>
+          <a:chOff x="0" y="0"/>
+          <a:chExt cx="0" cy="0"/>
+        </a:xfrm>
+      </p:grpSpPr>
+      <p:sp>
+        <p:nvSpPr>
+          <p:cNvPr id="2" name="TextBox 1">
+            <a:extLst>
+              <a:ext uri="{FF2B5EF4-FFF2-40B4-BE49-F238E27FC236}">
+                <a16:creationId xmlns:a16="http://schemas.microsoft.com/office/drawing/2014/main" id="{C12147FA-333E-645F-5652-89052CA7A50A}"/>
+              </a:ext>
+            </a:extLst>
+          </p:cNvPr>
+          <p:cNvSpPr txBox="1"/>
+          <p:nvPr/>
+        </p:nvSpPr>
+        <p:spPr>
+          <a:xfrm>
+            <a:off x="3422005" y="215146"/>
+            <a:ext cx="2299989" cy="369332"/>
+          </a:xfrm>
+          <a:prstGeom prst="rect">
+            <a:avLst/>
+          </a:prstGeom>
+          <a:noFill/>
+        </p:spPr>
+        <p:txBody>
+          <a:bodyPr wrap="none" rtlCol="0">
+            <a:spAutoFit/>
+          </a:bodyPr>
+          <a:lstStyle/>
+          <a:p>
+            <a:r>
+              <a:rPr lang="en-IN" dirty="0"/>
+              <a:t>Spar/Stiff = 1.5/1 = 1.5</a:t>
+            </a:r>
+          </a:p>
+        </p:txBody>
+      </p:sp>
+      <p:pic>
+        <p:nvPicPr>
+          <p:cNvPr id="4" name="Picture 3">
+            <a:extLst>
+              <a:ext uri="{FF2B5EF4-FFF2-40B4-BE49-F238E27FC236}">
+                <a16:creationId xmlns:a16="http://schemas.microsoft.com/office/drawing/2014/main" id="{ADE33EB0-C844-73A4-7A42-19C71AECFB75}"/>
+              </a:ext>
+            </a:extLst>
+          </p:cNvPr>
+          <p:cNvPicPr>
+            <a:picLocks noChangeAspect="1"/>
+          </p:cNvPicPr>
+          <p:nvPr/>
+        </p:nvPicPr>
+        <p:blipFill>
+          <a:blip r:embed="rId2"/>
+          <a:stretch>
+            <a:fillRect/>
+          </a:stretch>
+        </p:blipFill>
+        <p:spPr>
+          <a:xfrm>
+            <a:off x="0" y="771525"/>
+            <a:ext cx="9144000" cy="4371975"/>
+          </a:xfrm>
+          <a:prstGeom prst="rect">
+            <a:avLst/>
+          </a:prstGeom>
+        </p:spPr>
+      </p:pic>
+    </p:spTree>
+    <p:extLst>
+      <p:ext uri="{BB962C8B-B14F-4D97-AF65-F5344CB8AC3E}">
+        <p14:creationId xmlns:p14="http://schemas.microsoft.com/office/powerpoint/2010/main" val="2709299229"/>
+      </p:ext>
+    </p:extLst>
+  </p:cSld>
+  <p:clrMapOvr>
+    <a:masterClrMapping/>
+  </p:clrMapOvr>
+</p:sld>
+</file>
+
+<file path=ppt/slides/slide28.xml><?xml version="1.0" encoding="utf-8"?>
+<p:sld xmlns:a="http://schemas.openxmlformats.org/drawingml/2006/main" xmlns:r="http://schemas.openxmlformats.org/officeDocument/2006/relationships" xmlns:p="http://schemas.openxmlformats.org/presentationml/2006/main">
+  <p:cSld>
+    <p:spTree>
+      <p:nvGrpSpPr>
+        <p:cNvPr id="1" name=""/>
+        <p:cNvGrpSpPr/>
+        <p:nvPr/>
+      </p:nvGrpSpPr>
+      <p:grpSpPr>
+        <a:xfrm>
+          <a:off x="0" y="0"/>
+          <a:ext cx="0" cy="0"/>
+          <a:chOff x="0" y="0"/>
+          <a:chExt cx="0" cy="0"/>
+        </a:xfrm>
+      </p:grpSpPr>
+      <p:sp>
+        <p:nvSpPr>
+          <p:cNvPr id="2" name="TextBox 1">
+            <a:extLst>
+              <a:ext uri="{FF2B5EF4-FFF2-40B4-BE49-F238E27FC236}">
+                <a16:creationId xmlns:a16="http://schemas.microsoft.com/office/drawing/2014/main" id="{1FDBC40C-C231-E65E-FB12-6C06D4640460}"/>
+              </a:ext>
+            </a:extLst>
+          </p:cNvPr>
+          <p:cNvSpPr txBox="1"/>
+          <p:nvPr/>
+        </p:nvSpPr>
+        <p:spPr>
+          <a:xfrm>
+            <a:off x="3596733" y="213360"/>
+            <a:ext cx="1950534" cy="369332"/>
+          </a:xfrm>
+          <a:prstGeom prst="rect">
+            <a:avLst/>
+          </a:prstGeom>
+          <a:noFill/>
+        </p:spPr>
+        <p:txBody>
+          <a:bodyPr wrap="none" rtlCol="0">
+            <a:spAutoFit/>
+          </a:bodyPr>
+          <a:lstStyle/>
+          <a:p>
+            <a:r>
+              <a:rPr lang="en-IN" dirty="0"/>
+              <a:t>Spar/Stiff = 2/1 = 2</a:t>
+            </a:r>
+          </a:p>
+        </p:txBody>
+      </p:sp>
+      <p:pic>
+        <p:nvPicPr>
+          <p:cNvPr id="4" name="Picture 3">
+            <a:extLst>
+              <a:ext uri="{FF2B5EF4-FFF2-40B4-BE49-F238E27FC236}">
+                <a16:creationId xmlns:a16="http://schemas.microsoft.com/office/drawing/2014/main" id="{DABC8B71-2DFE-BF1A-CD7C-629874DFD620}"/>
+              </a:ext>
+            </a:extLst>
+          </p:cNvPr>
+          <p:cNvPicPr>
+            <a:picLocks noChangeAspect="1"/>
+          </p:cNvPicPr>
+          <p:nvPr/>
+        </p:nvPicPr>
+        <p:blipFill>
+          <a:blip r:embed="rId2"/>
+          <a:stretch>
+            <a:fillRect/>
+          </a:stretch>
+        </p:blipFill>
+        <p:spPr>
+          <a:xfrm>
+            <a:off x="0" y="771525"/>
+            <a:ext cx="9144000" cy="4371975"/>
+          </a:xfrm>
+          <a:prstGeom prst="rect">
+            <a:avLst/>
+          </a:prstGeom>
+        </p:spPr>
+      </p:pic>
+    </p:spTree>
+    <p:extLst>
+      <p:ext uri="{BB962C8B-B14F-4D97-AF65-F5344CB8AC3E}">
+        <p14:creationId xmlns:p14="http://schemas.microsoft.com/office/powerpoint/2010/main" val="3565455069"/>
+      </p:ext>
+    </p:extLst>
+  </p:cSld>
+  <p:clrMapOvr>
+    <a:masterClrMapping/>
+  </p:clrMapOvr>
+</p:sld>
+</file>
+
+<file path=ppt/slides/slide29.xml><?xml version="1.0" encoding="utf-8"?>
+<p:sld xmlns:a="http://schemas.openxmlformats.org/drawingml/2006/main" xmlns:r="http://schemas.openxmlformats.org/officeDocument/2006/relationships" xmlns:p="http://schemas.openxmlformats.org/presentationml/2006/main">
+  <p:cSld>
+    <p:spTree>
+      <p:nvGrpSpPr>
+        <p:cNvPr id="1" name=""/>
+        <p:cNvGrpSpPr/>
+        <p:nvPr/>
+      </p:nvGrpSpPr>
+      <p:grpSpPr>
+        <a:xfrm>
+          <a:off x="0" y="0"/>
+          <a:ext cx="0" cy="0"/>
+          <a:chOff x="0" y="0"/>
+          <a:chExt cx="0" cy="0"/>
+        </a:xfrm>
+      </p:grpSpPr>
+      <p:sp>
+        <p:nvSpPr>
+          <p:cNvPr id="2" name="TextBox 1">
+            <a:extLst>
+              <a:ext uri="{FF2B5EF4-FFF2-40B4-BE49-F238E27FC236}">
                 <a16:creationId xmlns:a16="http://schemas.microsoft.com/office/drawing/2014/main" id="{871EFC4A-D735-E347-1395-3FF14385D9D9}"/>
               </a:ext>
             </a:extLst>
@@ -7187,7 +8964,329 @@
 </p:sld>
 </file>
 
-<file path=ppt/slides/slide19.xml><?xml version="1.0" encoding="utf-8"?>
+<file path=ppt/slides/slide3.xml><?xml version="1.0" encoding="utf-8"?>
+<p:sld xmlns:a="http://schemas.openxmlformats.org/drawingml/2006/main" xmlns:r="http://schemas.openxmlformats.org/officeDocument/2006/relationships" xmlns:p="http://schemas.openxmlformats.org/presentationml/2006/main">
+  <p:cSld name="Slide 4">
+    <p:bg>
+      <p:bgPr>
+        <a:solidFill>
+          <a:srgbClr val="F7F7F7"/>
+        </a:solidFill>
+        <a:effectLst/>
+      </p:bgPr>
+    </p:bg>
+    <p:spTree>
+      <p:nvGrpSpPr>
+        <p:cNvPr id="1" name=""/>
+        <p:cNvGrpSpPr/>
+        <p:nvPr/>
+      </p:nvGrpSpPr>
+      <p:grpSpPr>
+        <a:xfrm>
+          <a:off x="0" y="0"/>
+          <a:ext cx="0" cy="0"/>
+          <a:chOff x="0" y="0"/>
+          <a:chExt cx="0" cy="0"/>
+        </a:xfrm>
+      </p:grpSpPr>
+      <p:sp>
+        <p:nvSpPr>
+          <p:cNvPr id="2" name="Text 0"/>
+          <p:cNvSpPr/>
+          <p:nvPr/>
+        </p:nvSpPr>
+        <p:spPr>
+          <a:xfrm>
+            <a:off x="365760" y="164592"/>
+            <a:ext cx="2743200" cy="201168"/>
+          </a:xfrm>
+          <a:prstGeom prst="rect">
+            <a:avLst/>
+          </a:prstGeom>
+          <a:noFill/>
+          <a:ln/>
+        </p:spPr>
+        <p:txBody>
+          <a:bodyPr wrap="square" rtlCol="0" anchor="ctr"/>
+          <a:lstStyle/>
+          <a:p>
+            <a:pPr marL="0" indent="0" algn="l">
+              <a:buNone/>
+            </a:pPr>
+            <a:r>
+              <a:rPr lang="en-US" sz="1000" b="1" kern="0" spc="300" dirty="0">
+                <a:solidFill>
+                  <a:srgbClr val="4A90D9"/>
+                </a:solidFill>
+                <a:latin typeface="Calibri" pitchFamily="34" charset="0"/>
+                <a:ea typeface="Calibri" pitchFamily="34" charset="-122"/>
+                <a:cs typeface="Calibri" pitchFamily="34" charset="-120"/>
+              </a:rPr>
+              <a:t>PARAMETER 1</a:t>
+            </a:r>
+            <a:endParaRPr lang="en-US" sz="1000" dirty="0"/>
+          </a:p>
+        </p:txBody>
+      </p:sp>
+      <p:sp>
+        <p:nvSpPr>
+          <p:cNvPr id="3" name="Text 1"/>
+          <p:cNvSpPr/>
+          <p:nvPr/>
+        </p:nvSpPr>
+        <p:spPr>
+          <a:xfrm>
+            <a:off x="365760" y="384048"/>
+            <a:ext cx="8412480" cy="548640"/>
+          </a:xfrm>
+          <a:prstGeom prst="rect">
+            <a:avLst/>
+          </a:prstGeom>
+          <a:noFill/>
+          <a:ln/>
+        </p:spPr>
+        <p:txBody>
+          <a:bodyPr wrap="square" rtlCol="0" anchor="ctr"/>
+          <a:lstStyle/>
+          <a:p>
+            <a:pPr marL="0" indent="0" algn="l">
+              <a:buNone/>
+            </a:pPr>
+            <a:r>
+              <a:rPr lang="en-US" sz="2600" b="1" dirty="0">
+                <a:solidFill>
+                  <a:srgbClr val="1E1E2E"/>
+                </a:solidFill>
+                <a:latin typeface="Calibri" pitchFamily="34" charset="0"/>
+                <a:ea typeface="Calibri" pitchFamily="34" charset="-122"/>
+                <a:cs typeface="Calibri" pitchFamily="34" charset="-120"/>
+              </a:rPr>
+              <a:t>Wing Inertia </a:t>
+            </a:r>
+            <a:endParaRPr lang="en-US" sz="2600" dirty="0"/>
+          </a:p>
+        </p:txBody>
+      </p:sp>
+      <p:sp>
+        <p:nvSpPr>
+          <p:cNvPr id="4" name="Shape 2"/>
+          <p:cNvSpPr/>
+          <p:nvPr/>
+        </p:nvSpPr>
+        <p:spPr>
+          <a:xfrm>
+            <a:off x="365760" y="987552"/>
+            <a:ext cx="8412480" cy="22860"/>
+          </a:xfrm>
+          <a:prstGeom prst="rect">
+            <a:avLst/>
+          </a:prstGeom>
+          <a:solidFill>
+            <a:srgbClr val="4A90D9"/>
+          </a:solidFill>
+          <a:ln w="12700">
+            <a:solidFill>
+              <a:srgbClr val="4A90D9"/>
+            </a:solidFill>
+            <a:prstDash val="solid"/>
+          </a:ln>
+        </p:spPr>
+      </p:sp>
+      <p:sp>
+        <p:nvSpPr>
+          <p:cNvPr id="5" name="Text 3"/>
+          <p:cNvSpPr/>
+          <p:nvPr/>
+        </p:nvSpPr>
+        <p:spPr>
+          <a:xfrm>
+            <a:off x="365760" y="1115568"/>
+            <a:ext cx="8412480" cy="411480"/>
+          </a:xfrm>
+          <a:prstGeom prst="rect">
+            <a:avLst/>
+          </a:prstGeom>
+          <a:noFill/>
+          <a:ln/>
+        </p:spPr>
+        <p:txBody>
+          <a:bodyPr wrap="square" rtlCol="0" anchor="ctr"/>
+          <a:lstStyle/>
+          <a:p>
+            <a:pPr marL="0" indent="0">
+              <a:buNone/>
+            </a:pPr>
+            <a:r>
+              <a:rPr lang="en-US" sz="1100" b="1" dirty="0">
+                <a:solidFill>
+                  <a:srgbClr val="4A90D9"/>
+                </a:solidFill>
+                <a:latin typeface="Calibri" pitchFamily="34" charset="0"/>
+                <a:ea typeface="Calibri" pitchFamily="34" charset="-122"/>
+                <a:cs typeface="Calibri" pitchFamily="34" charset="-120"/>
+              </a:rPr>
+              <a:t>Key Finding: </a:t>
+            </a:r>
+            <a:r>
+              <a:rPr lang="en-US" sz="1100" dirty="0">
+                <a:solidFill>
+                  <a:srgbClr val="1E1E2E"/>
+                </a:solidFill>
+                <a:latin typeface="Calibri" pitchFamily="34" charset="0"/>
+                <a:ea typeface="Calibri" pitchFamily="34" charset="-122"/>
+                <a:cs typeface="Calibri" pitchFamily="34" charset="-120"/>
+              </a:rPr>
+              <a:t>An intermediate inertia (not minimum) gives maximum lift. This is because inertia governs pitch amplitude .</a:t>
+            </a:r>
+            <a:endParaRPr lang="en-US" sz="1100" dirty="0"/>
+          </a:p>
+        </p:txBody>
+      </p:sp>
+      <p:pic>
+        <p:nvPicPr>
+          <p:cNvPr id="21" name="Picture 20">
+            <a:extLst>
+              <a:ext uri="{FF2B5EF4-FFF2-40B4-BE49-F238E27FC236}">
+                <a16:creationId xmlns:a16="http://schemas.microsoft.com/office/drawing/2014/main" id="{EEC102B8-D1AC-8F08-C57C-C3DA8E7157F0}"/>
+              </a:ext>
+            </a:extLst>
+          </p:cNvPr>
+          <p:cNvPicPr>
+            <a:picLocks noChangeAspect="1"/>
+          </p:cNvPicPr>
+          <p:nvPr/>
+        </p:nvPicPr>
+        <p:blipFill>
+          <a:blip r:embed="rId3"/>
+          <a:stretch>
+            <a:fillRect/>
+          </a:stretch>
+        </p:blipFill>
+        <p:spPr>
+          <a:xfrm>
+            <a:off x="1737360" y="1632204"/>
+            <a:ext cx="5049442" cy="1430566"/>
+          </a:xfrm>
+          <a:prstGeom prst="rect">
+            <a:avLst/>
+          </a:prstGeom>
+        </p:spPr>
+      </p:pic>
+      <p:sp>
+        <p:nvSpPr>
+          <p:cNvPr id="22" name="TextBox 21">
+            <a:extLst>
+              <a:ext uri="{FF2B5EF4-FFF2-40B4-BE49-F238E27FC236}">
+                <a16:creationId xmlns:a16="http://schemas.microsoft.com/office/drawing/2014/main" id="{B460D6FE-FB5E-6D44-5C01-524A4FE926D9}"/>
+              </a:ext>
+            </a:extLst>
+          </p:cNvPr>
+          <p:cNvSpPr txBox="1"/>
+          <p:nvPr/>
+        </p:nvSpPr>
+        <p:spPr>
+          <a:xfrm>
+            <a:off x="3393894" y="3351860"/>
+            <a:ext cx="1736373" cy="1107996"/>
+          </a:xfrm>
+          <a:prstGeom prst="rect">
+            <a:avLst/>
+          </a:prstGeom>
+          <a:noFill/>
+        </p:spPr>
+        <p:txBody>
+          <a:bodyPr wrap="none" rtlCol="0">
+            <a:spAutoFit/>
+          </a:bodyPr>
+          <a:lstStyle/>
+          <a:p>
+            <a:r>
+              <a:rPr lang="en-IN" noProof="1">
+                <a:latin typeface="Sabon Next LT" panose="020B0502040204020203" pitchFamily="2" charset="0"/>
+                <a:cs typeface="Sabon Next LT" panose="020B0502040204020203" pitchFamily="2" charset="0"/>
+              </a:rPr>
+              <a:t>m</a:t>
+            </a:r>
+            <a:r>
+              <a:rPr lang="en-IN" sz="1200" noProof="1">
+                <a:latin typeface="Sabon Next LT" panose="020B0502040204020203" pitchFamily="2" charset="0"/>
+                <a:cs typeface="Sabon Next LT" panose="020B0502040204020203" pitchFamily="2" charset="0"/>
+              </a:rPr>
+              <a:t>spar = </a:t>
+            </a:r>
+            <a:r>
+              <a:rPr lang="en-IN" noProof="1"/>
+              <a:t>ρ *</a:t>
+            </a:r>
+            <a:r>
+              <a:rPr lang="en-IN" sz="1200" noProof="1"/>
+              <a:t> </a:t>
+            </a:r>
+            <a:r>
+              <a:rPr lang="en-IN" noProof="1"/>
+              <a:t>V</a:t>
+            </a:r>
+            <a:r>
+              <a:rPr lang="en-IN" sz="1200" noProof="1"/>
+              <a:t>spar</a:t>
+            </a:r>
+          </a:p>
+          <a:p>
+            <a:r>
+              <a:rPr lang="en-IN" noProof="1">
+                <a:latin typeface="Sabon Next LT" panose="020B0502040204020203" pitchFamily="2" charset="0"/>
+                <a:cs typeface="Sabon Next LT" panose="020B0502040204020203" pitchFamily="2" charset="0"/>
+              </a:rPr>
+              <a:t>m</a:t>
+            </a:r>
+            <a:r>
+              <a:rPr lang="en-IN" sz="1200" noProof="1">
+                <a:latin typeface="Sabon Next LT" panose="020B0502040204020203" pitchFamily="2" charset="0"/>
+                <a:cs typeface="Sabon Next LT" panose="020B0502040204020203" pitchFamily="2" charset="0"/>
+              </a:rPr>
+              <a:t>spar = </a:t>
+            </a:r>
+            <a:r>
+              <a:rPr lang="en-IN" noProof="1"/>
+              <a:t>ρ</a:t>
+            </a:r>
+            <a:r>
+              <a:rPr lang="en-IN" sz="1200" noProof="1"/>
+              <a:t> </a:t>
+            </a:r>
+            <a:r>
+              <a:rPr lang="en-IN" noProof="1"/>
+              <a:t>* L*t*W</a:t>
+            </a:r>
+          </a:p>
+          <a:p>
+            <a:r>
+              <a:rPr lang="en-IN" noProof="1"/>
+              <a:t>I = </a:t>
+            </a:r>
+            <a:r>
+              <a:rPr lang="en-IN" noProof="1">
+                <a:latin typeface="Sabon Next LT" panose="02000500000000000000" pitchFamily="2" charset="0"/>
+                <a:cs typeface="Sabon Next LT" panose="02000500000000000000" pitchFamily="2" charset="0"/>
+              </a:rPr>
+              <a:t>ʃ r^2 * dm</a:t>
+            </a:r>
+            <a:endParaRPr lang="en-IN" noProof="1"/>
+          </a:p>
+          <a:p>
+            <a:endParaRPr lang="en-IN" sz="1200" noProof="1"/>
+          </a:p>
+        </p:txBody>
+      </p:sp>
+    </p:spTree>
+  </p:cSld>
+  <p:clrMapOvr>
+    <a:masterClrMapping/>
+  </p:clrMapOvr>
+</p:sld>
+</file>
+
+<file path=ppt/slides/slide30.xml><?xml version="1.0" encoding="utf-8"?>
 <p:sld xmlns:a="http://schemas.openxmlformats.org/drawingml/2006/main" xmlns:r="http://schemas.openxmlformats.org/officeDocument/2006/relationships" xmlns:p="http://schemas.openxmlformats.org/presentationml/2006/main">
   <p:cSld>
     <p:spTree>
@@ -7385,8 +9484,8 @@
           </a:p>
         </p:txBody>
       </p:sp>
-      <mc:AlternateContent xmlns:mc="http://schemas.openxmlformats.org/markup-compatibility/2006">
-        <mc:Choice xmlns:a14="http://schemas.microsoft.com/office/drawing/2010/main" Requires="a14">
+      <mc:AlternateContent xmlns:mc="http://schemas.openxmlformats.org/markup-compatibility/2006" xmlns:a14="http://schemas.microsoft.com/office/drawing/2010/main">
+        <mc:Choice Requires="a14">
           <p:sp>
             <p:nvSpPr>
               <p:cNvPr id="5" name="TextBox 4">
@@ -7415,6 +9514,7 @@
               </a:bodyPr>
               <a:lstStyle/>
               <a:p>
+                <a:pPr/>
                 <a14:m>
                   <m:oMathPara xmlns:m="http://schemas.openxmlformats.org/officeDocument/2006/math">
                     <m:oMathParaPr>
@@ -7491,7 +9591,13 @@
                                 <a:rPr lang="en-IN" sz="1400" i="0">
                                   <a:latin typeface="Cambria Math" panose="02040503050406030204" pitchFamily="18" charset="0"/>
                                 </a:rPr>
-                                <m:t>5−</m:t>
+                                <m:t>5</m:t>
+                              </m:r>
+                              <m:r>
+                                <a:rPr lang="en-IN" sz="1400" i="0">
+                                  <a:latin typeface="Cambria Math" panose="02040503050406030204" pitchFamily="18" charset="0"/>
+                                </a:rPr>
+                                <m:t>−</m:t>
                               </m:r>
                               <m:rad>
                                 <m:radPr>
@@ -7584,7 +9690,7 @@
             </p:txBody>
           </p:sp>
         </mc:Choice>
-        <mc:Fallback>
+        <mc:Fallback xmlns="">
           <p:sp>
             <p:nvSpPr>
               <p:cNvPr id="5" name="TextBox 4">
@@ -7629,8 +9735,8 @@
           </p:sp>
         </mc:Fallback>
       </mc:AlternateContent>
-      <mc:AlternateContent xmlns:mc="http://schemas.openxmlformats.org/markup-compatibility/2006">
-        <mc:Choice xmlns:a14="http://schemas.microsoft.com/office/drawing/2010/main" Requires="a14">
+      <mc:AlternateContent xmlns:mc="http://schemas.openxmlformats.org/markup-compatibility/2006" xmlns:a14="http://schemas.microsoft.com/office/drawing/2010/main">
+        <mc:Choice Requires="a14">
           <p:sp>
             <p:nvSpPr>
               <p:cNvPr id="6" name="TextBox 5">
@@ -7659,6 +9765,7 @@
               </a:bodyPr>
               <a:lstStyle/>
               <a:p>
+                <a:pPr/>
                 <a14:m>
                   <m:oMathPara xmlns:m="http://schemas.openxmlformats.org/officeDocument/2006/math">
                     <m:oMathParaPr>
@@ -7672,7 +9779,7 @@
                           <m:subHide m:val="on"/>
                           <m:supHide m:val="on"/>
                           <m:ctrlPr>
-                            <a:rPr lang="en-IN" sz="1400" smtClean="0">
+                            <a:rPr lang="en-IN" sz="1400" i="1" smtClean="0">
                               <a:latin typeface="Cambria Math" panose="02040503050406030204" pitchFamily="18" charset="0"/>
                             </a:rPr>
                           </m:ctrlPr>
@@ -7760,7 +9867,13 @@
                             <a:rPr lang="en-IN" sz="1400" i="0">
                               <a:latin typeface="Cambria Math" panose="02040503050406030204" pitchFamily="18" charset="0"/>
                             </a:rPr>
-                            <m:t>5−</m:t>
+                            <m:t>5</m:t>
+                          </m:r>
+                          <m:r>
+                            <a:rPr lang="en-IN" sz="1400" i="0">
+                              <a:latin typeface="Cambria Math" panose="02040503050406030204" pitchFamily="18" charset="0"/>
+                            </a:rPr>
+                            <m:t>−</m:t>
                           </m:r>
                           <m:rad>
                             <m:radPr>
@@ -7802,7 +9915,13 @@
                             <a:rPr lang="en-IN" sz="1400" i="0">
                               <a:latin typeface="Cambria Math" panose="02040503050406030204" pitchFamily="18" charset="0"/>
                             </a:rPr>
-                            <m:t>1−</m:t>
+                            <m:t>1</m:t>
+                          </m:r>
+                          <m:r>
+                            <a:rPr lang="en-IN" sz="1400" i="0">
+                              <a:latin typeface="Cambria Math" panose="02040503050406030204" pitchFamily="18" charset="0"/>
+                            </a:rPr>
+                            <m:t>−</m:t>
                           </m:r>
                           <m:f>
                             <m:fPr>
@@ -7854,7 +9973,7 @@
             </p:txBody>
           </p:sp>
         </mc:Choice>
-        <mc:Fallback>
+        <mc:Fallback xmlns="">
           <p:sp>
             <p:nvSpPr>
               <p:cNvPr id="6" name="TextBox 5">
@@ -7899,8 +10018,8 @@
           </p:sp>
         </mc:Fallback>
       </mc:AlternateContent>
-      <mc:AlternateContent xmlns:mc="http://schemas.openxmlformats.org/markup-compatibility/2006">
-        <mc:Choice xmlns:a14="http://schemas.microsoft.com/office/drawing/2010/main" Requires="a14">
+      <mc:AlternateContent xmlns:mc="http://schemas.openxmlformats.org/markup-compatibility/2006" xmlns:a14="http://schemas.microsoft.com/office/drawing/2010/main">
+        <mc:Choice Requires="a14">
           <p:sp>
             <p:nvSpPr>
               <p:cNvPr id="8" name="TextBox 7">
@@ -7929,6 +10048,7 @@
               </a:bodyPr>
               <a:lstStyle/>
               <a:p>
+                <a:pPr/>
                 <a14:m>
                   <m:oMathPara xmlns:m="http://schemas.openxmlformats.org/officeDocument/2006/math">
                     <m:oMathParaPr>
@@ -8013,7 +10133,13 @@
                             <a:rPr lang="en-IN" sz="1400" i="0">
                               <a:latin typeface="Cambria Math" panose="02040503050406030204" pitchFamily="18" charset="0"/>
                             </a:rPr>
-                            <m:t>5−</m:t>
+                            <m:t>5</m:t>
+                          </m:r>
+                          <m:r>
+                            <a:rPr lang="en-IN" sz="1400" i="0">
+                              <a:latin typeface="Cambria Math" panose="02040503050406030204" pitchFamily="18" charset="0"/>
+                            </a:rPr>
+                            <m:t>−</m:t>
                           </m:r>
                           <m:rad>
                             <m:radPr>
@@ -8078,7 +10204,7 @@
             </p:txBody>
           </p:sp>
         </mc:Choice>
-        <mc:Fallback>
+        <mc:Fallback xmlns="">
           <p:sp>
             <p:nvSpPr>
               <p:cNvPr id="8" name="TextBox 7">
@@ -8123,8 +10249,8 @@
           </p:sp>
         </mc:Fallback>
       </mc:AlternateContent>
-      <mc:AlternateContent xmlns:mc="http://schemas.openxmlformats.org/markup-compatibility/2006">
-        <mc:Choice xmlns:a14="http://schemas.microsoft.com/office/drawing/2010/main" Requires="a14">
+      <mc:AlternateContent xmlns:mc="http://schemas.openxmlformats.org/markup-compatibility/2006" xmlns:a14="http://schemas.microsoft.com/office/drawing/2010/main">
+        <mc:Choice Requires="a14">
           <p:sp>
             <p:nvSpPr>
               <p:cNvPr id="11" name="TextBox 10">
@@ -8255,7 +10381,13 @@
                             <a:rPr lang="en-IN" sz="1400" i="0">
                               <a:latin typeface="Cambria Math" panose="02040503050406030204" pitchFamily="18" charset="0"/>
                             </a:rPr>
-                            <m:t>5−</m:t>
+                            <m:t>5</m:t>
+                          </m:r>
+                          <m:r>
+                            <a:rPr lang="en-IN" sz="1400" i="0">
+                              <a:latin typeface="Cambria Math" panose="02040503050406030204" pitchFamily="18" charset="0"/>
+                            </a:rPr>
+                            <m:t>−</m:t>
                           </m:r>
                           <m:rad>
                             <m:radPr>
@@ -8343,7 +10475,7 @@
             </p:txBody>
           </p:sp>
         </mc:Choice>
-        <mc:Fallback>
+        <mc:Fallback xmlns="">
           <p:sp>
             <p:nvSpPr>
               <p:cNvPr id="11" name="TextBox 10">
@@ -8436,689 +10568,7 @@
 </p:sld>
 </file>
 
-<file path=ppt/slides/slide2.xml><?xml version="1.0" encoding="utf-8"?>
-<p:sld xmlns:a="http://schemas.openxmlformats.org/drawingml/2006/main" xmlns:r="http://schemas.openxmlformats.org/officeDocument/2006/relationships" xmlns:p="http://schemas.openxmlformats.org/presentationml/2006/main">
-  <p:cSld name="Slide 2">
-    <p:bg>
-      <p:bgPr>
-        <a:solidFill>
-          <a:srgbClr val="F7F7F7"/>
-        </a:solidFill>
-        <a:effectLst/>
-      </p:bgPr>
-    </p:bg>
-    <p:spTree>
-      <p:nvGrpSpPr>
-        <p:cNvPr id="1" name=""/>
-        <p:cNvGrpSpPr/>
-        <p:nvPr/>
-      </p:nvGrpSpPr>
-      <p:grpSpPr>
-        <a:xfrm>
-          <a:off x="0" y="0"/>
-          <a:ext cx="0" cy="0"/>
-          <a:chOff x="0" y="0"/>
-          <a:chExt cx="0" cy="0"/>
-        </a:xfrm>
-      </p:grpSpPr>
-      <p:sp>
-        <p:nvSpPr>
-          <p:cNvPr id="2" name="Text 0"/>
-          <p:cNvSpPr/>
-          <p:nvPr/>
-        </p:nvSpPr>
-        <p:spPr>
-          <a:xfrm>
-            <a:off x="365760" y="164592"/>
-            <a:ext cx="2743200" cy="201168"/>
-          </a:xfrm>
-          <a:prstGeom prst="rect">
-            <a:avLst/>
-          </a:prstGeom>
-          <a:noFill/>
-          <a:ln/>
-        </p:spPr>
-        <p:txBody>
-          <a:bodyPr wrap="square" rtlCol="0" anchor="ctr"/>
-          <a:lstStyle/>
-          <a:p>
-            <a:pPr marL="0" indent="0" algn="l">
-              <a:buNone/>
-            </a:pPr>
-            <a:r>
-              <a:rPr lang="en-US" sz="1400" b="1" kern="0" spc="300" dirty="0">
-                <a:solidFill>
-                  <a:srgbClr val="4A90D9"/>
-                </a:solidFill>
-                <a:latin typeface="Calibri" pitchFamily="34" charset="0"/>
-                <a:ea typeface="Calibri" pitchFamily="34" charset="-122"/>
-                <a:cs typeface="Calibri" pitchFamily="34" charset="-120"/>
-              </a:rPr>
-              <a:t>INTRODUCTION</a:t>
-            </a:r>
-            <a:endParaRPr lang="en-US" sz="1400" dirty="0"/>
-          </a:p>
-        </p:txBody>
-      </p:sp>
-      <p:sp>
-        <p:nvSpPr>
-          <p:cNvPr id="3" name="Text 1"/>
-          <p:cNvSpPr/>
-          <p:nvPr/>
-        </p:nvSpPr>
-        <p:spPr>
-          <a:xfrm>
-            <a:off x="365760" y="384048"/>
-            <a:ext cx="8412480" cy="548640"/>
-          </a:xfrm>
-          <a:prstGeom prst="rect">
-            <a:avLst/>
-          </a:prstGeom>
-          <a:noFill/>
-          <a:ln/>
-        </p:spPr>
-        <p:txBody>
-          <a:bodyPr wrap="square" rtlCol="0" anchor="ctr"/>
-          <a:lstStyle/>
-          <a:p>
-            <a:pPr marL="0" indent="0" algn="l">
-              <a:buNone/>
-            </a:pPr>
-            <a:r>
-              <a:rPr lang="en-US" sz="2600" b="1" dirty="0">
-                <a:solidFill>
-                  <a:srgbClr val="1E1E2E"/>
-                </a:solidFill>
-                <a:latin typeface="Calibri" pitchFamily="34" charset="0"/>
-                <a:ea typeface="Calibri" pitchFamily="34" charset="-122"/>
-                <a:cs typeface="Calibri" pitchFamily="34" charset="-120"/>
-              </a:rPr>
-              <a:t>Background &amp; Motivation</a:t>
-            </a:r>
-            <a:endParaRPr lang="en-US" sz="2600" dirty="0"/>
-          </a:p>
-        </p:txBody>
-      </p:sp>
-      <p:sp>
-        <p:nvSpPr>
-          <p:cNvPr id="4" name="Shape 2"/>
-          <p:cNvSpPr/>
-          <p:nvPr/>
-        </p:nvSpPr>
-        <p:spPr>
-          <a:xfrm>
-            <a:off x="365760" y="987552"/>
-            <a:ext cx="8412480" cy="22860"/>
-          </a:xfrm>
-          <a:prstGeom prst="rect">
-            <a:avLst/>
-          </a:prstGeom>
-          <a:solidFill>
-            <a:srgbClr val="4A90D9"/>
-          </a:solidFill>
-          <a:ln w="12700">
-            <a:solidFill>
-              <a:srgbClr val="4A90D9"/>
-            </a:solidFill>
-            <a:prstDash val="solid"/>
-          </a:ln>
-        </p:spPr>
-      </p:sp>
-      <p:sp>
-        <p:nvSpPr>
-          <p:cNvPr id="5" name="Text 3"/>
-          <p:cNvSpPr/>
-          <p:nvPr/>
-        </p:nvSpPr>
-        <p:spPr>
-          <a:xfrm>
-            <a:off x="365760" y="1143000"/>
-            <a:ext cx="4937760" cy="4000500"/>
-          </a:xfrm>
-          <a:prstGeom prst="rect">
-            <a:avLst/>
-          </a:prstGeom>
-          <a:noFill/>
-          <a:ln/>
-        </p:spPr>
-        <p:txBody>
-          <a:bodyPr wrap="square" rtlCol="0" anchor="t"/>
-          <a:lstStyle/>
-          <a:p>
-            <a:pPr marL="0" indent="0" algn="l">
-              <a:buNone/>
-            </a:pPr>
-            <a:r>
-              <a:rPr lang="en-US" sz="1200" b="1" dirty="0">
-                <a:solidFill>
-                  <a:srgbClr val="1E1E2E"/>
-                </a:solidFill>
-                <a:latin typeface="Calibri" pitchFamily="34" charset="0"/>
-                <a:ea typeface="Calibri" pitchFamily="34" charset="-122"/>
-                <a:cs typeface="Calibri" pitchFamily="34" charset="-120"/>
-              </a:rPr>
-              <a:t>What are Micro Air Vehicles (MAVs)?</a:t>
-            </a:r>
-            <a:endParaRPr lang="en-US" sz="1200" dirty="0"/>
-          </a:p>
-          <a:p>
-            <a:pPr marL="0" indent="0" algn="l">
-              <a:buNone/>
-            </a:pPr>
-            <a:r>
-              <a:rPr lang="en-US" sz="1100" dirty="0">
-                <a:solidFill>
-                  <a:srgbClr val="6B7280"/>
-                </a:solidFill>
-                <a:latin typeface="Calibri" pitchFamily="34" charset="0"/>
-                <a:ea typeface="Calibri" pitchFamily="34" charset="-122"/>
-                <a:cs typeface="Calibri" pitchFamily="34" charset="-120"/>
-              </a:rPr>
-              <a:t>Insect-scale robots that use flapping wings for lift and thrust.</a:t>
-            </a:r>
-            <a:endParaRPr lang="en-US" sz="1100" dirty="0"/>
-          </a:p>
-          <a:p>
-            <a:pPr marL="0" indent="0" algn="l">
-              <a:buNone/>
-            </a:pPr>
-            <a:r>
-              <a:rPr lang="en-US" sz="1100" dirty="0">
-                <a:solidFill>
-                  <a:srgbClr val="000000"/>
-                </a:solidFill>
-                <a:latin typeface="Calibri" pitchFamily="34" charset="0"/>
-                <a:ea typeface="Calibri" pitchFamily="34" charset="-122"/>
-                <a:cs typeface="Calibri" pitchFamily="34" charset="-120"/>
-              </a:rPr>
-              <a:t> </a:t>
-            </a:r>
-            <a:endParaRPr lang="en-US" sz="1200" dirty="0"/>
-          </a:p>
-          <a:p>
-            <a:pPr marL="0" indent="0" algn="l">
-              <a:buNone/>
-            </a:pPr>
-            <a:r>
-              <a:rPr lang="en-US" sz="1200" b="1" dirty="0">
-                <a:solidFill>
-                  <a:srgbClr val="1E1E2E"/>
-                </a:solidFill>
-                <a:latin typeface="Calibri" pitchFamily="34" charset="0"/>
-                <a:ea typeface="Calibri" pitchFamily="34" charset="-122"/>
-                <a:cs typeface="Calibri" pitchFamily="34" charset="-120"/>
-              </a:rPr>
-              <a:t>The RoboBee Platform</a:t>
-            </a:r>
-            <a:endParaRPr lang="en-US" sz="1200" dirty="0"/>
-          </a:p>
-          <a:p>
-            <a:pPr marL="0" indent="0" algn="l">
-              <a:buNone/>
-            </a:pPr>
-            <a:r>
-              <a:rPr lang="en-US" sz="1100" dirty="0">
-                <a:solidFill>
-                  <a:srgbClr val="6B7280"/>
-                </a:solidFill>
-                <a:latin typeface="Calibri" pitchFamily="34" charset="0"/>
-                <a:ea typeface="Calibri" pitchFamily="34" charset="-122"/>
-                <a:cs typeface="Calibri" pitchFamily="34" charset="-120"/>
-              </a:rPr>
-              <a:t>Developed at Harvard Microrobotics Lab. Mass ≈ 80 mg.</a:t>
-            </a:r>
-            <a:endParaRPr lang="en-US" sz="1100" dirty="0"/>
-          </a:p>
-          <a:p>
-            <a:pPr marL="0" indent="0" algn="l">
-              <a:buNone/>
-            </a:pPr>
-            <a:r>
-              <a:rPr lang="en-US" sz="1100" dirty="0">
-                <a:solidFill>
-                  <a:srgbClr val="000000"/>
-                </a:solidFill>
-                <a:latin typeface="Calibri" pitchFamily="34" charset="0"/>
-                <a:ea typeface="Calibri" pitchFamily="34" charset="-122"/>
-                <a:cs typeface="Calibri" pitchFamily="34" charset="-120"/>
-              </a:rPr>
-              <a:t> </a:t>
-            </a:r>
-            <a:endParaRPr lang="en-US" sz="1100" dirty="0"/>
-          </a:p>
-          <a:p>
-            <a:pPr marL="0" indent="0" algn="l">
-              <a:buNone/>
-            </a:pPr>
-            <a:r>
-              <a:rPr lang="en-US" sz="1200" b="1" dirty="0">
-                <a:solidFill>
-                  <a:srgbClr val="1E1E2E"/>
-                </a:solidFill>
-                <a:latin typeface="Calibri" pitchFamily="34" charset="0"/>
-                <a:ea typeface="Calibri" pitchFamily="34" charset="-122"/>
-                <a:cs typeface="Calibri" pitchFamily="34" charset="-120"/>
-              </a:rPr>
-              <a:t>Why wing morphology matters?</a:t>
-            </a:r>
-            <a:endParaRPr lang="en-US" sz="1200" dirty="0"/>
-          </a:p>
-          <a:p>
-            <a:pPr marL="0" indent="0" algn="l">
-              <a:buNone/>
-            </a:pPr>
-            <a:r>
-              <a:rPr lang="en-US" sz="1100" dirty="0">
-                <a:solidFill>
-                  <a:srgbClr val="6B7280"/>
-                </a:solidFill>
-                <a:latin typeface="Calibri" pitchFamily="34" charset="0"/>
-                <a:ea typeface="Calibri" pitchFamily="34" charset="-122"/>
-                <a:cs typeface="Calibri" pitchFamily="34" charset="-120"/>
-              </a:rPr>
-              <a:t>Wing geometry directly governs resonance frequency, pitch amplitude, lift generation, and power consumption.</a:t>
-            </a:r>
-            <a:endParaRPr lang="en-US" sz="1100" dirty="0"/>
-          </a:p>
-        </p:txBody>
-      </p:sp>
-      <p:sp>
-        <p:nvSpPr>
-          <p:cNvPr id="7" name="Text 5"/>
-          <p:cNvSpPr/>
-          <p:nvPr/>
-        </p:nvSpPr>
-        <p:spPr>
-          <a:xfrm>
-            <a:off x="5577840" y="1353312"/>
-            <a:ext cx="1600200" cy="457200"/>
-          </a:xfrm>
-          <a:prstGeom prst="rect">
-            <a:avLst/>
-          </a:prstGeom>
-          <a:noFill/>
-          <a:ln/>
-        </p:spPr>
-        <p:txBody>
-          <a:bodyPr wrap="square" rtlCol="0" anchor="ctr"/>
-          <a:lstStyle/>
-          <a:p>
-            <a:pPr marL="0" indent="0" algn="ctr">
-              <a:buNone/>
-            </a:pPr>
-            <a:endParaRPr lang="en-US" sz="1800" dirty="0"/>
-          </a:p>
-        </p:txBody>
-      </p:sp>
-      <p:sp>
-        <p:nvSpPr>
-          <p:cNvPr id="8" name="Text 6"/>
-          <p:cNvSpPr/>
-          <p:nvPr/>
-        </p:nvSpPr>
-        <p:spPr>
-          <a:xfrm>
-            <a:off x="5577840" y="1810512"/>
-            <a:ext cx="1600200" cy="365760"/>
-          </a:xfrm>
-          <a:prstGeom prst="rect">
-            <a:avLst/>
-          </a:prstGeom>
-          <a:noFill/>
-          <a:ln/>
-        </p:spPr>
-        <p:txBody>
-          <a:bodyPr wrap="square" rtlCol="0" anchor="ctr"/>
-          <a:lstStyle/>
-          <a:p>
-            <a:pPr marL="0" indent="0" algn="ctr">
-              <a:buNone/>
-            </a:pPr>
-            <a:endParaRPr lang="en-US" sz="900" dirty="0"/>
-          </a:p>
-        </p:txBody>
-      </p:sp>
-      <p:sp>
-        <p:nvSpPr>
-          <p:cNvPr id="10" name="Text 8"/>
-          <p:cNvSpPr/>
-          <p:nvPr/>
-        </p:nvSpPr>
-        <p:spPr>
-          <a:xfrm>
-            <a:off x="7360920" y="1353312"/>
-            <a:ext cx="1600200" cy="457200"/>
-          </a:xfrm>
-          <a:prstGeom prst="rect">
-            <a:avLst/>
-          </a:prstGeom>
-          <a:noFill/>
-          <a:ln/>
-        </p:spPr>
-        <p:txBody>
-          <a:bodyPr wrap="square" rtlCol="0" anchor="ctr"/>
-          <a:lstStyle/>
-          <a:p>
-            <a:pPr marL="0" indent="0" algn="ctr">
-              <a:buNone/>
-            </a:pPr>
-            <a:endParaRPr lang="en-US" sz="1800" dirty="0"/>
-          </a:p>
-        </p:txBody>
-      </p:sp>
-      <p:sp>
-        <p:nvSpPr>
-          <p:cNvPr id="11" name="Text 9"/>
-          <p:cNvSpPr/>
-          <p:nvPr/>
-        </p:nvSpPr>
-        <p:spPr>
-          <a:xfrm>
-            <a:off x="7360920" y="1810512"/>
-            <a:ext cx="1600200" cy="365760"/>
-          </a:xfrm>
-          <a:prstGeom prst="rect">
-            <a:avLst/>
-          </a:prstGeom>
-          <a:noFill/>
-          <a:ln/>
-        </p:spPr>
-        <p:txBody>
-          <a:bodyPr wrap="square" rtlCol="0" anchor="ctr"/>
-          <a:lstStyle/>
-          <a:p>
-            <a:pPr marL="0" indent="0" algn="ctr">
-              <a:buNone/>
-            </a:pPr>
-            <a:endParaRPr lang="en-US" sz="900" dirty="0"/>
-          </a:p>
-        </p:txBody>
-      </p:sp>
-      <p:sp>
-        <p:nvSpPr>
-          <p:cNvPr id="13" name="Text 11"/>
-          <p:cNvSpPr/>
-          <p:nvPr/>
-        </p:nvSpPr>
-        <p:spPr>
-          <a:xfrm>
-            <a:off x="5577840" y="2770632"/>
-            <a:ext cx="1600200" cy="457200"/>
-          </a:xfrm>
-          <a:prstGeom prst="rect">
-            <a:avLst/>
-          </a:prstGeom>
-          <a:noFill/>
-          <a:ln/>
-        </p:spPr>
-        <p:txBody>
-          <a:bodyPr wrap="square" rtlCol="0" anchor="ctr"/>
-          <a:lstStyle/>
-          <a:p>
-            <a:pPr marL="0" indent="0" algn="ctr">
-              <a:buNone/>
-            </a:pPr>
-            <a:endParaRPr lang="en-US" sz="1800" dirty="0"/>
-          </a:p>
-        </p:txBody>
-      </p:sp>
-      <p:sp>
-        <p:nvSpPr>
-          <p:cNvPr id="14" name="Text 12"/>
-          <p:cNvSpPr/>
-          <p:nvPr/>
-        </p:nvSpPr>
-        <p:spPr>
-          <a:xfrm>
-            <a:off x="5577840" y="3227832"/>
-            <a:ext cx="1600200" cy="365760"/>
-          </a:xfrm>
-          <a:prstGeom prst="rect">
-            <a:avLst/>
-          </a:prstGeom>
-          <a:noFill/>
-          <a:ln/>
-        </p:spPr>
-        <p:txBody>
-          <a:bodyPr wrap="square" rtlCol="0" anchor="ctr"/>
-          <a:lstStyle/>
-          <a:p>
-            <a:pPr marL="0" indent="0" algn="ctr">
-              <a:buNone/>
-            </a:pPr>
-            <a:endParaRPr lang="en-US" sz="900" dirty="0"/>
-          </a:p>
-        </p:txBody>
-      </p:sp>
-      <p:sp>
-        <p:nvSpPr>
-          <p:cNvPr id="16" name="Text 14"/>
-          <p:cNvSpPr/>
-          <p:nvPr/>
-        </p:nvSpPr>
-        <p:spPr>
-          <a:xfrm>
-            <a:off x="7360920" y="2770632"/>
-            <a:ext cx="1600200" cy="457200"/>
-          </a:xfrm>
-          <a:prstGeom prst="rect">
-            <a:avLst/>
-          </a:prstGeom>
-          <a:noFill/>
-          <a:ln/>
-        </p:spPr>
-        <p:txBody>
-          <a:bodyPr wrap="square" rtlCol="0" anchor="ctr"/>
-          <a:lstStyle/>
-          <a:p>
-            <a:pPr marL="0" indent="0" algn="ctr">
-              <a:buNone/>
-            </a:pPr>
-            <a:endParaRPr lang="en-US" sz="1800" dirty="0"/>
-          </a:p>
-        </p:txBody>
-      </p:sp>
-      <p:sp>
-        <p:nvSpPr>
-          <p:cNvPr id="17" name="Text 15"/>
-          <p:cNvSpPr/>
-          <p:nvPr/>
-        </p:nvSpPr>
-        <p:spPr>
-          <a:xfrm>
-            <a:off x="7360920" y="3227832"/>
-            <a:ext cx="1600200" cy="365760"/>
-          </a:xfrm>
-          <a:prstGeom prst="rect">
-            <a:avLst/>
-          </a:prstGeom>
-          <a:noFill/>
-          <a:ln/>
-        </p:spPr>
-        <p:txBody>
-          <a:bodyPr wrap="square" rtlCol="0" anchor="ctr"/>
-          <a:lstStyle/>
-          <a:p>
-            <a:pPr marL="0" indent="0" algn="ctr">
-              <a:buNone/>
-            </a:pPr>
-            <a:endParaRPr lang="en-US" sz="900" dirty="0"/>
-          </a:p>
-        </p:txBody>
-      </p:sp>
-      <p:sp>
-        <p:nvSpPr>
-          <p:cNvPr id="19" name="Text 17"/>
-          <p:cNvSpPr/>
-          <p:nvPr/>
-        </p:nvSpPr>
-        <p:spPr>
-          <a:xfrm>
-            <a:off x="365760" y="4480560"/>
-            <a:ext cx="8412480" cy="502920"/>
-          </a:xfrm>
-          <a:prstGeom prst="rect">
-            <a:avLst/>
-          </a:prstGeom>
-          <a:noFill/>
-          <a:ln/>
-        </p:spPr>
-        <p:txBody>
-          <a:bodyPr wrap="square" rtlCol="0" anchor="ctr"/>
-          <a:lstStyle/>
-          <a:p>
-            <a:pPr marL="0" indent="0" algn="ctr">
-              <a:buNone/>
-            </a:pPr>
-            <a:r>
-              <a:rPr lang="en-US" sz="1050" b="1" dirty="0">
-                <a:solidFill>
-                  <a:srgbClr val="FFFFFF"/>
-                </a:solidFill>
-                <a:latin typeface="Calibri" pitchFamily="34" charset="0"/>
-                <a:ea typeface="Calibri" pitchFamily="34" charset="-122"/>
-                <a:cs typeface="Calibri" pitchFamily="34" charset="-120"/>
-              </a:rPr>
-              <a:t>Goal of Chapter 3: Systematically quantify how 5 wing parameters affect lift, power, and resonance frequency.</a:t>
-            </a:r>
-            <a:endParaRPr lang="en-US" sz="1050" dirty="0"/>
-          </a:p>
-        </p:txBody>
-      </p:sp>
-      <p:pic>
-        <p:nvPicPr>
-          <p:cNvPr id="21" name="Picture 20">
-            <a:extLst>
-              <a:ext uri="{FF2B5EF4-FFF2-40B4-BE49-F238E27FC236}">
-                <a16:creationId xmlns:a16="http://schemas.microsoft.com/office/drawing/2014/main" id="{7311551D-0EC2-7E3E-7C9A-69164E9B2FA9}"/>
-              </a:ext>
-            </a:extLst>
-          </p:cNvPr>
-          <p:cNvPicPr>
-            <a:picLocks noChangeAspect="1"/>
-          </p:cNvPicPr>
-          <p:nvPr/>
-        </p:nvPicPr>
-        <p:blipFill>
-          <a:blip r:embed="rId3"/>
-          <a:stretch>
-            <a:fillRect/>
-          </a:stretch>
-        </p:blipFill>
-        <p:spPr>
-          <a:xfrm>
-            <a:off x="5303520" y="1227680"/>
-            <a:ext cx="3538413" cy="2512671"/>
-          </a:xfrm>
-          <a:prstGeom prst="rect">
-            <a:avLst/>
-          </a:prstGeom>
-        </p:spPr>
-      </p:pic>
-      <p:sp>
-        <p:nvSpPr>
-          <p:cNvPr id="22" name="TextBox 21">
-            <a:extLst>
-              <a:ext uri="{FF2B5EF4-FFF2-40B4-BE49-F238E27FC236}">
-                <a16:creationId xmlns:a16="http://schemas.microsoft.com/office/drawing/2014/main" id="{C10C960B-F728-A0A9-6C3A-E86B976E25E7}"/>
-              </a:ext>
-            </a:extLst>
-          </p:cNvPr>
-          <p:cNvSpPr txBox="1"/>
-          <p:nvPr/>
-        </p:nvSpPr>
-        <p:spPr>
-          <a:xfrm>
-            <a:off x="5140146" y="3825031"/>
-            <a:ext cx="3865161" cy="307777"/>
-          </a:xfrm>
-          <a:prstGeom prst="rect">
-            <a:avLst/>
-          </a:prstGeom>
-          <a:noFill/>
-        </p:spPr>
-        <p:txBody>
-          <a:bodyPr wrap="none" rtlCol="0">
-            <a:spAutoFit/>
-          </a:bodyPr>
-          <a:lstStyle/>
-          <a:p>
-            <a:r>
-              <a:rPr lang="en-IN" sz="1400" dirty="0"/>
-              <a:t>Figure 3.1: Wing driver platform and wing designs.</a:t>
-            </a:r>
-          </a:p>
-        </p:txBody>
-      </p:sp>
-      <p:sp>
-        <p:nvSpPr>
-          <p:cNvPr id="23" name="TextBox 22">
-            <a:extLst>
-              <a:ext uri="{FF2B5EF4-FFF2-40B4-BE49-F238E27FC236}">
-                <a16:creationId xmlns:a16="http://schemas.microsoft.com/office/drawing/2014/main" id="{9426D35C-CA1E-FEF2-32CA-215716C964D8}"/>
-              </a:ext>
-            </a:extLst>
-          </p:cNvPr>
-          <p:cNvSpPr txBox="1"/>
-          <p:nvPr/>
-        </p:nvSpPr>
-        <p:spPr>
-          <a:xfrm>
-            <a:off x="365760" y="2783788"/>
-            <a:ext cx="4604146" cy="615553"/>
-          </a:xfrm>
-          <a:prstGeom prst="rect">
-            <a:avLst/>
-          </a:prstGeom>
-          <a:noFill/>
-        </p:spPr>
-        <p:txBody>
-          <a:bodyPr wrap="none" rtlCol="0">
-            <a:spAutoFit/>
-          </a:bodyPr>
-          <a:lstStyle/>
-          <a:p>
-            <a:r>
-              <a:rPr lang="en-IN" sz="1200" b="1" dirty="0"/>
-              <a:t>Our Aim</a:t>
-            </a:r>
-            <a:br>
-              <a:rPr lang="en-IN" dirty="0"/>
-            </a:br>
-            <a:r>
-              <a:rPr lang="en-IN" sz="1100" dirty="0">
-                <a:solidFill>
-                  <a:schemeClr val="bg1">
-                    <a:lumMod val="50000"/>
-                  </a:schemeClr>
-                </a:solidFill>
-              </a:rPr>
-              <a:t>Improving the robot’s flapping performance and thus payload capacity.</a:t>
-            </a:r>
-          </a:p>
-          <a:p>
-            <a:r>
-              <a:rPr lang="en-IN" sz="1100" dirty="0">
-                <a:solidFill>
-                  <a:schemeClr val="bg1">
-                    <a:lumMod val="50000"/>
-                  </a:schemeClr>
-                </a:solidFill>
-              </a:rPr>
-              <a:t>We demonstrate that wing morphology has large impact on lift enhancement.</a:t>
-            </a:r>
-          </a:p>
-        </p:txBody>
-      </p:sp>
-    </p:spTree>
-  </p:cSld>
-  <p:clrMapOvr>
-    <a:masterClrMapping/>
-  </p:clrMapOvr>
-</p:sld>
-</file>
-
-<file path=ppt/slides/slide20.xml><?xml version="1.0" encoding="utf-8"?>
+<file path=ppt/slides/slide31.xml><?xml version="1.0" encoding="utf-8"?>
 <p:sld xmlns:a="http://schemas.openxmlformats.org/drawingml/2006/main" xmlns:r="http://schemas.openxmlformats.org/officeDocument/2006/relationships" xmlns:p="http://schemas.openxmlformats.org/presentationml/2006/main">
   <p:cSld>
     <p:spTree>
@@ -9213,7 +10663,7 @@
 </p:sld>
 </file>
 
-<file path=ppt/slides/slide21.xml><?xml version="1.0" encoding="utf-8"?>
+<file path=ppt/slides/slide32.xml><?xml version="1.0" encoding="utf-8"?>
 <p:sld xmlns:a="http://schemas.openxmlformats.org/drawingml/2006/main" xmlns:r="http://schemas.openxmlformats.org/officeDocument/2006/relationships" xmlns:p="http://schemas.openxmlformats.org/presentationml/2006/main">
   <p:cSld name="Slide 10">
     <p:bg>
@@ -9492,328 +10942,6 @@
             <a:prstDash val="solid"/>
           </a:ln>
         </p:spPr>
-      </p:sp>
-    </p:spTree>
-  </p:cSld>
-  <p:clrMapOvr>
-    <a:masterClrMapping/>
-  </p:clrMapOvr>
-</p:sld>
-</file>
-
-<file path=ppt/slides/slide3.xml><?xml version="1.0" encoding="utf-8"?>
-<p:sld xmlns:a="http://schemas.openxmlformats.org/drawingml/2006/main" xmlns:r="http://schemas.openxmlformats.org/officeDocument/2006/relationships" xmlns:p="http://schemas.openxmlformats.org/presentationml/2006/main">
-  <p:cSld name="Slide 4">
-    <p:bg>
-      <p:bgPr>
-        <a:solidFill>
-          <a:srgbClr val="F7F7F7"/>
-        </a:solidFill>
-        <a:effectLst/>
-      </p:bgPr>
-    </p:bg>
-    <p:spTree>
-      <p:nvGrpSpPr>
-        <p:cNvPr id="1" name=""/>
-        <p:cNvGrpSpPr/>
-        <p:nvPr/>
-      </p:nvGrpSpPr>
-      <p:grpSpPr>
-        <a:xfrm>
-          <a:off x="0" y="0"/>
-          <a:ext cx="0" cy="0"/>
-          <a:chOff x="0" y="0"/>
-          <a:chExt cx="0" cy="0"/>
-        </a:xfrm>
-      </p:grpSpPr>
-      <p:sp>
-        <p:nvSpPr>
-          <p:cNvPr id="2" name="Text 0"/>
-          <p:cNvSpPr/>
-          <p:nvPr/>
-        </p:nvSpPr>
-        <p:spPr>
-          <a:xfrm>
-            <a:off x="365760" y="164592"/>
-            <a:ext cx="2743200" cy="201168"/>
-          </a:xfrm>
-          <a:prstGeom prst="rect">
-            <a:avLst/>
-          </a:prstGeom>
-          <a:noFill/>
-          <a:ln/>
-        </p:spPr>
-        <p:txBody>
-          <a:bodyPr wrap="square" rtlCol="0" anchor="ctr"/>
-          <a:lstStyle/>
-          <a:p>
-            <a:pPr marL="0" indent="0" algn="l">
-              <a:buNone/>
-            </a:pPr>
-            <a:r>
-              <a:rPr lang="en-US" sz="1000" b="1" kern="0" spc="300" dirty="0">
-                <a:solidFill>
-                  <a:srgbClr val="4A90D9"/>
-                </a:solidFill>
-                <a:latin typeface="Calibri" pitchFamily="34" charset="0"/>
-                <a:ea typeface="Calibri" pitchFamily="34" charset="-122"/>
-                <a:cs typeface="Calibri" pitchFamily="34" charset="-120"/>
-              </a:rPr>
-              <a:t>PARAMETER 1</a:t>
-            </a:r>
-            <a:endParaRPr lang="en-US" sz="1000" dirty="0"/>
-          </a:p>
-        </p:txBody>
-      </p:sp>
-      <p:sp>
-        <p:nvSpPr>
-          <p:cNvPr id="3" name="Text 1"/>
-          <p:cNvSpPr/>
-          <p:nvPr/>
-        </p:nvSpPr>
-        <p:spPr>
-          <a:xfrm>
-            <a:off x="365760" y="384048"/>
-            <a:ext cx="8412480" cy="548640"/>
-          </a:xfrm>
-          <a:prstGeom prst="rect">
-            <a:avLst/>
-          </a:prstGeom>
-          <a:noFill/>
-          <a:ln/>
-        </p:spPr>
-        <p:txBody>
-          <a:bodyPr wrap="square" rtlCol="0" anchor="ctr"/>
-          <a:lstStyle/>
-          <a:p>
-            <a:pPr marL="0" indent="0" algn="l">
-              <a:buNone/>
-            </a:pPr>
-            <a:r>
-              <a:rPr lang="en-US" sz="2600" b="1" dirty="0">
-                <a:solidFill>
-                  <a:srgbClr val="1E1E2E"/>
-                </a:solidFill>
-                <a:latin typeface="Calibri" pitchFamily="34" charset="0"/>
-                <a:ea typeface="Calibri" pitchFamily="34" charset="-122"/>
-                <a:cs typeface="Calibri" pitchFamily="34" charset="-120"/>
-              </a:rPr>
-              <a:t>Wing Inertia </a:t>
-            </a:r>
-            <a:endParaRPr lang="en-US" sz="2600" dirty="0"/>
-          </a:p>
-        </p:txBody>
-      </p:sp>
-      <p:sp>
-        <p:nvSpPr>
-          <p:cNvPr id="4" name="Shape 2"/>
-          <p:cNvSpPr/>
-          <p:nvPr/>
-        </p:nvSpPr>
-        <p:spPr>
-          <a:xfrm>
-            <a:off x="365760" y="987552"/>
-            <a:ext cx="8412480" cy="22860"/>
-          </a:xfrm>
-          <a:prstGeom prst="rect">
-            <a:avLst/>
-          </a:prstGeom>
-          <a:solidFill>
-            <a:srgbClr val="4A90D9"/>
-          </a:solidFill>
-          <a:ln w="12700">
-            <a:solidFill>
-              <a:srgbClr val="4A90D9"/>
-            </a:solidFill>
-            <a:prstDash val="solid"/>
-          </a:ln>
-        </p:spPr>
-      </p:sp>
-      <p:sp>
-        <p:nvSpPr>
-          <p:cNvPr id="5" name="Text 3"/>
-          <p:cNvSpPr/>
-          <p:nvPr/>
-        </p:nvSpPr>
-        <p:spPr>
-          <a:xfrm>
-            <a:off x="365760" y="1115568"/>
-            <a:ext cx="8412480" cy="411480"/>
-          </a:xfrm>
-          <a:prstGeom prst="rect">
-            <a:avLst/>
-          </a:prstGeom>
-          <a:noFill/>
-          <a:ln/>
-        </p:spPr>
-        <p:txBody>
-          <a:bodyPr wrap="square" rtlCol="0" anchor="ctr"/>
-          <a:lstStyle/>
-          <a:p>
-            <a:pPr marL="0" indent="0">
-              <a:buNone/>
-            </a:pPr>
-            <a:r>
-              <a:rPr lang="en-US" sz="1100" b="1" dirty="0">
-                <a:solidFill>
-                  <a:srgbClr val="4A90D9"/>
-                </a:solidFill>
-                <a:latin typeface="Calibri" pitchFamily="34" charset="0"/>
-                <a:ea typeface="Calibri" pitchFamily="34" charset="-122"/>
-                <a:cs typeface="Calibri" pitchFamily="34" charset="-120"/>
-              </a:rPr>
-              <a:t>Key Finding: </a:t>
-            </a:r>
-            <a:r>
-              <a:rPr lang="en-US" sz="1100" dirty="0">
-                <a:solidFill>
-                  <a:srgbClr val="1E1E2E"/>
-                </a:solidFill>
-                <a:latin typeface="Calibri" pitchFamily="34" charset="0"/>
-                <a:ea typeface="Calibri" pitchFamily="34" charset="-122"/>
-                <a:cs typeface="Calibri" pitchFamily="34" charset="-120"/>
-              </a:rPr>
-              <a:t>An intermediate inertia (not minimum) gives maximum lift. This is because inertia governs pitch amplitude .</a:t>
-            </a:r>
-            <a:endParaRPr lang="en-US" sz="1100" dirty="0"/>
-          </a:p>
-        </p:txBody>
-      </p:sp>
-      <p:pic>
-        <p:nvPicPr>
-          <p:cNvPr id="21" name="Picture 20">
-            <a:extLst>
-              <a:ext uri="{FF2B5EF4-FFF2-40B4-BE49-F238E27FC236}">
-                <a16:creationId xmlns:a16="http://schemas.microsoft.com/office/drawing/2014/main" id="{EEC102B8-D1AC-8F08-C57C-C3DA8E7157F0}"/>
-              </a:ext>
-            </a:extLst>
-          </p:cNvPr>
-          <p:cNvPicPr>
-            <a:picLocks noChangeAspect="1"/>
-          </p:cNvPicPr>
-          <p:nvPr/>
-        </p:nvPicPr>
-        <p:blipFill>
-          <a:blip r:embed="rId3"/>
-          <a:stretch>
-            <a:fillRect/>
-          </a:stretch>
-        </p:blipFill>
-        <p:spPr>
-          <a:xfrm>
-            <a:off x="1737360" y="1632204"/>
-            <a:ext cx="5049442" cy="1430566"/>
-          </a:xfrm>
-          <a:prstGeom prst="rect">
-            <a:avLst/>
-          </a:prstGeom>
-        </p:spPr>
-      </p:pic>
-      <p:sp>
-        <p:nvSpPr>
-          <p:cNvPr id="22" name="TextBox 21">
-            <a:extLst>
-              <a:ext uri="{FF2B5EF4-FFF2-40B4-BE49-F238E27FC236}">
-                <a16:creationId xmlns:a16="http://schemas.microsoft.com/office/drawing/2014/main" id="{B460D6FE-FB5E-6D44-5C01-524A4FE926D9}"/>
-              </a:ext>
-            </a:extLst>
-          </p:cNvPr>
-          <p:cNvSpPr txBox="1"/>
-          <p:nvPr/>
-        </p:nvSpPr>
-        <p:spPr>
-          <a:xfrm>
-            <a:off x="3393894" y="3351860"/>
-            <a:ext cx="1736373" cy="1107996"/>
-          </a:xfrm>
-          <a:prstGeom prst="rect">
-            <a:avLst/>
-          </a:prstGeom>
-          <a:noFill/>
-        </p:spPr>
-        <p:txBody>
-          <a:bodyPr wrap="none" rtlCol="0">
-            <a:spAutoFit/>
-          </a:bodyPr>
-          <a:lstStyle/>
-          <a:p>
-            <a:r>
-              <a:rPr lang="en-IN" noProof="1">
-                <a:latin typeface="Sabon Next LT" panose="020B0502040204020203" pitchFamily="2" charset="0"/>
-                <a:cs typeface="Sabon Next LT" panose="020B0502040204020203" pitchFamily="2" charset="0"/>
-              </a:rPr>
-              <a:t>m</a:t>
-            </a:r>
-            <a:r>
-              <a:rPr lang="en-IN" sz="1200" noProof="1">
-                <a:latin typeface="Sabon Next LT" panose="020B0502040204020203" pitchFamily="2" charset="0"/>
-                <a:cs typeface="Sabon Next LT" panose="020B0502040204020203" pitchFamily="2" charset="0"/>
-              </a:rPr>
-              <a:t>spar = </a:t>
-            </a:r>
-            <a:r>
-              <a:rPr lang="en-IN" noProof="1"/>
-              <a:t>ρ *</a:t>
-            </a:r>
-            <a:r>
-              <a:rPr lang="en-IN" sz="1200" noProof="1"/>
-              <a:t> </a:t>
-            </a:r>
-            <a:r>
-              <a:rPr lang="en-IN" noProof="1"/>
-              <a:t>V</a:t>
-            </a:r>
-            <a:r>
-              <a:rPr lang="en-IN" sz="1200" noProof="1"/>
-              <a:t>spar</a:t>
-            </a:r>
-          </a:p>
-          <a:p>
-            <a:r>
-              <a:rPr lang="en-IN" noProof="1">
-                <a:latin typeface="Sabon Next LT" panose="020B0502040204020203" pitchFamily="2" charset="0"/>
-                <a:cs typeface="Sabon Next LT" panose="020B0502040204020203" pitchFamily="2" charset="0"/>
-              </a:rPr>
-              <a:t>m</a:t>
-            </a:r>
-            <a:r>
-              <a:rPr lang="en-IN" sz="1200" noProof="1">
-                <a:latin typeface="Sabon Next LT" panose="020B0502040204020203" pitchFamily="2" charset="0"/>
-                <a:cs typeface="Sabon Next LT" panose="020B0502040204020203" pitchFamily="2" charset="0"/>
-              </a:rPr>
-              <a:t>spar = </a:t>
-            </a:r>
-            <a:r>
-              <a:rPr lang="en-IN" noProof="1"/>
-              <a:t>ρ</a:t>
-            </a:r>
-            <a:r>
-              <a:rPr lang="en-IN" sz="1200" noProof="1"/>
-              <a:t> </a:t>
-            </a:r>
-            <a:r>
-              <a:rPr lang="en-IN" noProof="1"/>
-              <a:t>* L*t*W</a:t>
-            </a:r>
-          </a:p>
-          <a:p>
-            <a:r>
-              <a:rPr lang="en-IN" noProof="1"/>
-              <a:t>I = </a:t>
-            </a:r>
-            <a:r>
-              <a:rPr lang="en-IN" noProof="1">
-                <a:latin typeface="Sabon Next LT" panose="02000500000000000000" pitchFamily="2" charset="0"/>
-                <a:cs typeface="Sabon Next LT" panose="02000500000000000000" pitchFamily="2" charset="0"/>
-              </a:rPr>
-              <a:t>ʃ r^2 * dm</a:t>
-            </a:r>
-            <a:endParaRPr lang="en-IN" noProof="1"/>
-          </a:p>
-          <a:p>
-            <a:endParaRPr lang="en-IN" sz="1200" noProof="1"/>
-          </a:p>
-        </p:txBody>
       </p:sp>
     </p:spTree>
   </p:cSld>

</xml_diff>

<commit_message>
Analysis of the vertically straight and inclined stiffener by varying spar and stiffener thickness.
</commit_message>
<xml_diff>
--- a/Flapping wing design/Wing_Morphology.pptx
+++ b/Flapping wing design/Wing_Morphology.pptx
@@ -5,7 +5,7 @@
     <p:sldMasterId id="2147483676" r:id="rId1"/>
   </p:sldMasterIdLst>
   <p:notesMasterIdLst>
-    <p:notesMasterId r:id="rId34"/>
+    <p:notesMasterId r:id="rId41"/>
   </p:notesMasterIdLst>
   <p:sldIdLst>
     <p:sldId id="256" r:id="rId2"/>
@@ -34,12 +34,19 @@
     <p:sldId id="286" r:id="rId25"/>
     <p:sldId id="289" r:id="rId26"/>
     <p:sldId id="287" r:id="rId27"/>
-    <p:sldId id="288" r:id="rId28"/>
-    <p:sldId id="290" r:id="rId29"/>
-    <p:sldId id="275" r:id="rId30"/>
-    <p:sldId id="276" r:id="rId31"/>
-    <p:sldId id="279" r:id="rId32"/>
-    <p:sldId id="265" r:id="rId33"/>
+    <p:sldId id="297" r:id="rId28"/>
+    <p:sldId id="288" r:id="rId29"/>
+    <p:sldId id="290" r:id="rId30"/>
+    <p:sldId id="275" r:id="rId31"/>
+    <p:sldId id="276" r:id="rId32"/>
+    <p:sldId id="279" r:id="rId33"/>
+    <p:sldId id="291" r:id="rId34"/>
+    <p:sldId id="292" r:id="rId35"/>
+    <p:sldId id="293" r:id="rId36"/>
+    <p:sldId id="294" r:id="rId37"/>
+    <p:sldId id="295" r:id="rId38"/>
+    <p:sldId id="296" r:id="rId39"/>
+    <p:sldId id="265" r:id="rId40"/>
   </p:sldIdLst>
   <p:sldSz cx="9144000" cy="5143500" type="screen16x9"/>
   <p:notesSz cx="5143500" cy="9144000"/>
@@ -924,7 +931,7 @@
           <a:p>
             <a:fld id="{F7021451-1387-4CA6-816F-3879F97B5CBC}" type="slidenum">
               <a:rPr lang="en-US"/>
-              <a:t>32</a:t>
+              <a:t>39</a:t>
             </a:fld>
             <a:endParaRPr lang="en-US"/>
           </a:p>
@@ -8701,7 +8708,7 @@
           <p:cNvPr id="2" name="TextBox 1">
             <a:extLst>
               <a:ext uri="{FF2B5EF4-FFF2-40B4-BE49-F238E27FC236}">
-                <a16:creationId xmlns:a16="http://schemas.microsoft.com/office/drawing/2014/main" id="{C12147FA-333E-645F-5652-89052CA7A50A}"/>
+                <a16:creationId xmlns:a16="http://schemas.microsoft.com/office/drawing/2014/main" id="{7DE8E770-54D5-4856-D6FB-5310B02EBE9D}"/>
               </a:ext>
             </a:extLst>
           </p:cNvPr>
@@ -8710,8 +8717,8 @@
         </p:nvSpPr>
         <p:spPr>
           <a:xfrm>
-            <a:off x="3422005" y="215146"/>
-            <a:ext cx="2299989" cy="369332"/>
+            <a:off x="3596733" y="205740"/>
+            <a:ext cx="1950534" cy="369332"/>
           </a:xfrm>
           <a:prstGeom prst="rect">
             <a:avLst/>
@@ -8726,7 +8733,7 @@
           <a:p>
             <a:r>
               <a:rPr lang="en-IN" dirty="0"/>
-              <a:t>Spar/Stiff = 1.5/1 = 1.5</a:t>
+              <a:t>Spar/Stiff = 2/2 = 1</a:t>
             </a:r>
           </a:p>
         </p:txBody>
@@ -8736,7 +8743,7 @@
           <p:cNvPr id="4" name="Picture 3">
             <a:extLst>
               <a:ext uri="{FF2B5EF4-FFF2-40B4-BE49-F238E27FC236}">
-                <a16:creationId xmlns:a16="http://schemas.microsoft.com/office/drawing/2014/main" id="{ADE33EB0-C844-73A4-7A42-19C71AECFB75}"/>
+                <a16:creationId xmlns:a16="http://schemas.microsoft.com/office/drawing/2014/main" id="{AFF6DA01-FACA-C9C7-DB2A-AA4B5EDCBC96}"/>
               </a:ext>
             </a:extLst>
           </p:cNvPr>
@@ -8753,7 +8760,7 @@
         </p:blipFill>
         <p:spPr>
           <a:xfrm>
-            <a:off x="0" y="771525"/>
+            <a:off x="93" y="771525"/>
             <a:ext cx="9144000" cy="4371975"/>
           </a:xfrm>
           <a:prstGeom prst="rect">
@@ -8764,7 +8771,7 @@
     </p:spTree>
     <p:extLst>
       <p:ext uri="{BB962C8B-B14F-4D97-AF65-F5344CB8AC3E}">
-        <p14:creationId xmlns:p14="http://schemas.microsoft.com/office/powerpoint/2010/main" val="2709299229"/>
+        <p14:creationId xmlns:p14="http://schemas.microsoft.com/office/powerpoint/2010/main" val="1340107635"/>
       </p:ext>
     </p:extLst>
   </p:cSld>
@@ -8796,7 +8803,7 @@
           <p:cNvPr id="2" name="TextBox 1">
             <a:extLst>
               <a:ext uri="{FF2B5EF4-FFF2-40B4-BE49-F238E27FC236}">
-                <a16:creationId xmlns:a16="http://schemas.microsoft.com/office/drawing/2014/main" id="{1FDBC40C-C231-E65E-FB12-6C06D4640460}"/>
+                <a16:creationId xmlns:a16="http://schemas.microsoft.com/office/drawing/2014/main" id="{C12147FA-333E-645F-5652-89052CA7A50A}"/>
               </a:ext>
             </a:extLst>
           </p:cNvPr>
@@ -8805,8 +8812,8 @@
         </p:nvSpPr>
         <p:spPr>
           <a:xfrm>
-            <a:off x="3596733" y="213360"/>
-            <a:ext cx="1950534" cy="369332"/>
+            <a:off x="3422005" y="215146"/>
+            <a:ext cx="2299989" cy="369332"/>
           </a:xfrm>
           <a:prstGeom prst="rect">
             <a:avLst/>
@@ -8821,7 +8828,7 @@
           <a:p>
             <a:r>
               <a:rPr lang="en-IN" dirty="0"/>
-              <a:t>Spar/Stiff = 2/1 = 2</a:t>
+              <a:t>Spar/Stiff = 1.5/1 = 1.5</a:t>
             </a:r>
           </a:p>
         </p:txBody>
@@ -8831,7 +8838,7 @@
           <p:cNvPr id="4" name="Picture 3">
             <a:extLst>
               <a:ext uri="{FF2B5EF4-FFF2-40B4-BE49-F238E27FC236}">
-                <a16:creationId xmlns:a16="http://schemas.microsoft.com/office/drawing/2014/main" id="{DABC8B71-2DFE-BF1A-CD7C-629874DFD620}"/>
+                <a16:creationId xmlns:a16="http://schemas.microsoft.com/office/drawing/2014/main" id="{ADE33EB0-C844-73A4-7A42-19C71AECFB75}"/>
               </a:ext>
             </a:extLst>
           </p:cNvPr>
@@ -8859,7 +8866,7 @@
     </p:spTree>
     <p:extLst>
       <p:ext uri="{BB962C8B-B14F-4D97-AF65-F5344CB8AC3E}">
-        <p14:creationId xmlns:p14="http://schemas.microsoft.com/office/powerpoint/2010/main" val="3565455069"/>
+        <p14:creationId xmlns:p14="http://schemas.microsoft.com/office/powerpoint/2010/main" val="2709299229"/>
       </p:ext>
     </p:extLst>
   </p:cSld>
@@ -8891,7 +8898,7 @@
           <p:cNvPr id="2" name="TextBox 1">
             <a:extLst>
               <a:ext uri="{FF2B5EF4-FFF2-40B4-BE49-F238E27FC236}">
-                <a16:creationId xmlns:a16="http://schemas.microsoft.com/office/drawing/2014/main" id="{871EFC4A-D735-E347-1395-3FF14385D9D9}"/>
+                <a16:creationId xmlns:a16="http://schemas.microsoft.com/office/drawing/2014/main" id="{1FDBC40C-C231-E65E-FB12-6C06D4640460}"/>
               </a:ext>
             </a:extLst>
           </p:cNvPr>
@@ -8900,8 +8907,8 @@
         </p:nvSpPr>
         <p:spPr>
           <a:xfrm>
-            <a:off x="2306796" y="38100"/>
-            <a:ext cx="4530407" cy="461665"/>
+            <a:off x="3596733" y="213360"/>
+            <a:ext cx="1950534" cy="369332"/>
           </a:xfrm>
           <a:prstGeom prst="rect">
             <a:avLst/>
@@ -8915,18 +8922,18 @@
           <a:lstStyle/>
           <a:p>
             <a:r>
-              <a:rPr lang="en-IN" sz="2400" dirty="0"/>
-              <a:t>Vertically Inclined Carbon Stiffener</a:t>
+              <a:rPr lang="en-IN" dirty="0"/>
+              <a:t>Spar/Stiff = 2/1 = 2</a:t>
             </a:r>
           </a:p>
         </p:txBody>
       </p:sp>
       <p:pic>
         <p:nvPicPr>
-          <p:cNvPr id="6" name="Picture 5">
+          <p:cNvPr id="4" name="Picture 3">
             <a:extLst>
               <a:ext uri="{FF2B5EF4-FFF2-40B4-BE49-F238E27FC236}">
-                <a16:creationId xmlns:a16="http://schemas.microsoft.com/office/drawing/2014/main" id="{F86B8FB1-7AE3-4519-907A-34709E3D2FA9}"/>
+                <a16:creationId xmlns:a16="http://schemas.microsoft.com/office/drawing/2014/main" id="{DABC8B71-2DFE-BF1A-CD7C-629874DFD620}"/>
               </a:ext>
             </a:extLst>
           </p:cNvPr>
@@ -8943,7 +8950,7 @@
         </p:blipFill>
         <p:spPr>
           <a:xfrm>
-            <a:off x="0" y="499765"/>
+            <a:off x="0" y="771525"/>
             <a:ext cx="9144000" cy="4371975"/>
           </a:xfrm>
           <a:prstGeom prst="rect">
@@ -8954,7 +8961,7 @@
     </p:spTree>
     <p:extLst>
       <p:ext uri="{BB962C8B-B14F-4D97-AF65-F5344CB8AC3E}">
-        <p14:creationId xmlns:p14="http://schemas.microsoft.com/office/powerpoint/2010/main" val="2318864112"/>
+        <p14:creationId xmlns:p14="http://schemas.microsoft.com/office/powerpoint/2010/main" val="3565455069"/>
       </p:ext>
     </p:extLst>
   </p:cSld>
@@ -9287,6 +9294,101 @@
 </file>
 
 <file path=ppt/slides/slide30.xml><?xml version="1.0" encoding="utf-8"?>
+<p:sld xmlns:a="http://schemas.openxmlformats.org/drawingml/2006/main" xmlns:r="http://schemas.openxmlformats.org/officeDocument/2006/relationships" xmlns:p="http://schemas.openxmlformats.org/presentationml/2006/main">
+  <p:cSld>
+    <p:spTree>
+      <p:nvGrpSpPr>
+        <p:cNvPr id="1" name=""/>
+        <p:cNvGrpSpPr/>
+        <p:nvPr/>
+      </p:nvGrpSpPr>
+      <p:grpSpPr>
+        <a:xfrm>
+          <a:off x="0" y="0"/>
+          <a:ext cx="0" cy="0"/>
+          <a:chOff x="0" y="0"/>
+          <a:chExt cx="0" cy="0"/>
+        </a:xfrm>
+      </p:grpSpPr>
+      <p:sp>
+        <p:nvSpPr>
+          <p:cNvPr id="2" name="TextBox 1">
+            <a:extLst>
+              <a:ext uri="{FF2B5EF4-FFF2-40B4-BE49-F238E27FC236}">
+                <a16:creationId xmlns:a16="http://schemas.microsoft.com/office/drawing/2014/main" id="{871EFC4A-D735-E347-1395-3FF14385D9D9}"/>
+              </a:ext>
+            </a:extLst>
+          </p:cNvPr>
+          <p:cNvSpPr txBox="1"/>
+          <p:nvPr/>
+        </p:nvSpPr>
+        <p:spPr>
+          <a:xfrm>
+            <a:off x="2306796" y="38100"/>
+            <a:ext cx="4530407" cy="461665"/>
+          </a:xfrm>
+          <a:prstGeom prst="rect">
+            <a:avLst/>
+          </a:prstGeom>
+          <a:noFill/>
+        </p:spPr>
+        <p:txBody>
+          <a:bodyPr wrap="none" rtlCol="0">
+            <a:spAutoFit/>
+          </a:bodyPr>
+          <a:lstStyle/>
+          <a:p>
+            <a:r>
+              <a:rPr lang="en-IN" sz="2400" dirty="0"/>
+              <a:t>Vertically Inclined Carbon Stiffener</a:t>
+            </a:r>
+          </a:p>
+        </p:txBody>
+      </p:sp>
+      <p:pic>
+        <p:nvPicPr>
+          <p:cNvPr id="6" name="Picture 5">
+            <a:extLst>
+              <a:ext uri="{FF2B5EF4-FFF2-40B4-BE49-F238E27FC236}">
+                <a16:creationId xmlns:a16="http://schemas.microsoft.com/office/drawing/2014/main" id="{F86B8FB1-7AE3-4519-907A-34709E3D2FA9}"/>
+              </a:ext>
+            </a:extLst>
+          </p:cNvPr>
+          <p:cNvPicPr>
+            <a:picLocks noChangeAspect="1"/>
+          </p:cNvPicPr>
+          <p:nvPr/>
+        </p:nvPicPr>
+        <p:blipFill>
+          <a:blip r:embed="rId2"/>
+          <a:stretch>
+            <a:fillRect/>
+          </a:stretch>
+        </p:blipFill>
+        <p:spPr>
+          <a:xfrm>
+            <a:off x="0" y="499765"/>
+            <a:ext cx="9144000" cy="4371975"/>
+          </a:xfrm>
+          <a:prstGeom prst="rect">
+            <a:avLst/>
+          </a:prstGeom>
+        </p:spPr>
+      </p:pic>
+    </p:spTree>
+    <p:extLst>
+      <p:ext uri="{BB962C8B-B14F-4D97-AF65-F5344CB8AC3E}">
+        <p14:creationId xmlns:p14="http://schemas.microsoft.com/office/powerpoint/2010/main" val="2318864112"/>
+      </p:ext>
+    </p:extLst>
+  </p:cSld>
+  <p:clrMapOvr>
+    <a:masterClrMapping/>
+  </p:clrMapOvr>
+</p:sld>
+</file>
+
+<file path=ppt/slides/slide31.xml><?xml version="1.0" encoding="utf-8"?>
 <p:sld xmlns:a="http://schemas.openxmlformats.org/drawingml/2006/main" xmlns:r="http://schemas.openxmlformats.org/officeDocument/2006/relationships" xmlns:p="http://schemas.openxmlformats.org/presentationml/2006/main">
   <p:cSld>
     <p:spTree>
@@ -9591,13 +9693,7 @@
                                 <a:rPr lang="en-IN" sz="1400" i="0">
                                   <a:latin typeface="Cambria Math" panose="02040503050406030204" pitchFamily="18" charset="0"/>
                                 </a:rPr>
-                                <m:t>5</m:t>
-                              </m:r>
-                              <m:r>
-                                <a:rPr lang="en-IN" sz="1400" i="0">
-                                  <a:latin typeface="Cambria Math" panose="02040503050406030204" pitchFamily="18" charset="0"/>
-                                </a:rPr>
-                                <m:t>−</m:t>
+                                <m:t>5−</m:t>
                               </m:r>
                               <m:rad>
                                 <m:radPr>
@@ -9867,13 +9963,7 @@
                             <a:rPr lang="en-IN" sz="1400" i="0">
                               <a:latin typeface="Cambria Math" panose="02040503050406030204" pitchFamily="18" charset="0"/>
                             </a:rPr>
-                            <m:t>5</m:t>
-                          </m:r>
-                          <m:r>
-                            <a:rPr lang="en-IN" sz="1400" i="0">
-                              <a:latin typeface="Cambria Math" panose="02040503050406030204" pitchFamily="18" charset="0"/>
-                            </a:rPr>
-                            <m:t>−</m:t>
+                            <m:t>5−</m:t>
                           </m:r>
                           <m:rad>
                             <m:radPr>
@@ -9915,13 +10005,7 @@
                             <a:rPr lang="en-IN" sz="1400" i="0">
                               <a:latin typeface="Cambria Math" panose="02040503050406030204" pitchFamily="18" charset="0"/>
                             </a:rPr>
-                            <m:t>1</m:t>
-                          </m:r>
-                          <m:r>
-                            <a:rPr lang="en-IN" sz="1400" i="0">
-                              <a:latin typeface="Cambria Math" panose="02040503050406030204" pitchFamily="18" charset="0"/>
-                            </a:rPr>
-                            <m:t>−</m:t>
+                            <m:t>1−</m:t>
                           </m:r>
                           <m:f>
                             <m:fPr>
@@ -10133,13 +10217,7 @@
                             <a:rPr lang="en-IN" sz="1400" i="0">
                               <a:latin typeface="Cambria Math" panose="02040503050406030204" pitchFamily="18" charset="0"/>
                             </a:rPr>
-                            <m:t>5</m:t>
-                          </m:r>
-                          <m:r>
-                            <a:rPr lang="en-IN" sz="1400" i="0">
-                              <a:latin typeface="Cambria Math" panose="02040503050406030204" pitchFamily="18" charset="0"/>
-                            </a:rPr>
-                            <m:t>−</m:t>
+                            <m:t>5−</m:t>
                           </m:r>
                           <m:rad>
                             <m:radPr>
@@ -10381,13 +10459,7 @@
                             <a:rPr lang="en-IN" sz="1400" i="0">
                               <a:latin typeface="Cambria Math" panose="02040503050406030204" pitchFamily="18" charset="0"/>
                             </a:rPr>
-                            <m:t>5</m:t>
-                          </m:r>
-                          <m:r>
-                            <a:rPr lang="en-IN" sz="1400" i="0">
-                              <a:latin typeface="Cambria Math" panose="02040503050406030204" pitchFamily="18" charset="0"/>
-                            </a:rPr>
-                            <m:t>−</m:t>
+                            <m:t>5−</m:t>
                           </m:r>
                           <m:rad>
                             <m:radPr>
@@ -10568,7 +10640,7 @@
 </p:sld>
 </file>
 
-<file path=ppt/slides/slide31.xml><?xml version="1.0" encoding="utf-8"?>
+<file path=ppt/slides/slide32.xml><?xml version="1.0" encoding="utf-8"?>
 <p:sld xmlns:a="http://schemas.openxmlformats.org/drawingml/2006/main" xmlns:r="http://schemas.openxmlformats.org/officeDocument/2006/relationships" xmlns:p="http://schemas.openxmlformats.org/presentationml/2006/main">
   <p:cSld>
     <p:spTree>
@@ -10663,7 +10735,615 @@
 </p:sld>
 </file>
 
-<file path=ppt/slides/slide32.xml><?xml version="1.0" encoding="utf-8"?>
+<file path=ppt/slides/slide33.xml><?xml version="1.0" encoding="utf-8"?>
+<p:sld xmlns:a="http://schemas.openxmlformats.org/drawingml/2006/main" xmlns:r="http://schemas.openxmlformats.org/officeDocument/2006/relationships" xmlns:p="http://schemas.openxmlformats.org/presentationml/2006/main">
+  <p:cSld>
+    <p:spTree>
+      <p:nvGrpSpPr>
+        <p:cNvPr id="1" name=""/>
+        <p:cNvGrpSpPr/>
+        <p:nvPr/>
+      </p:nvGrpSpPr>
+      <p:grpSpPr>
+        <a:xfrm>
+          <a:off x="0" y="0"/>
+          <a:ext cx="0" cy="0"/>
+          <a:chOff x="0" y="0"/>
+          <a:chExt cx="0" cy="0"/>
+        </a:xfrm>
+      </p:grpSpPr>
+      <p:sp>
+        <p:nvSpPr>
+          <p:cNvPr id="2" name="TextBox 1">
+            <a:extLst>
+              <a:ext uri="{FF2B5EF4-FFF2-40B4-BE49-F238E27FC236}">
+                <a16:creationId xmlns:a16="http://schemas.microsoft.com/office/drawing/2014/main" id="{6C383EC5-8C5B-B7B8-8F9D-2CAB607FBD46}"/>
+              </a:ext>
+            </a:extLst>
+          </p:cNvPr>
+          <p:cNvSpPr txBox="1"/>
+          <p:nvPr/>
+        </p:nvSpPr>
+        <p:spPr>
+          <a:xfrm>
+            <a:off x="747459" y="30480"/>
+            <a:ext cx="7649082" cy="646331"/>
+          </a:xfrm>
+          <a:prstGeom prst="rect">
+            <a:avLst/>
+          </a:prstGeom>
+          <a:noFill/>
+        </p:spPr>
+        <p:txBody>
+          <a:bodyPr wrap="none" rtlCol="0">
+            <a:spAutoFit/>
+          </a:bodyPr>
+          <a:lstStyle/>
+          <a:p>
+            <a:r>
+              <a:rPr lang="en-IN" dirty="0"/>
+              <a:t>Analysis by varying spar/stiffener ratio in vertically straight stiffener wing profile</a:t>
+            </a:r>
+          </a:p>
+          <a:p>
+            <a:endParaRPr lang="en-IN" dirty="0"/>
+          </a:p>
+        </p:txBody>
+      </p:sp>
+      <p:sp>
+        <p:nvSpPr>
+          <p:cNvPr id="3" name="TextBox 2">
+            <a:extLst>
+              <a:ext uri="{FF2B5EF4-FFF2-40B4-BE49-F238E27FC236}">
+                <a16:creationId xmlns:a16="http://schemas.microsoft.com/office/drawing/2014/main" id="{54C5EA79-B7A9-58A3-9B06-E191B0A8334D}"/>
+              </a:ext>
+            </a:extLst>
+          </p:cNvPr>
+          <p:cNvSpPr txBox="1"/>
+          <p:nvPr/>
+        </p:nvSpPr>
+        <p:spPr>
+          <a:xfrm>
+            <a:off x="3370389" y="354836"/>
+            <a:ext cx="2403222" cy="369332"/>
+          </a:xfrm>
+          <a:prstGeom prst="rect">
+            <a:avLst/>
+          </a:prstGeom>
+          <a:noFill/>
+        </p:spPr>
+        <p:txBody>
+          <a:bodyPr wrap="none" rtlCol="0">
+            <a:spAutoFit/>
+          </a:bodyPr>
+          <a:lstStyle/>
+          <a:p>
+            <a:r>
+              <a:rPr lang="en-IN" dirty="0"/>
+              <a:t>Spar/stiff = 0.5/2 = 0.25</a:t>
+            </a:r>
+          </a:p>
+        </p:txBody>
+      </p:sp>
+      <p:pic>
+        <p:nvPicPr>
+          <p:cNvPr id="5" name="Picture 4">
+            <a:extLst>
+              <a:ext uri="{FF2B5EF4-FFF2-40B4-BE49-F238E27FC236}">
+                <a16:creationId xmlns:a16="http://schemas.microsoft.com/office/drawing/2014/main" id="{B9A2D404-212B-F877-0CBE-D598E3383B24}"/>
+              </a:ext>
+            </a:extLst>
+          </p:cNvPr>
+          <p:cNvPicPr>
+            <a:picLocks noChangeAspect="1"/>
+          </p:cNvPicPr>
+          <p:nvPr/>
+        </p:nvPicPr>
+        <p:blipFill>
+          <a:blip r:embed="rId2"/>
+          <a:stretch>
+            <a:fillRect/>
+          </a:stretch>
+        </p:blipFill>
+        <p:spPr>
+          <a:xfrm>
+            <a:off x="0" y="771525"/>
+            <a:ext cx="9144000" cy="4371975"/>
+          </a:xfrm>
+          <a:prstGeom prst="rect">
+            <a:avLst/>
+          </a:prstGeom>
+        </p:spPr>
+      </p:pic>
+    </p:spTree>
+    <p:extLst>
+      <p:ext uri="{BB962C8B-B14F-4D97-AF65-F5344CB8AC3E}">
+        <p14:creationId xmlns:p14="http://schemas.microsoft.com/office/powerpoint/2010/main" val="1016388454"/>
+      </p:ext>
+    </p:extLst>
+  </p:cSld>
+  <p:clrMapOvr>
+    <a:masterClrMapping/>
+  </p:clrMapOvr>
+</p:sld>
+</file>
+
+<file path=ppt/slides/slide34.xml><?xml version="1.0" encoding="utf-8"?>
+<p:sld xmlns:a="http://schemas.openxmlformats.org/drawingml/2006/main" xmlns:r="http://schemas.openxmlformats.org/officeDocument/2006/relationships" xmlns:p="http://schemas.openxmlformats.org/presentationml/2006/main">
+  <p:cSld>
+    <p:spTree>
+      <p:nvGrpSpPr>
+        <p:cNvPr id="1" name=""/>
+        <p:cNvGrpSpPr/>
+        <p:nvPr/>
+      </p:nvGrpSpPr>
+      <p:grpSpPr>
+        <a:xfrm>
+          <a:off x="0" y="0"/>
+          <a:ext cx="0" cy="0"/>
+          <a:chOff x="0" y="0"/>
+          <a:chExt cx="0" cy="0"/>
+        </a:xfrm>
+      </p:grpSpPr>
+      <p:sp>
+        <p:nvSpPr>
+          <p:cNvPr id="2" name="TextBox 1">
+            <a:extLst>
+              <a:ext uri="{FF2B5EF4-FFF2-40B4-BE49-F238E27FC236}">
+                <a16:creationId xmlns:a16="http://schemas.microsoft.com/office/drawing/2014/main" id="{1707F001-A679-791E-B613-B033746F2150}"/>
+              </a:ext>
+            </a:extLst>
+          </p:cNvPr>
+          <p:cNvSpPr txBox="1"/>
+          <p:nvPr/>
+        </p:nvSpPr>
+        <p:spPr>
+          <a:xfrm>
+            <a:off x="3593527" y="234434"/>
+            <a:ext cx="1956946" cy="369332"/>
+          </a:xfrm>
+          <a:prstGeom prst="rect">
+            <a:avLst/>
+          </a:prstGeom>
+          <a:noFill/>
+        </p:spPr>
+        <p:txBody>
+          <a:bodyPr wrap="none" rtlCol="0">
+            <a:spAutoFit/>
+          </a:bodyPr>
+          <a:lstStyle/>
+          <a:p>
+            <a:r>
+              <a:rPr lang="en-IN" dirty="0"/>
+              <a:t>Spar/Stiff = ½ = 0.5</a:t>
+            </a:r>
+          </a:p>
+        </p:txBody>
+      </p:sp>
+      <p:pic>
+        <p:nvPicPr>
+          <p:cNvPr id="4" name="Picture 3">
+            <a:extLst>
+              <a:ext uri="{FF2B5EF4-FFF2-40B4-BE49-F238E27FC236}">
+                <a16:creationId xmlns:a16="http://schemas.microsoft.com/office/drawing/2014/main" id="{930A4DBF-029E-0565-DD60-CEB96044FD38}"/>
+              </a:ext>
+            </a:extLst>
+          </p:cNvPr>
+          <p:cNvPicPr>
+            <a:picLocks noChangeAspect="1"/>
+          </p:cNvPicPr>
+          <p:nvPr/>
+        </p:nvPicPr>
+        <p:blipFill>
+          <a:blip r:embed="rId2"/>
+          <a:stretch>
+            <a:fillRect/>
+          </a:stretch>
+        </p:blipFill>
+        <p:spPr>
+          <a:xfrm>
+            <a:off x="0" y="771525"/>
+            <a:ext cx="9144000" cy="4371975"/>
+          </a:xfrm>
+          <a:prstGeom prst="rect">
+            <a:avLst/>
+          </a:prstGeom>
+        </p:spPr>
+      </p:pic>
+    </p:spTree>
+    <p:extLst>
+      <p:ext uri="{BB962C8B-B14F-4D97-AF65-F5344CB8AC3E}">
+        <p14:creationId xmlns:p14="http://schemas.microsoft.com/office/powerpoint/2010/main" val="3605688237"/>
+      </p:ext>
+    </p:extLst>
+  </p:cSld>
+  <p:clrMapOvr>
+    <a:masterClrMapping/>
+  </p:clrMapOvr>
+</p:sld>
+</file>
+
+<file path=ppt/slides/slide35.xml><?xml version="1.0" encoding="utf-8"?>
+<p:sld xmlns:a="http://schemas.openxmlformats.org/drawingml/2006/main" xmlns:r="http://schemas.openxmlformats.org/officeDocument/2006/relationships" xmlns:p="http://schemas.openxmlformats.org/presentationml/2006/main">
+  <p:cSld>
+    <p:spTree>
+      <p:nvGrpSpPr>
+        <p:cNvPr id="1" name=""/>
+        <p:cNvGrpSpPr/>
+        <p:nvPr/>
+      </p:nvGrpSpPr>
+      <p:grpSpPr>
+        <a:xfrm>
+          <a:off x="0" y="0"/>
+          <a:ext cx="0" cy="0"/>
+          <a:chOff x="0" y="0"/>
+          <a:chExt cx="0" cy="0"/>
+        </a:xfrm>
+      </p:grpSpPr>
+      <p:sp>
+        <p:nvSpPr>
+          <p:cNvPr id="2" name="TextBox 1">
+            <a:extLst>
+              <a:ext uri="{FF2B5EF4-FFF2-40B4-BE49-F238E27FC236}">
+                <a16:creationId xmlns:a16="http://schemas.microsoft.com/office/drawing/2014/main" id="{D1674708-D2C6-F241-23DF-E8BA33F059CF}"/>
+              </a:ext>
+            </a:extLst>
+          </p:cNvPr>
+          <p:cNvSpPr txBox="1"/>
+          <p:nvPr/>
+        </p:nvSpPr>
+        <p:spPr>
+          <a:xfrm>
+            <a:off x="3595610" y="228600"/>
+            <a:ext cx="1952779" cy="369332"/>
+          </a:xfrm>
+          <a:prstGeom prst="rect">
+            <a:avLst/>
+          </a:prstGeom>
+          <a:noFill/>
+        </p:spPr>
+        <p:txBody>
+          <a:bodyPr wrap="none" rtlCol="0">
+            <a:spAutoFit/>
+          </a:bodyPr>
+          <a:lstStyle/>
+          <a:p>
+            <a:r>
+              <a:rPr lang="en-IN" dirty="0"/>
+              <a:t>Spar/Stiff = 1/1 = 1</a:t>
+            </a:r>
+          </a:p>
+        </p:txBody>
+      </p:sp>
+      <p:pic>
+        <p:nvPicPr>
+          <p:cNvPr id="4" name="Picture 3">
+            <a:extLst>
+              <a:ext uri="{FF2B5EF4-FFF2-40B4-BE49-F238E27FC236}">
+                <a16:creationId xmlns:a16="http://schemas.microsoft.com/office/drawing/2014/main" id="{9EE7FAF1-51DB-7F31-3CCF-9A8A0C5616AD}"/>
+              </a:ext>
+            </a:extLst>
+          </p:cNvPr>
+          <p:cNvPicPr>
+            <a:picLocks noChangeAspect="1"/>
+          </p:cNvPicPr>
+          <p:nvPr/>
+        </p:nvPicPr>
+        <p:blipFill>
+          <a:blip r:embed="rId2"/>
+          <a:stretch>
+            <a:fillRect/>
+          </a:stretch>
+        </p:blipFill>
+        <p:spPr>
+          <a:xfrm>
+            <a:off x="-1" y="771525"/>
+            <a:ext cx="9144000" cy="4371975"/>
+          </a:xfrm>
+          <a:prstGeom prst="rect">
+            <a:avLst/>
+          </a:prstGeom>
+        </p:spPr>
+      </p:pic>
+    </p:spTree>
+    <p:extLst>
+      <p:ext uri="{BB962C8B-B14F-4D97-AF65-F5344CB8AC3E}">
+        <p14:creationId xmlns:p14="http://schemas.microsoft.com/office/powerpoint/2010/main" val="2083210682"/>
+      </p:ext>
+    </p:extLst>
+  </p:cSld>
+  <p:clrMapOvr>
+    <a:masterClrMapping/>
+  </p:clrMapOvr>
+</p:sld>
+</file>
+
+<file path=ppt/slides/slide36.xml><?xml version="1.0" encoding="utf-8"?>
+<p:sld xmlns:a="http://schemas.openxmlformats.org/drawingml/2006/main" xmlns:r="http://schemas.openxmlformats.org/officeDocument/2006/relationships" xmlns:p="http://schemas.openxmlformats.org/presentationml/2006/main">
+  <p:cSld>
+    <p:spTree>
+      <p:nvGrpSpPr>
+        <p:cNvPr id="1" name=""/>
+        <p:cNvGrpSpPr/>
+        <p:nvPr/>
+      </p:nvGrpSpPr>
+      <p:grpSpPr>
+        <a:xfrm>
+          <a:off x="0" y="0"/>
+          <a:ext cx="0" cy="0"/>
+          <a:chOff x="0" y="0"/>
+          <a:chExt cx="0" cy="0"/>
+        </a:xfrm>
+      </p:grpSpPr>
+      <p:sp>
+        <p:nvSpPr>
+          <p:cNvPr id="2" name="TextBox 1">
+            <a:extLst>
+              <a:ext uri="{FF2B5EF4-FFF2-40B4-BE49-F238E27FC236}">
+                <a16:creationId xmlns:a16="http://schemas.microsoft.com/office/drawing/2014/main" id="{8A972498-1C1E-B281-2E66-5F15FA629192}"/>
+              </a:ext>
+            </a:extLst>
+          </p:cNvPr>
+          <p:cNvSpPr txBox="1"/>
+          <p:nvPr/>
+        </p:nvSpPr>
+        <p:spPr>
+          <a:xfrm>
+            <a:off x="3422005" y="211574"/>
+            <a:ext cx="2299989" cy="369332"/>
+          </a:xfrm>
+          <a:prstGeom prst="rect">
+            <a:avLst/>
+          </a:prstGeom>
+          <a:noFill/>
+        </p:spPr>
+        <p:txBody>
+          <a:bodyPr wrap="none" rtlCol="0">
+            <a:spAutoFit/>
+          </a:bodyPr>
+          <a:lstStyle/>
+          <a:p>
+            <a:r>
+              <a:rPr lang="en-IN" dirty="0"/>
+              <a:t>Spar/Stiff = 1.5/1 = 1.5</a:t>
+            </a:r>
+          </a:p>
+        </p:txBody>
+      </p:sp>
+      <p:pic>
+        <p:nvPicPr>
+          <p:cNvPr id="4" name="Picture 3">
+            <a:extLst>
+              <a:ext uri="{FF2B5EF4-FFF2-40B4-BE49-F238E27FC236}">
+                <a16:creationId xmlns:a16="http://schemas.microsoft.com/office/drawing/2014/main" id="{62C4B573-E9A6-FD80-E457-564AAB3CA2B6}"/>
+              </a:ext>
+            </a:extLst>
+          </p:cNvPr>
+          <p:cNvPicPr>
+            <a:picLocks noChangeAspect="1"/>
+          </p:cNvPicPr>
+          <p:nvPr/>
+        </p:nvPicPr>
+        <p:blipFill>
+          <a:blip r:embed="rId2"/>
+          <a:stretch>
+            <a:fillRect/>
+          </a:stretch>
+        </p:blipFill>
+        <p:spPr>
+          <a:xfrm>
+            <a:off x="-1" y="771525"/>
+            <a:ext cx="9144000" cy="4371975"/>
+          </a:xfrm>
+          <a:prstGeom prst="rect">
+            <a:avLst/>
+          </a:prstGeom>
+        </p:spPr>
+      </p:pic>
+    </p:spTree>
+    <p:extLst>
+      <p:ext uri="{BB962C8B-B14F-4D97-AF65-F5344CB8AC3E}">
+        <p14:creationId xmlns:p14="http://schemas.microsoft.com/office/powerpoint/2010/main" val="1939349474"/>
+      </p:ext>
+    </p:extLst>
+  </p:cSld>
+  <p:clrMapOvr>
+    <a:masterClrMapping/>
+  </p:clrMapOvr>
+</p:sld>
+</file>
+
+<file path=ppt/slides/slide37.xml><?xml version="1.0" encoding="utf-8"?>
+<p:sld xmlns:a="http://schemas.openxmlformats.org/drawingml/2006/main" xmlns:r="http://schemas.openxmlformats.org/officeDocument/2006/relationships" xmlns:p="http://schemas.openxmlformats.org/presentationml/2006/main">
+  <p:cSld>
+    <p:spTree>
+      <p:nvGrpSpPr>
+        <p:cNvPr id="1" name=""/>
+        <p:cNvGrpSpPr/>
+        <p:nvPr/>
+      </p:nvGrpSpPr>
+      <p:grpSpPr>
+        <a:xfrm>
+          <a:off x="0" y="0"/>
+          <a:ext cx="0" cy="0"/>
+          <a:chOff x="0" y="0"/>
+          <a:chExt cx="0" cy="0"/>
+        </a:xfrm>
+      </p:grpSpPr>
+      <p:sp>
+        <p:nvSpPr>
+          <p:cNvPr id="2" name="TextBox 1">
+            <a:extLst>
+              <a:ext uri="{FF2B5EF4-FFF2-40B4-BE49-F238E27FC236}">
+                <a16:creationId xmlns:a16="http://schemas.microsoft.com/office/drawing/2014/main" id="{FBE976FC-ED6F-CE78-FFE7-FA01E61D7493}"/>
+              </a:ext>
+            </a:extLst>
+          </p:cNvPr>
+          <p:cNvSpPr txBox="1"/>
+          <p:nvPr/>
+        </p:nvSpPr>
+        <p:spPr>
+          <a:xfrm>
+            <a:off x="3596733" y="213360"/>
+            <a:ext cx="1950534" cy="369332"/>
+          </a:xfrm>
+          <a:prstGeom prst="rect">
+            <a:avLst/>
+          </a:prstGeom>
+          <a:noFill/>
+        </p:spPr>
+        <p:txBody>
+          <a:bodyPr wrap="none" rtlCol="0">
+            <a:spAutoFit/>
+          </a:bodyPr>
+          <a:lstStyle/>
+          <a:p>
+            <a:r>
+              <a:rPr lang="en-IN" dirty="0"/>
+              <a:t>Spar/Stiff = 2/1 = 2</a:t>
+            </a:r>
+          </a:p>
+        </p:txBody>
+      </p:sp>
+      <p:pic>
+        <p:nvPicPr>
+          <p:cNvPr id="4" name="Picture 3">
+            <a:extLst>
+              <a:ext uri="{FF2B5EF4-FFF2-40B4-BE49-F238E27FC236}">
+                <a16:creationId xmlns:a16="http://schemas.microsoft.com/office/drawing/2014/main" id="{0C0051CC-72FF-A003-4AD6-81A4F227A385}"/>
+              </a:ext>
+            </a:extLst>
+          </p:cNvPr>
+          <p:cNvPicPr>
+            <a:picLocks noChangeAspect="1"/>
+          </p:cNvPicPr>
+          <p:nvPr/>
+        </p:nvPicPr>
+        <p:blipFill>
+          <a:blip r:embed="rId2"/>
+          <a:stretch>
+            <a:fillRect/>
+          </a:stretch>
+        </p:blipFill>
+        <p:spPr>
+          <a:xfrm>
+            <a:off x="0" y="771525"/>
+            <a:ext cx="9144000" cy="4371975"/>
+          </a:xfrm>
+          <a:prstGeom prst="rect">
+            <a:avLst/>
+          </a:prstGeom>
+        </p:spPr>
+      </p:pic>
+    </p:spTree>
+    <p:extLst>
+      <p:ext uri="{BB962C8B-B14F-4D97-AF65-F5344CB8AC3E}">
+        <p14:creationId xmlns:p14="http://schemas.microsoft.com/office/powerpoint/2010/main" val="4106364435"/>
+      </p:ext>
+    </p:extLst>
+  </p:cSld>
+  <p:clrMapOvr>
+    <a:masterClrMapping/>
+  </p:clrMapOvr>
+</p:sld>
+</file>
+
+<file path=ppt/slides/slide38.xml><?xml version="1.0" encoding="utf-8"?>
+<p:sld xmlns:a="http://schemas.openxmlformats.org/drawingml/2006/main" xmlns:r="http://schemas.openxmlformats.org/officeDocument/2006/relationships" xmlns:p="http://schemas.openxmlformats.org/presentationml/2006/main">
+  <p:cSld>
+    <p:spTree>
+      <p:nvGrpSpPr>
+        <p:cNvPr id="1" name=""/>
+        <p:cNvGrpSpPr/>
+        <p:nvPr/>
+      </p:nvGrpSpPr>
+      <p:grpSpPr>
+        <a:xfrm>
+          <a:off x="0" y="0"/>
+          <a:ext cx="0" cy="0"/>
+          <a:chOff x="0" y="0"/>
+          <a:chExt cx="0" cy="0"/>
+        </a:xfrm>
+      </p:grpSpPr>
+      <p:pic>
+        <p:nvPicPr>
+          <p:cNvPr id="3" name="Picture 2">
+            <a:extLst>
+              <a:ext uri="{FF2B5EF4-FFF2-40B4-BE49-F238E27FC236}">
+                <a16:creationId xmlns:a16="http://schemas.microsoft.com/office/drawing/2014/main" id="{7B350E51-F962-32FB-8349-52B4210987BC}"/>
+              </a:ext>
+            </a:extLst>
+          </p:cNvPr>
+          <p:cNvPicPr>
+            <a:picLocks noChangeAspect="1"/>
+          </p:cNvPicPr>
+          <p:nvPr/>
+        </p:nvPicPr>
+        <p:blipFill>
+          <a:blip r:embed="rId2"/>
+          <a:stretch>
+            <a:fillRect/>
+          </a:stretch>
+        </p:blipFill>
+        <p:spPr>
+          <a:xfrm>
+            <a:off x="0" y="771525"/>
+            <a:ext cx="9144000" cy="4371975"/>
+          </a:xfrm>
+          <a:prstGeom prst="rect">
+            <a:avLst/>
+          </a:prstGeom>
+        </p:spPr>
+      </p:pic>
+      <p:sp>
+        <p:nvSpPr>
+          <p:cNvPr id="4" name="TextBox 3">
+            <a:extLst>
+              <a:ext uri="{FF2B5EF4-FFF2-40B4-BE49-F238E27FC236}">
+                <a16:creationId xmlns:a16="http://schemas.microsoft.com/office/drawing/2014/main" id="{CDB1C4DB-B0AE-DF10-894A-83A15DE2B7A4}"/>
+              </a:ext>
+            </a:extLst>
+          </p:cNvPr>
+          <p:cNvSpPr txBox="1"/>
+          <p:nvPr/>
+        </p:nvSpPr>
+        <p:spPr>
+          <a:xfrm>
+            <a:off x="3596733" y="295394"/>
+            <a:ext cx="1950534" cy="369332"/>
+          </a:xfrm>
+          <a:prstGeom prst="rect">
+            <a:avLst/>
+          </a:prstGeom>
+          <a:noFill/>
+        </p:spPr>
+        <p:txBody>
+          <a:bodyPr wrap="none" rtlCol="0">
+            <a:spAutoFit/>
+          </a:bodyPr>
+          <a:lstStyle/>
+          <a:p>
+            <a:r>
+              <a:rPr lang="en-IN" dirty="0"/>
+              <a:t>Spar/Stiff = 2/2 = 1</a:t>
+            </a:r>
+          </a:p>
+        </p:txBody>
+      </p:sp>
+    </p:spTree>
+    <p:extLst>
+      <p:ext uri="{BB962C8B-B14F-4D97-AF65-F5344CB8AC3E}">
+        <p14:creationId xmlns:p14="http://schemas.microsoft.com/office/powerpoint/2010/main" val="25370330"/>
+      </p:ext>
+    </p:extLst>
+  </p:cSld>
+  <p:clrMapOvr>
+    <a:masterClrMapping/>
+  </p:clrMapOvr>
+</p:sld>
+</file>
+
+<file path=ppt/slides/slide39.xml><?xml version="1.0" encoding="utf-8"?>
 <p:sld xmlns:a="http://schemas.openxmlformats.org/drawingml/2006/main" xmlns:r="http://schemas.openxmlformats.org/officeDocument/2006/relationships" xmlns:p="http://schemas.openxmlformats.org/presentationml/2006/main">
   <p:cSld name="Slide 10">
     <p:bg>

</xml_diff>

<commit_message>
Fixing the dimension calculation in type B strip in case of inclined strip.
</commit_message>
<xml_diff>
--- a/Flapping wing design/Wing_Morphology.pptx
+++ b/Flapping wing design/Wing_Morphology.pptx
@@ -1081,7 +1081,7 @@
           <a:p>
             <a:fld id="{C764DE79-268F-4C1A-8933-263129D2AF90}" type="datetimeFigureOut">
               <a:rPr lang="en-US" smtClean="0"/>
-              <a:t>7/2/2026</a:t>
+              <a:t>7/3/2026</a:t>
             </a:fld>
             <a:endParaRPr lang="en-US" dirty="0"/>
           </a:p>
@@ -1252,7 +1252,7 @@
           <a:p>
             <a:fld id="{C764DE79-268F-4C1A-8933-263129D2AF90}" type="datetimeFigureOut">
               <a:rPr lang="en-US" smtClean="0"/>
-              <a:t>7/2/2026</a:t>
+              <a:t>7/3/2026</a:t>
             </a:fld>
             <a:endParaRPr lang="en-US" dirty="0"/>
           </a:p>
@@ -1433,7 +1433,7 @@
           <a:p>
             <a:fld id="{C764DE79-268F-4C1A-8933-263129D2AF90}" type="datetimeFigureOut">
               <a:rPr lang="en-US" smtClean="0"/>
-              <a:t>7/2/2026</a:t>
+              <a:t>7/3/2026</a:t>
             </a:fld>
             <a:endParaRPr lang="en-US" dirty="0"/>
           </a:p>
@@ -1639,7 +1639,7 @@
           <a:p>
             <a:fld id="{C764DE79-268F-4C1A-8933-263129D2AF90}" type="datetimeFigureOut">
               <a:rPr lang="en-US" smtClean="0"/>
-              <a:t>7/2/2026</a:t>
+              <a:t>7/3/2026</a:t>
             </a:fld>
             <a:endParaRPr lang="en-US" dirty="0"/>
           </a:p>
@@ -1886,7 +1886,7 @@
           <a:p>
             <a:fld id="{C764DE79-268F-4C1A-8933-263129D2AF90}" type="datetimeFigureOut">
               <a:rPr lang="en-US" smtClean="0"/>
-              <a:t>7/2/2026</a:t>
+              <a:t>7/3/2026</a:t>
             </a:fld>
             <a:endParaRPr lang="en-US" dirty="0"/>
           </a:p>
@@ -2119,7 +2119,7 @@
           <a:p>
             <a:fld id="{C764DE79-268F-4C1A-8933-263129D2AF90}" type="datetimeFigureOut">
               <a:rPr lang="en-US" smtClean="0"/>
-              <a:t>7/2/2026</a:t>
+              <a:t>7/3/2026</a:t>
             </a:fld>
             <a:endParaRPr lang="en-US" dirty="0"/>
           </a:p>
@@ -2487,7 +2487,7 @@
           <a:p>
             <a:fld id="{C764DE79-268F-4C1A-8933-263129D2AF90}" type="datetimeFigureOut">
               <a:rPr lang="en-US" smtClean="0"/>
-              <a:t>7/2/2026</a:t>
+              <a:t>7/3/2026</a:t>
             </a:fld>
             <a:endParaRPr lang="en-US" dirty="0"/>
           </a:p>
@@ -2606,7 +2606,7 @@
           <a:p>
             <a:fld id="{C764DE79-268F-4C1A-8933-263129D2AF90}" type="datetimeFigureOut">
               <a:rPr lang="en-US" smtClean="0"/>
-              <a:t>7/2/2026</a:t>
+              <a:t>7/3/2026</a:t>
             </a:fld>
             <a:endParaRPr lang="en-US" dirty="0"/>
           </a:p>
@@ -2702,7 +2702,7 @@
           <a:p>
             <a:fld id="{C764DE79-268F-4C1A-8933-263129D2AF90}" type="datetimeFigureOut">
               <a:rPr lang="en-US" smtClean="0"/>
-              <a:t>7/2/2026</a:t>
+              <a:t>7/3/2026</a:t>
             </a:fld>
             <a:endParaRPr lang="en-US" dirty="0"/>
           </a:p>
@@ -2980,7 +2980,7 @@
           <a:p>
             <a:fld id="{C764DE79-268F-4C1A-8933-263129D2AF90}" type="datetimeFigureOut">
               <a:rPr lang="en-US" smtClean="0"/>
-              <a:t>7/2/2026</a:t>
+              <a:t>7/3/2026</a:t>
             </a:fld>
             <a:endParaRPr lang="en-US" dirty="0"/>
           </a:p>
@@ -3238,7 +3238,7 @@
           <a:p>
             <a:fld id="{C764DE79-268F-4C1A-8933-263129D2AF90}" type="datetimeFigureOut">
               <a:rPr lang="en-US" smtClean="0"/>
-              <a:t>7/2/2026</a:t>
+              <a:t>7/3/2026</a:t>
             </a:fld>
             <a:endParaRPr lang="en-US" dirty="0"/>
           </a:p>
@@ -3452,7 +3452,7 @@
           <a:p>
             <a:fld id="{C764DE79-268F-4C1A-8933-263129D2AF90}" type="datetimeFigureOut">
               <a:rPr lang="en-US" smtClean="0"/>
-              <a:t>7/2/2026</a:t>
+              <a:t>7/3/2026</a:t>
             </a:fld>
             <a:endParaRPr lang="en-US" dirty="0"/>
           </a:p>
@@ -7665,7 +7665,25 @@
                         <a:rPr lang="en-IN" i="0">
                           <a:latin typeface="Cambria Math" panose="02040503050406030204" pitchFamily="18" charset="0"/>
                         </a:rPr>
-                        <m:t>=1.6</m:t>
+                        <m:t>=</m:t>
+                      </m:r>
+                      <m:r>
+                        <a:rPr lang="en-IN" i="0">
+                          <a:latin typeface="Cambria Math" panose="02040503050406030204" pitchFamily="18" charset="0"/>
+                        </a:rPr>
+                        <m:t>1</m:t>
+                      </m:r>
+                      <m:r>
+                        <a:rPr lang="en-IN" i="0">
+                          <a:latin typeface="Cambria Math" panose="02040503050406030204" pitchFamily="18" charset="0"/>
+                        </a:rPr>
+                        <m:t>.</m:t>
+                      </m:r>
+                      <m:r>
+                        <a:rPr lang="en-IN" i="0">
+                          <a:latin typeface="Cambria Math" panose="02040503050406030204" pitchFamily="18" charset="0"/>
+                        </a:rPr>
+                        <m:t>6</m:t>
                       </m:r>
                     </m:oMath>
                   </m:oMathPara>
@@ -7786,7 +7804,25 @@
                         <a:rPr lang="en-IN" i="0">
                           <a:latin typeface="Cambria Math" panose="02040503050406030204" pitchFamily="18" charset="0"/>
                         </a:rPr>
-                        <m:t>=1.3</m:t>
+                        <m:t>=</m:t>
+                      </m:r>
+                      <m:r>
+                        <a:rPr lang="en-IN" i="0">
+                          <a:latin typeface="Cambria Math" panose="02040503050406030204" pitchFamily="18" charset="0"/>
+                        </a:rPr>
+                        <m:t>1</m:t>
+                      </m:r>
+                      <m:r>
+                        <a:rPr lang="en-IN" i="0">
+                          <a:latin typeface="Cambria Math" panose="02040503050406030204" pitchFamily="18" charset="0"/>
+                        </a:rPr>
+                        <m:t>.</m:t>
+                      </m:r>
+                      <m:r>
+                        <a:rPr lang="en-IN" i="0">
+                          <a:latin typeface="Cambria Math" panose="02040503050406030204" pitchFamily="18" charset="0"/>
+                        </a:rPr>
+                        <m:t>3</m:t>
                       </m:r>
                     </m:oMath>
                   </m:oMathPara>
@@ -7907,7 +7943,25 @@
                         <a:rPr lang="en-IN" i="0">
                           <a:latin typeface="Cambria Math" panose="02040503050406030204" pitchFamily="18" charset="0"/>
                         </a:rPr>
-                        <m:t>=0.5</m:t>
+                        <m:t>=</m:t>
+                      </m:r>
+                      <m:r>
+                        <a:rPr lang="en-IN" i="0">
+                          <a:latin typeface="Cambria Math" panose="02040503050406030204" pitchFamily="18" charset="0"/>
+                        </a:rPr>
+                        <m:t>0</m:t>
+                      </m:r>
+                      <m:r>
+                        <a:rPr lang="en-IN" i="0">
+                          <a:latin typeface="Cambria Math" panose="02040503050406030204" pitchFamily="18" charset="0"/>
+                        </a:rPr>
+                        <m:t>.</m:t>
+                      </m:r>
+                      <m:r>
+                        <a:rPr lang="en-IN" i="0">
+                          <a:latin typeface="Cambria Math" panose="02040503050406030204" pitchFamily="18" charset="0"/>
+                        </a:rPr>
+                        <m:t>5</m:t>
                       </m:r>
                       <m:r>
                         <a:rPr lang="en-IN" i="1">
@@ -8046,7 +8100,13 @@
                         <a:rPr lang="en-IN" i="0">
                           <a:latin typeface="Cambria Math" panose="02040503050406030204" pitchFamily="18" charset="0"/>
                         </a:rPr>
-                        <m:t>.05</m:t>
+                        <m:t>.</m:t>
+                      </m:r>
+                      <m:r>
+                        <a:rPr lang="en-IN" i="0">
+                          <a:latin typeface="Cambria Math" panose="02040503050406030204" pitchFamily="18" charset="0"/>
+                        </a:rPr>
+                        <m:t>05</m:t>
                       </m:r>
                       <m:r>
                         <a:rPr lang="en-IN" i="1">
@@ -8154,7 +8214,13 @@
                         <a:rPr lang="en-IN" i="0" smtClean="0">
                           <a:latin typeface="Cambria Math" panose="02040503050406030204" pitchFamily="18" charset="0"/>
                         </a:rPr>
-                        <m:t>=5</m:t>
+                        <m:t>=</m:t>
+                      </m:r>
+                      <m:r>
+                        <a:rPr lang="en-IN" i="0" smtClean="0">
+                          <a:latin typeface="Cambria Math" panose="02040503050406030204" pitchFamily="18" charset="0"/>
+                        </a:rPr>
+                        <m:t>5</m:t>
                       </m:r>
                       <m:r>
                         <a:rPr lang="en-IN" i="1" smtClean="0">
@@ -8197,7 +8263,13 @@
                         <a:rPr lang="en-IN" i="0">
                           <a:latin typeface="Cambria Math" panose="02040503050406030204" pitchFamily="18" charset="0"/>
                         </a:rPr>
-                        <m:t>=8</m:t>
+                        <m:t>=</m:t>
+                      </m:r>
+                      <m:r>
+                        <a:rPr lang="en-IN" i="0">
+                          <a:latin typeface="Cambria Math" panose="02040503050406030204" pitchFamily="18" charset="0"/>
+                        </a:rPr>
+                        <m:t>8</m:t>
                       </m:r>
                       <m:r>
                         <a:rPr lang="en-IN" i="1">
@@ -10827,10 +10899,10 @@
       </p:sp>
       <p:pic>
         <p:nvPicPr>
-          <p:cNvPr id="5" name="Picture 4">
+          <p:cNvPr id="6" name="Picture 5">
             <a:extLst>
               <a:ext uri="{FF2B5EF4-FFF2-40B4-BE49-F238E27FC236}">
-                <a16:creationId xmlns:a16="http://schemas.microsoft.com/office/drawing/2014/main" id="{B9A2D404-212B-F877-0CBE-D598E3383B24}"/>
+                <a16:creationId xmlns:a16="http://schemas.microsoft.com/office/drawing/2014/main" id="{1F9A02E0-62DF-CB52-ED47-72C6DE7421AB}"/>
               </a:ext>
             </a:extLst>
           </p:cNvPr>
@@ -10922,10 +10994,10 @@
       </p:sp>
       <p:pic>
         <p:nvPicPr>
-          <p:cNvPr id="4" name="Picture 3">
+          <p:cNvPr id="7" name="Picture 6">
             <a:extLst>
               <a:ext uri="{FF2B5EF4-FFF2-40B4-BE49-F238E27FC236}">
-                <a16:creationId xmlns:a16="http://schemas.microsoft.com/office/drawing/2014/main" id="{930A4DBF-029E-0565-DD60-CEB96044FD38}"/>
+                <a16:creationId xmlns:a16="http://schemas.microsoft.com/office/drawing/2014/main" id="{B9E9C636-B669-A693-939E-14F72FA303FC}"/>
               </a:ext>
             </a:extLst>
           </p:cNvPr>
@@ -11017,10 +11089,10 @@
       </p:sp>
       <p:pic>
         <p:nvPicPr>
-          <p:cNvPr id="4" name="Picture 3">
+          <p:cNvPr id="5" name="Picture 4">
             <a:extLst>
               <a:ext uri="{FF2B5EF4-FFF2-40B4-BE49-F238E27FC236}">
-                <a16:creationId xmlns:a16="http://schemas.microsoft.com/office/drawing/2014/main" id="{9EE7FAF1-51DB-7F31-3CCF-9A8A0C5616AD}"/>
+                <a16:creationId xmlns:a16="http://schemas.microsoft.com/office/drawing/2014/main" id="{0C8421C6-E392-E2FE-F7B7-69797BD55350}"/>
               </a:ext>
             </a:extLst>
           </p:cNvPr>
@@ -11112,10 +11184,10 @@
       </p:sp>
       <p:pic>
         <p:nvPicPr>
-          <p:cNvPr id="4" name="Picture 3">
+          <p:cNvPr id="5" name="Picture 4">
             <a:extLst>
               <a:ext uri="{FF2B5EF4-FFF2-40B4-BE49-F238E27FC236}">
-                <a16:creationId xmlns:a16="http://schemas.microsoft.com/office/drawing/2014/main" id="{62C4B573-E9A6-FD80-E457-564AAB3CA2B6}"/>
+                <a16:creationId xmlns:a16="http://schemas.microsoft.com/office/drawing/2014/main" id="{C0F7C834-1E0D-840D-D578-604482060450}"/>
               </a:ext>
             </a:extLst>
           </p:cNvPr>
@@ -11207,10 +11279,10 @@
       </p:sp>
       <p:pic>
         <p:nvPicPr>
-          <p:cNvPr id="4" name="Picture 3">
+          <p:cNvPr id="5" name="Picture 4">
             <a:extLst>
               <a:ext uri="{FF2B5EF4-FFF2-40B4-BE49-F238E27FC236}">
-                <a16:creationId xmlns:a16="http://schemas.microsoft.com/office/drawing/2014/main" id="{0C0051CC-72FF-A003-4AD6-81A4F227A385}"/>
+                <a16:creationId xmlns:a16="http://schemas.microsoft.com/office/drawing/2014/main" id="{99B0C6E8-4F5B-3522-0403-1860955D7676}"/>
               </a:ext>
             </a:extLst>
           </p:cNvPr>
@@ -11265,36 +11337,6 @@
           <a:chExt cx="0" cy="0"/>
         </a:xfrm>
       </p:grpSpPr>
-      <p:pic>
-        <p:nvPicPr>
-          <p:cNvPr id="3" name="Picture 2">
-            <a:extLst>
-              <a:ext uri="{FF2B5EF4-FFF2-40B4-BE49-F238E27FC236}">
-                <a16:creationId xmlns:a16="http://schemas.microsoft.com/office/drawing/2014/main" id="{7B350E51-F962-32FB-8349-52B4210987BC}"/>
-              </a:ext>
-            </a:extLst>
-          </p:cNvPr>
-          <p:cNvPicPr>
-            <a:picLocks noChangeAspect="1"/>
-          </p:cNvPicPr>
-          <p:nvPr/>
-        </p:nvPicPr>
-        <p:blipFill>
-          <a:blip r:embed="rId2"/>
-          <a:stretch>
-            <a:fillRect/>
-          </a:stretch>
-        </p:blipFill>
-        <p:spPr>
-          <a:xfrm>
-            <a:off x="0" y="771525"/>
-            <a:ext cx="9144000" cy="4371975"/>
-          </a:xfrm>
-          <a:prstGeom prst="rect">
-            <a:avLst/>
-          </a:prstGeom>
-        </p:spPr>
-      </p:pic>
       <p:sp>
         <p:nvSpPr>
           <p:cNvPr id="4" name="TextBox 3">
@@ -11330,6 +11372,36 @@
           </a:p>
         </p:txBody>
       </p:sp>
+      <p:pic>
+        <p:nvPicPr>
+          <p:cNvPr id="5" name="Picture 4">
+            <a:extLst>
+              <a:ext uri="{FF2B5EF4-FFF2-40B4-BE49-F238E27FC236}">
+                <a16:creationId xmlns:a16="http://schemas.microsoft.com/office/drawing/2014/main" id="{0B58608C-E447-FBB3-F3D6-2CCA446CCCAD}"/>
+              </a:ext>
+            </a:extLst>
+          </p:cNvPr>
+          <p:cNvPicPr>
+            <a:picLocks noChangeAspect="1"/>
+          </p:cNvPicPr>
+          <p:nvPr/>
+        </p:nvPicPr>
+        <p:blipFill>
+          <a:blip r:embed="rId2"/>
+          <a:stretch>
+            <a:fillRect/>
+          </a:stretch>
+        </p:blipFill>
+        <p:spPr>
+          <a:xfrm>
+            <a:off x="0" y="771525"/>
+            <a:ext cx="9144000" cy="4371975"/>
+          </a:xfrm>
+          <a:prstGeom prst="rect">
+            <a:avLst/>
+          </a:prstGeom>
+        </p:spPr>
+      </p:pic>
     </p:spTree>
     <p:extLst>
       <p:ext uri="{BB962C8B-B14F-4D97-AF65-F5344CB8AC3E}">

</xml_diff>

<commit_message>
Plots of descritized study of the type B inclined stiffener.
</commit_message>
<xml_diff>
--- a/Flapping wing design/Wing_Morphology.pptx
+++ b/Flapping wing design/Wing_Morphology.pptx
@@ -5,7 +5,7 @@
     <p:sldMasterId id="2147483676" r:id="rId1"/>
   </p:sldMasterIdLst>
   <p:notesMasterIdLst>
-    <p:notesMasterId r:id="rId41"/>
+    <p:notesMasterId r:id="rId47"/>
   </p:notesMasterIdLst>
   <p:sldIdLst>
     <p:sldId id="256" r:id="rId2"/>
@@ -34,9 +34,9 @@
     <p:sldId id="286" r:id="rId25"/>
     <p:sldId id="289" r:id="rId26"/>
     <p:sldId id="287" r:id="rId27"/>
-    <p:sldId id="297" r:id="rId28"/>
-    <p:sldId id="288" r:id="rId29"/>
-    <p:sldId id="290" r:id="rId30"/>
+    <p:sldId id="288" r:id="rId28"/>
+    <p:sldId id="290" r:id="rId29"/>
+    <p:sldId id="297" r:id="rId30"/>
     <p:sldId id="275" r:id="rId31"/>
     <p:sldId id="276" r:id="rId32"/>
     <p:sldId id="279" r:id="rId33"/>
@@ -46,7 +46,13 @@
     <p:sldId id="294" r:id="rId37"/>
     <p:sldId id="295" r:id="rId38"/>
     <p:sldId id="296" r:id="rId39"/>
-    <p:sldId id="265" r:id="rId40"/>
+    <p:sldId id="298" r:id="rId40"/>
+    <p:sldId id="299" r:id="rId41"/>
+    <p:sldId id="300" r:id="rId42"/>
+    <p:sldId id="301" r:id="rId43"/>
+    <p:sldId id="302" r:id="rId44"/>
+    <p:sldId id="303" r:id="rId45"/>
+    <p:sldId id="265" r:id="rId46"/>
   </p:sldIdLst>
   <p:sldSz cx="9144000" cy="5143500" type="screen16x9"/>
   <p:notesSz cx="5143500" cy="9144000"/>
@@ -931,7 +937,7 @@
           <a:p>
             <a:fld id="{F7021451-1387-4CA6-816F-3879F97B5CBC}" type="slidenum">
               <a:rPr lang="en-US"/>
-              <a:t>39</a:t>
+              <a:t>45</a:t>
             </a:fld>
             <a:endParaRPr lang="en-US"/>
           </a:p>
@@ -1081,7 +1087,7 @@
           <a:p>
             <a:fld id="{C764DE79-268F-4C1A-8933-263129D2AF90}" type="datetimeFigureOut">
               <a:rPr lang="en-US" smtClean="0"/>
-              <a:t>7/3/2026</a:t>
+              <a:t>7/6/2026</a:t>
             </a:fld>
             <a:endParaRPr lang="en-US" dirty="0"/>
           </a:p>
@@ -1252,7 +1258,7 @@
           <a:p>
             <a:fld id="{C764DE79-268F-4C1A-8933-263129D2AF90}" type="datetimeFigureOut">
               <a:rPr lang="en-US" smtClean="0"/>
-              <a:t>7/3/2026</a:t>
+              <a:t>7/6/2026</a:t>
             </a:fld>
             <a:endParaRPr lang="en-US" dirty="0"/>
           </a:p>
@@ -1433,7 +1439,7 @@
           <a:p>
             <a:fld id="{C764DE79-268F-4C1A-8933-263129D2AF90}" type="datetimeFigureOut">
               <a:rPr lang="en-US" smtClean="0"/>
-              <a:t>7/3/2026</a:t>
+              <a:t>7/6/2026</a:t>
             </a:fld>
             <a:endParaRPr lang="en-US" dirty="0"/>
           </a:p>
@@ -1639,7 +1645,7 @@
           <a:p>
             <a:fld id="{C764DE79-268F-4C1A-8933-263129D2AF90}" type="datetimeFigureOut">
               <a:rPr lang="en-US" smtClean="0"/>
-              <a:t>7/3/2026</a:t>
+              <a:t>7/6/2026</a:t>
             </a:fld>
             <a:endParaRPr lang="en-US" dirty="0"/>
           </a:p>
@@ -1886,7 +1892,7 @@
           <a:p>
             <a:fld id="{C764DE79-268F-4C1A-8933-263129D2AF90}" type="datetimeFigureOut">
               <a:rPr lang="en-US" smtClean="0"/>
-              <a:t>7/3/2026</a:t>
+              <a:t>7/6/2026</a:t>
             </a:fld>
             <a:endParaRPr lang="en-US" dirty="0"/>
           </a:p>
@@ -2119,7 +2125,7 @@
           <a:p>
             <a:fld id="{C764DE79-268F-4C1A-8933-263129D2AF90}" type="datetimeFigureOut">
               <a:rPr lang="en-US" smtClean="0"/>
-              <a:t>7/3/2026</a:t>
+              <a:t>7/6/2026</a:t>
             </a:fld>
             <a:endParaRPr lang="en-US" dirty="0"/>
           </a:p>
@@ -2487,7 +2493,7 @@
           <a:p>
             <a:fld id="{C764DE79-268F-4C1A-8933-263129D2AF90}" type="datetimeFigureOut">
               <a:rPr lang="en-US" smtClean="0"/>
-              <a:t>7/3/2026</a:t>
+              <a:t>7/6/2026</a:t>
             </a:fld>
             <a:endParaRPr lang="en-US" dirty="0"/>
           </a:p>
@@ -2606,7 +2612,7 @@
           <a:p>
             <a:fld id="{C764DE79-268F-4C1A-8933-263129D2AF90}" type="datetimeFigureOut">
               <a:rPr lang="en-US" smtClean="0"/>
-              <a:t>7/3/2026</a:t>
+              <a:t>7/6/2026</a:t>
             </a:fld>
             <a:endParaRPr lang="en-US" dirty="0"/>
           </a:p>
@@ -2702,7 +2708,7 @@
           <a:p>
             <a:fld id="{C764DE79-268F-4C1A-8933-263129D2AF90}" type="datetimeFigureOut">
               <a:rPr lang="en-US" smtClean="0"/>
-              <a:t>7/3/2026</a:t>
+              <a:t>7/6/2026</a:t>
             </a:fld>
             <a:endParaRPr lang="en-US" dirty="0"/>
           </a:p>
@@ -2980,7 +2986,7 @@
           <a:p>
             <a:fld id="{C764DE79-268F-4C1A-8933-263129D2AF90}" type="datetimeFigureOut">
               <a:rPr lang="en-US" smtClean="0"/>
-              <a:t>7/3/2026</a:t>
+              <a:t>7/6/2026</a:t>
             </a:fld>
             <a:endParaRPr lang="en-US" dirty="0"/>
           </a:p>
@@ -3238,7 +3244,7 @@
           <a:p>
             <a:fld id="{C764DE79-268F-4C1A-8933-263129D2AF90}" type="datetimeFigureOut">
               <a:rPr lang="en-US" smtClean="0"/>
-              <a:t>7/3/2026</a:t>
+              <a:t>7/6/2026</a:t>
             </a:fld>
             <a:endParaRPr lang="en-US" dirty="0"/>
           </a:p>
@@ -3452,7 +3458,7 @@
           <a:p>
             <a:fld id="{C764DE79-268F-4C1A-8933-263129D2AF90}" type="datetimeFigureOut">
               <a:rPr lang="en-US" smtClean="0"/>
-              <a:t>7/3/2026</a:t>
+              <a:t>7/6/2026</a:t>
             </a:fld>
             <a:endParaRPr lang="en-US" dirty="0"/>
           </a:p>
@@ -7665,25 +7671,7 @@
                         <a:rPr lang="en-IN" i="0">
                           <a:latin typeface="Cambria Math" panose="02040503050406030204" pitchFamily="18" charset="0"/>
                         </a:rPr>
-                        <m:t>=</m:t>
-                      </m:r>
-                      <m:r>
-                        <a:rPr lang="en-IN" i="0">
-                          <a:latin typeface="Cambria Math" panose="02040503050406030204" pitchFamily="18" charset="0"/>
-                        </a:rPr>
-                        <m:t>1</m:t>
-                      </m:r>
-                      <m:r>
-                        <a:rPr lang="en-IN" i="0">
-                          <a:latin typeface="Cambria Math" panose="02040503050406030204" pitchFamily="18" charset="0"/>
-                        </a:rPr>
-                        <m:t>.</m:t>
-                      </m:r>
-                      <m:r>
-                        <a:rPr lang="en-IN" i="0">
-                          <a:latin typeface="Cambria Math" panose="02040503050406030204" pitchFamily="18" charset="0"/>
-                        </a:rPr>
-                        <m:t>6</m:t>
+                        <m:t>=1.6</m:t>
                       </m:r>
                     </m:oMath>
                   </m:oMathPara>
@@ -7804,25 +7792,7 @@
                         <a:rPr lang="en-IN" i="0">
                           <a:latin typeface="Cambria Math" panose="02040503050406030204" pitchFamily="18" charset="0"/>
                         </a:rPr>
-                        <m:t>=</m:t>
-                      </m:r>
-                      <m:r>
-                        <a:rPr lang="en-IN" i="0">
-                          <a:latin typeface="Cambria Math" panose="02040503050406030204" pitchFamily="18" charset="0"/>
-                        </a:rPr>
-                        <m:t>1</m:t>
-                      </m:r>
-                      <m:r>
-                        <a:rPr lang="en-IN" i="0">
-                          <a:latin typeface="Cambria Math" panose="02040503050406030204" pitchFamily="18" charset="0"/>
-                        </a:rPr>
-                        <m:t>.</m:t>
-                      </m:r>
-                      <m:r>
-                        <a:rPr lang="en-IN" i="0">
-                          <a:latin typeface="Cambria Math" panose="02040503050406030204" pitchFamily="18" charset="0"/>
-                        </a:rPr>
-                        <m:t>3</m:t>
+                        <m:t>=1.3</m:t>
                       </m:r>
                     </m:oMath>
                   </m:oMathPara>
@@ -7943,25 +7913,7 @@
                         <a:rPr lang="en-IN" i="0">
                           <a:latin typeface="Cambria Math" panose="02040503050406030204" pitchFamily="18" charset="0"/>
                         </a:rPr>
-                        <m:t>=</m:t>
-                      </m:r>
-                      <m:r>
-                        <a:rPr lang="en-IN" i="0">
-                          <a:latin typeface="Cambria Math" panose="02040503050406030204" pitchFamily="18" charset="0"/>
-                        </a:rPr>
-                        <m:t>0</m:t>
-                      </m:r>
-                      <m:r>
-                        <a:rPr lang="en-IN" i="0">
-                          <a:latin typeface="Cambria Math" panose="02040503050406030204" pitchFamily="18" charset="0"/>
-                        </a:rPr>
-                        <m:t>.</m:t>
-                      </m:r>
-                      <m:r>
-                        <a:rPr lang="en-IN" i="0">
-                          <a:latin typeface="Cambria Math" panose="02040503050406030204" pitchFamily="18" charset="0"/>
-                        </a:rPr>
-                        <m:t>5</m:t>
+                        <m:t>=0.5</m:t>
                       </m:r>
                       <m:r>
                         <a:rPr lang="en-IN" i="1">
@@ -8100,13 +8052,7 @@
                         <a:rPr lang="en-IN" i="0">
                           <a:latin typeface="Cambria Math" panose="02040503050406030204" pitchFamily="18" charset="0"/>
                         </a:rPr>
-                        <m:t>.</m:t>
-                      </m:r>
-                      <m:r>
-                        <a:rPr lang="en-IN" i="0">
-                          <a:latin typeface="Cambria Math" panose="02040503050406030204" pitchFamily="18" charset="0"/>
-                        </a:rPr>
-                        <m:t>05</m:t>
+                        <m:t>.05</m:t>
                       </m:r>
                       <m:r>
                         <a:rPr lang="en-IN" i="1">
@@ -8214,13 +8160,7 @@
                         <a:rPr lang="en-IN" i="0" smtClean="0">
                           <a:latin typeface="Cambria Math" panose="02040503050406030204" pitchFamily="18" charset="0"/>
                         </a:rPr>
-                        <m:t>=</m:t>
-                      </m:r>
-                      <m:r>
-                        <a:rPr lang="en-IN" i="0" smtClean="0">
-                          <a:latin typeface="Cambria Math" panose="02040503050406030204" pitchFamily="18" charset="0"/>
-                        </a:rPr>
-                        <m:t>5</m:t>
+                        <m:t>=5</m:t>
                       </m:r>
                       <m:r>
                         <a:rPr lang="en-IN" i="1" smtClean="0">
@@ -8263,13 +8203,7 @@
                         <a:rPr lang="en-IN" i="0">
                           <a:latin typeface="Cambria Math" panose="02040503050406030204" pitchFamily="18" charset="0"/>
                         </a:rPr>
-                        <m:t>=</m:t>
-                      </m:r>
-                      <m:r>
-                        <a:rPr lang="en-IN" i="0">
-                          <a:latin typeface="Cambria Math" panose="02040503050406030204" pitchFamily="18" charset="0"/>
-                        </a:rPr>
-                        <m:t>8</m:t>
+                        <m:t>=8</m:t>
                       </m:r>
                       <m:r>
                         <a:rPr lang="en-IN" i="1">
@@ -8780,7 +8714,7 @@
           <p:cNvPr id="2" name="TextBox 1">
             <a:extLst>
               <a:ext uri="{FF2B5EF4-FFF2-40B4-BE49-F238E27FC236}">
-                <a16:creationId xmlns:a16="http://schemas.microsoft.com/office/drawing/2014/main" id="{7DE8E770-54D5-4856-D6FB-5310B02EBE9D}"/>
+                <a16:creationId xmlns:a16="http://schemas.microsoft.com/office/drawing/2014/main" id="{C12147FA-333E-645F-5652-89052CA7A50A}"/>
               </a:ext>
             </a:extLst>
           </p:cNvPr>
@@ -8789,8 +8723,8 @@
         </p:nvSpPr>
         <p:spPr>
           <a:xfrm>
-            <a:off x="3596733" y="205740"/>
-            <a:ext cx="1950534" cy="369332"/>
+            <a:off x="3422005" y="215146"/>
+            <a:ext cx="2299989" cy="369332"/>
           </a:xfrm>
           <a:prstGeom prst="rect">
             <a:avLst/>
@@ -8805,7 +8739,7 @@
           <a:p>
             <a:r>
               <a:rPr lang="en-IN" dirty="0"/>
-              <a:t>Spar/Stiff = 2/2 = 1</a:t>
+              <a:t>Spar/Stiff = 1.5/1 = 1.5</a:t>
             </a:r>
           </a:p>
         </p:txBody>
@@ -8815,7 +8749,7 @@
           <p:cNvPr id="4" name="Picture 3">
             <a:extLst>
               <a:ext uri="{FF2B5EF4-FFF2-40B4-BE49-F238E27FC236}">
-                <a16:creationId xmlns:a16="http://schemas.microsoft.com/office/drawing/2014/main" id="{AFF6DA01-FACA-C9C7-DB2A-AA4B5EDCBC96}"/>
+                <a16:creationId xmlns:a16="http://schemas.microsoft.com/office/drawing/2014/main" id="{ADE33EB0-C844-73A4-7A42-19C71AECFB75}"/>
               </a:ext>
             </a:extLst>
           </p:cNvPr>
@@ -8832,7 +8766,7 @@
         </p:blipFill>
         <p:spPr>
           <a:xfrm>
-            <a:off x="93" y="771525"/>
+            <a:off x="0" y="771525"/>
             <a:ext cx="9144000" cy="4371975"/>
           </a:xfrm>
           <a:prstGeom prst="rect">
@@ -8843,7 +8777,7 @@
     </p:spTree>
     <p:extLst>
       <p:ext uri="{BB962C8B-B14F-4D97-AF65-F5344CB8AC3E}">
-        <p14:creationId xmlns:p14="http://schemas.microsoft.com/office/powerpoint/2010/main" val="1340107635"/>
+        <p14:creationId xmlns:p14="http://schemas.microsoft.com/office/powerpoint/2010/main" val="2709299229"/>
       </p:ext>
     </p:extLst>
   </p:cSld>
@@ -8875,7 +8809,7 @@
           <p:cNvPr id="2" name="TextBox 1">
             <a:extLst>
               <a:ext uri="{FF2B5EF4-FFF2-40B4-BE49-F238E27FC236}">
-                <a16:creationId xmlns:a16="http://schemas.microsoft.com/office/drawing/2014/main" id="{C12147FA-333E-645F-5652-89052CA7A50A}"/>
+                <a16:creationId xmlns:a16="http://schemas.microsoft.com/office/drawing/2014/main" id="{1FDBC40C-C231-E65E-FB12-6C06D4640460}"/>
               </a:ext>
             </a:extLst>
           </p:cNvPr>
@@ -8884,8 +8818,8 @@
         </p:nvSpPr>
         <p:spPr>
           <a:xfrm>
-            <a:off x="3422005" y="215146"/>
-            <a:ext cx="2299989" cy="369332"/>
+            <a:off x="3596733" y="213360"/>
+            <a:ext cx="1950534" cy="369332"/>
           </a:xfrm>
           <a:prstGeom prst="rect">
             <a:avLst/>
@@ -8900,7 +8834,7 @@
           <a:p>
             <a:r>
               <a:rPr lang="en-IN" dirty="0"/>
-              <a:t>Spar/Stiff = 1.5/1 = 1.5</a:t>
+              <a:t>Spar/Stiff = 2/1 = 2</a:t>
             </a:r>
           </a:p>
         </p:txBody>
@@ -8910,7 +8844,7 @@
           <p:cNvPr id="4" name="Picture 3">
             <a:extLst>
               <a:ext uri="{FF2B5EF4-FFF2-40B4-BE49-F238E27FC236}">
-                <a16:creationId xmlns:a16="http://schemas.microsoft.com/office/drawing/2014/main" id="{ADE33EB0-C844-73A4-7A42-19C71AECFB75}"/>
+                <a16:creationId xmlns:a16="http://schemas.microsoft.com/office/drawing/2014/main" id="{DABC8B71-2DFE-BF1A-CD7C-629874DFD620}"/>
               </a:ext>
             </a:extLst>
           </p:cNvPr>
@@ -8938,7 +8872,7 @@
     </p:spTree>
     <p:extLst>
       <p:ext uri="{BB962C8B-B14F-4D97-AF65-F5344CB8AC3E}">
-        <p14:creationId xmlns:p14="http://schemas.microsoft.com/office/powerpoint/2010/main" val="2709299229"/>
+        <p14:creationId xmlns:p14="http://schemas.microsoft.com/office/powerpoint/2010/main" val="3565455069"/>
       </p:ext>
     </p:extLst>
   </p:cSld>
@@ -8970,7 +8904,7 @@
           <p:cNvPr id="2" name="TextBox 1">
             <a:extLst>
               <a:ext uri="{FF2B5EF4-FFF2-40B4-BE49-F238E27FC236}">
-                <a16:creationId xmlns:a16="http://schemas.microsoft.com/office/drawing/2014/main" id="{1FDBC40C-C231-E65E-FB12-6C06D4640460}"/>
+                <a16:creationId xmlns:a16="http://schemas.microsoft.com/office/drawing/2014/main" id="{7DE8E770-54D5-4856-D6FB-5310B02EBE9D}"/>
               </a:ext>
             </a:extLst>
           </p:cNvPr>
@@ -8979,7 +8913,7 @@
         </p:nvSpPr>
         <p:spPr>
           <a:xfrm>
-            <a:off x="3596733" y="213360"/>
+            <a:off x="3596733" y="205740"/>
             <a:ext cx="1950534" cy="369332"/>
           </a:xfrm>
           <a:prstGeom prst="rect">
@@ -8995,7 +8929,7 @@
           <a:p>
             <a:r>
               <a:rPr lang="en-IN" dirty="0"/>
-              <a:t>Spar/Stiff = 2/1 = 2</a:t>
+              <a:t>Spar/Stiff = 2/2 = 1</a:t>
             </a:r>
           </a:p>
         </p:txBody>
@@ -9005,7 +8939,7 @@
           <p:cNvPr id="4" name="Picture 3">
             <a:extLst>
               <a:ext uri="{FF2B5EF4-FFF2-40B4-BE49-F238E27FC236}">
-                <a16:creationId xmlns:a16="http://schemas.microsoft.com/office/drawing/2014/main" id="{DABC8B71-2DFE-BF1A-CD7C-629874DFD620}"/>
+                <a16:creationId xmlns:a16="http://schemas.microsoft.com/office/drawing/2014/main" id="{AFF6DA01-FACA-C9C7-DB2A-AA4B5EDCBC96}"/>
               </a:ext>
             </a:extLst>
           </p:cNvPr>
@@ -9022,7 +8956,7 @@
         </p:blipFill>
         <p:spPr>
           <a:xfrm>
-            <a:off x="0" y="771525"/>
+            <a:off x="93" y="771525"/>
             <a:ext cx="9144000" cy="4371975"/>
           </a:xfrm>
           <a:prstGeom prst="rect">
@@ -9033,7 +8967,7 @@
     </p:spTree>
     <p:extLst>
       <p:ext uri="{BB962C8B-B14F-4D97-AF65-F5344CB8AC3E}">
-        <p14:creationId xmlns:p14="http://schemas.microsoft.com/office/powerpoint/2010/main" val="3565455069"/>
+        <p14:creationId xmlns:p14="http://schemas.microsoft.com/office/powerpoint/2010/main" val="1340107635"/>
       </p:ext>
     </p:extLst>
   </p:cSld>
@@ -11417,15 +11351,7 @@
 
 <file path=ppt/slides/slide39.xml><?xml version="1.0" encoding="utf-8"?>
 <p:sld xmlns:a="http://schemas.openxmlformats.org/drawingml/2006/main" xmlns:r="http://schemas.openxmlformats.org/officeDocument/2006/relationships" xmlns:p="http://schemas.openxmlformats.org/presentationml/2006/main">
-  <p:cSld name="Slide 10">
-    <p:bg>
-      <p:bgPr>
-        <a:solidFill>
-          <a:srgbClr val="1E1E2E"/>
-        </a:solidFill>
-        <a:effectLst/>
-      </p:bgPr>
-    </p:bg>
+  <p:cSld>
     <p:spTree>
       <p:nvGrpSpPr>
         <p:cNvPr id="1" name=""/>
@@ -11442,260 +11368,110 @@
       </p:grpSpPr>
       <p:sp>
         <p:nvSpPr>
-          <p:cNvPr id="2" name="Shape 0"/>
-          <p:cNvSpPr/>
-          <p:nvPr/>
-        </p:nvSpPr>
-        <p:spPr>
-          <a:xfrm>
-            <a:off x="0" y="0"/>
-            <a:ext cx="9144000" cy="54864"/>
-          </a:xfrm>
-          <a:prstGeom prst="rect">
-            <a:avLst/>
-          </a:prstGeom>
-          <a:solidFill>
-            <a:srgbClr val="4A90D9"/>
-          </a:solidFill>
-          <a:ln w="12700">
-            <a:solidFill>
-              <a:srgbClr val="4A90D9"/>
-            </a:solidFill>
-            <a:prstDash val="solid"/>
-          </a:ln>
-        </p:spPr>
-      </p:sp>
-      <p:sp>
-        <p:nvSpPr>
-          <p:cNvPr id="3" name="Text 1"/>
-          <p:cNvSpPr/>
-          <p:nvPr/>
-        </p:nvSpPr>
-        <p:spPr>
-          <a:xfrm>
-            <a:off x="548640" y="1371600"/>
-            <a:ext cx="8046720" cy="1005840"/>
+          <p:cNvPr id="2" name="TextBox 1">
+            <a:extLst>
+              <a:ext uri="{FF2B5EF4-FFF2-40B4-BE49-F238E27FC236}">
+                <a16:creationId xmlns:a16="http://schemas.microsoft.com/office/drawing/2014/main" id="{C29D7E4F-4A36-FAE1-2F06-F7A2B4F66E14}"/>
+              </a:ext>
+            </a:extLst>
+          </p:cNvPr>
+          <p:cNvSpPr txBox="1"/>
+          <p:nvPr/>
+        </p:nvSpPr>
+        <p:spPr>
+          <a:xfrm>
+            <a:off x="1167061" y="76200"/>
+            <a:ext cx="6809878" cy="369332"/>
           </a:xfrm>
           <a:prstGeom prst="rect">
             <a:avLst/>
           </a:prstGeom>
           <a:noFill/>
-          <a:ln/>
-        </p:spPr>
-        <p:txBody>
-          <a:bodyPr wrap="square" rtlCol="0" anchor="ctr"/>
-          <a:lstStyle/>
-          <a:p>
-            <a:pPr marL="0" indent="0" algn="ctr">
-              <a:buNone/>
-            </a:pPr>
-            <a:r>
-              <a:rPr lang="en-US" sz="5200" b="1" dirty="0">
-                <a:solidFill>
-                  <a:srgbClr val="FFFFFF"/>
-                </a:solidFill>
-                <a:latin typeface="Calibri" pitchFamily="34" charset="0"/>
-                <a:ea typeface="Calibri" pitchFamily="34" charset="-122"/>
-                <a:cs typeface="Calibri" pitchFamily="34" charset="-120"/>
-              </a:rPr>
-              <a:t>Thank You</a:t>
-            </a:r>
-            <a:endParaRPr lang="en-US" sz="5200" dirty="0"/>
-          </a:p>
-        </p:txBody>
-      </p:sp>
-      <p:sp>
-        <p:nvSpPr>
-          <p:cNvPr id="4" name="Text 2"/>
-          <p:cNvSpPr/>
-          <p:nvPr/>
-        </p:nvSpPr>
-        <p:spPr>
-          <a:xfrm>
-            <a:off x="548640" y="2377440"/>
-            <a:ext cx="8046720" cy="411480"/>
+        </p:spPr>
+        <p:txBody>
+          <a:bodyPr wrap="none" rtlCol="0">
+            <a:spAutoFit/>
+          </a:bodyPr>
+          <a:lstStyle/>
+          <a:p>
+            <a:r>
+              <a:rPr lang="en-IN" dirty="0"/>
+              <a:t>Study of Inclined rectangular strip by dividing into 10 rectangular strip</a:t>
+            </a:r>
+          </a:p>
+        </p:txBody>
+      </p:sp>
+      <p:pic>
+        <p:nvPicPr>
+          <p:cNvPr id="6" name="Picture 5">
+            <a:extLst>
+              <a:ext uri="{FF2B5EF4-FFF2-40B4-BE49-F238E27FC236}">
+                <a16:creationId xmlns:a16="http://schemas.microsoft.com/office/drawing/2014/main" id="{950C1BE3-8FB8-AE22-0FF0-D4FDA8B03393}"/>
+              </a:ext>
+            </a:extLst>
+          </p:cNvPr>
+          <p:cNvPicPr>
+            <a:picLocks noChangeAspect="1"/>
+          </p:cNvPicPr>
+          <p:nvPr/>
+        </p:nvPicPr>
+        <p:blipFill>
+          <a:blip r:embed="rId2"/>
+          <a:stretch>
+            <a:fillRect/>
+          </a:stretch>
+        </p:blipFill>
+        <p:spPr>
+          <a:xfrm>
+            <a:off x="0" y="771525"/>
+            <a:ext cx="9144000" cy="4371975"/>
+          </a:xfrm>
+          <a:prstGeom prst="rect">
+            <a:avLst/>
+          </a:prstGeom>
+        </p:spPr>
+      </p:pic>
+      <p:sp>
+        <p:nvSpPr>
+          <p:cNvPr id="7" name="TextBox 6">
+            <a:extLst>
+              <a:ext uri="{FF2B5EF4-FFF2-40B4-BE49-F238E27FC236}">
+                <a16:creationId xmlns:a16="http://schemas.microsoft.com/office/drawing/2014/main" id="{6D800BFB-9B25-F766-F577-E46F54FA6AE6}"/>
+              </a:ext>
+            </a:extLst>
+          </p:cNvPr>
+          <p:cNvSpPr txBox="1"/>
+          <p:nvPr/>
+        </p:nvSpPr>
+        <p:spPr>
+          <a:xfrm>
+            <a:off x="3275010" y="402193"/>
+            <a:ext cx="2593980" cy="369332"/>
           </a:xfrm>
           <a:prstGeom prst="rect">
             <a:avLst/>
           </a:prstGeom>
           <a:noFill/>
-          <a:ln/>
-        </p:spPr>
-        <p:txBody>
-          <a:bodyPr wrap="square" rtlCol="0" anchor="ctr"/>
-          <a:lstStyle/>
-          <a:p>
-            <a:pPr marL="0" indent="0" algn="ctr">
-              <a:buNone/>
-            </a:pPr>
-            <a:r>
-              <a:rPr lang="en-US" sz="1600" dirty="0">
-                <a:solidFill>
-                  <a:srgbClr val="9CA3AF"/>
-                </a:solidFill>
-                <a:latin typeface="Calibri" pitchFamily="34" charset="0"/>
-                <a:ea typeface="Calibri" pitchFamily="34" charset="-122"/>
-                <a:cs typeface="Calibri" pitchFamily="34" charset="-120"/>
-              </a:rPr>
-              <a:t>for your time and attention</a:t>
-            </a:r>
-            <a:endParaRPr lang="en-US" sz="1600" dirty="0"/>
-          </a:p>
-        </p:txBody>
-      </p:sp>
-      <p:sp>
-        <p:nvSpPr>
-          <p:cNvPr id="5" name="Shape 3"/>
-          <p:cNvSpPr/>
-          <p:nvPr/>
-        </p:nvSpPr>
-        <p:spPr>
-          <a:xfrm>
-            <a:off x="3200400" y="2971800"/>
-            <a:ext cx="2743200" cy="36576"/>
-          </a:xfrm>
-          <a:prstGeom prst="rect">
-            <a:avLst/>
-          </a:prstGeom>
-          <a:solidFill>
-            <a:srgbClr val="4A90D9"/>
-          </a:solidFill>
-          <a:ln w="12700">
-            <a:solidFill>
-              <a:srgbClr val="4A90D9"/>
-            </a:solidFill>
-            <a:prstDash val="solid"/>
-          </a:ln>
-        </p:spPr>
-      </p:sp>
-      <p:sp>
-        <p:nvSpPr>
-          <p:cNvPr id="6" name="Text 4"/>
-          <p:cNvSpPr/>
-          <p:nvPr/>
-        </p:nvSpPr>
-        <p:spPr>
-          <a:xfrm>
-            <a:off x="548640" y="3200400"/>
-            <a:ext cx="8046720" cy="822960"/>
-          </a:xfrm>
-          <a:prstGeom prst="rect">
-            <a:avLst/>
-          </a:prstGeom>
-          <a:noFill/>
-          <a:ln/>
-        </p:spPr>
-        <p:txBody>
-          <a:bodyPr wrap="square" rtlCol="0" anchor="ctr"/>
-          <a:lstStyle/>
-          <a:p>
-            <a:pPr marL="0" indent="0" algn="ctr">
-              <a:buNone/>
-            </a:pPr>
-            <a:r>
-              <a:rPr lang="en-US" sz="1200" b="1" dirty="0">
-                <a:solidFill>
-                  <a:srgbClr val="D1D5DB"/>
-                </a:solidFill>
-                <a:latin typeface="Calibri" pitchFamily="34" charset="0"/>
-                <a:ea typeface="Calibri" pitchFamily="34" charset="-122"/>
-                <a:cs typeface="Calibri" pitchFamily="34" charset="-120"/>
-              </a:rPr>
-              <a:t>Anoop Patel  |  Intern
-</a:t>
-            </a:r>
-            <a:r>
-              <a:rPr lang="en-US" sz="1200" dirty="0">
-                <a:solidFill>
-                  <a:srgbClr val="D1D5DB"/>
-                </a:solidFill>
-                <a:latin typeface="Calibri" pitchFamily="34" charset="0"/>
-                <a:ea typeface="Calibri" pitchFamily="34" charset="-122"/>
-                <a:cs typeface="Calibri" pitchFamily="34" charset="-120"/>
-              </a:rPr>
-              <a:t>Mechanical Engineering, NIT Sikkim
-</a:t>
-            </a:r>
-            <a:r>
-              <a:rPr lang="en-US" sz="1200" dirty="0">
-                <a:solidFill>
-                  <a:srgbClr val="9CA3AF"/>
-                </a:solidFill>
-                <a:latin typeface="Calibri" pitchFamily="34" charset="0"/>
-                <a:ea typeface="Calibri" pitchFamily="34" charset="-122"/>
-                <a:cs typeface="Calibri" pitchFamily="34" charset="-120"/>
-              </a:rPr>
-              <a:t>Guide: Dr Sai Sidhardh</a:t>
-            </a:r>
-            <a:endParaRPr lang="en-US" sz="1200" dirty="0"/>
-          </a:p>
-        </p:txBody>
-      </p:sp>
-      <p:sp>
-        <p:nvSpPr>
-          <p:cNvPr id="7" name="Text 5"/>
-          <p:cNvSpPr/>
-          <p:nvPr/>
-        </p:nvSpPr>
-        <p:spPr>
-          <a:xfrm>
-            <a:off x="548640" y="4297680"/>
-            <a:ext cx="8046720" cy="320040"/>
-          </a:xfrm>
-          <a:prstGeom prst="rect">
-            <a:avLst/>
-          </a:prstGeom>
-          <a:noFill/>
-          <a:ln/>
-        </p:spPr>
-        <p:txBody>
-          <a:bodyPr wrap="square" rtlCol="0" anchor="ctr"/>
-          <a:lstStyle/>
-          <a:p>
-            <a:pPr marL="0" indent="0" algn="ctr">
-              <a:buNone/>
-            </a:pPr>
-            <a:r>
-              <a:rPr lang="en-US" sz="1100" dirty="0">
-                <a:solidFill>
-                  <a:srgbClr val="6B7280"/>
-                </a:solidFill>
-                <a:latin typeface="Calibri" pitchFamily="34" charset="0"/>
-                <a:ea typeface="Calibri" pitchFamily="34" charset="-122"/>
-                <a:cs typeface="Calibri" pitchFamily="34" charset="-120"/>
-              </a:rPr>
-              <a:t>Reference: Y. Chen, PhD Thesis — Harvard University, 2017</a:t>
-            </a:r>
-            <a:endParaRPr lang="en-US" sz="1100" dirty="0"/>
-          </a:p>
-        </p:txBody>
-      </p:sp>
-      <p:sp>
-        <p:nvSpPr>
-          <p:cNvPr id="8" name="Shape 6"/>
-          <p:cNvSpPr/>
-          <p:nvPr/>
-        </p:nvSpPr>
-        <p:spPr>
-          <a:xfrm>
-            <a:off x="0" y="5088636"/>
-            <a:ext cx="9144000" cy="54864"/>
-          </a:xfrm>
-          <a:prstGeom prst="rect">
-            <a:avLst/>
-          </a:prstGeom>
-          <a:solidFill>
-            <a:srgbClr val="4A90D9"/>
-          </a:solidFill>
-          <a:ln w="12700">
-            <a:solidFill>
-              <a:srgbClr val="4A90D9"/>
-            </a:solidFill>
-            <a:prstDash val="solid"/>
-          </a:ln>
-        </p:spPr>
+        </p:spPr>
+        <p:txBody>
+          <a:bodyPr wrap="none" rtlCol="0">
+            <a:spAutoFit/>
+          </a:bodyPr>
+          <a:lstStyle/>
+          <a:p>
+            <a:r>
+              <a:rPr lang="en-IN" dirty="0"/>
+              <a:t>Spar/Stiff = 0.5/2.0 = 0.25</a:t>
+            </a:r>
+          </a:p>
+        </p:txBody>
       </p:sp>
     </p:spTree>
+    <p:extLst>
+      <p:ext uri="{BB962C8B-B14F-4D97-AF65-F5344CB8AC3E}">
+        <p14:creationId xmlns:p14="http://schemas.microsoft.com/office/powerpoint/2010/main" val="342943244"/>
+      </p:ext>
+    </p:extLst>
   </p:cSld>
   <p:clrMapOvr>
     <a:masterClrMapping/>
@@ -11890,6 +11666,769 @@
         <p14:creationId xmlns:p14="http://schemas.microsoft.com/office/powerpoint/2010/main" val="299747332"/>
       </p:ext>
     </p:extLst>
+  </p:cSld>
+  <p:clrMapOvr>
+    <a:masterClrMapping/>
+  </p:clrMapOvr>
+</p:sld>
+</file>
+
+<file path=ppt/slides/slide40.xml><?xml version="1.0" encoding="utf-8"?>
+<p:sld xmlns:a="http://schemas.openxmlformats.org/drawingml/2006/main" xmlns:r="http://schemas.openxmlformats.org/officeDocument/2006/relationships" xmlns:p="http://schemas.openxmlformats.org/presentationml/2006/main">
+  <p:cSld>
+    <p:spTree>
+      <p:nvGrpSpPr>
+        <p:cNvPr id="1" name=""/>
+        <p:cNvGrpSpPr/>
+        <p:nvPr/>
+      </p:nvGrpSpPr>
+      <p:grpSpPr>
+        <a:xfrm>
+          <a:off x="0" y="0"/>
+          <a:ext cx="0" cy="0"/>
+          <a:chOff x="0" y="0"/>
+          <a:chExt cx="0" cy="0"/>
+        </a:xfrm>
+      </p:grpSpPr>
+      <p:pic>
+        <p:nvPicPr>
+          <p:cNvPr id="3" name="Picture 2">
+            <a:extLst>
+              <a:ext uri="{FF2B5EF4-FFF2-40B4-BE49-F238E27FC236}">
+                <a16:creationId xmlns:a16="http://schemas.microsoft.com/office/drawing/2014/main" id="{A4061D74-0A56-433E-B6BD-4AED0DA2887D}"/>
+              </a:ext>
+            </a:extLst>
+          </p:cNvPr>
+          <p:cNvPicPr>
+            <a:picLocks noChangeAspect="1"/>
+          </p:cNvPicPr>
+          <p:nvPr/>
+        </p:nvPicPr>
+        <p:blipFill>
+          <a:blip r:embed="rId2"/>
+          <a:stretch>
+            <a:fillRect/>
+          </a:stretch>
+        </p:blipFill>
+        <p:spPr>
+          <a:xfrm>
+            <a:off x="0" y="771525"/>
+            <a:ext cx="9144000" cy="4371975"/>
+          </a:xfrm>
+          <a:prstGeom prst="rect">
+            <a:avLst/>
+          </a:prstGeom>
+        </p:spPr>
+      </p:pic>
+      <p:sp>
+        <p:nvSpPr>
+          <p:cNvPr id="4" name="TextBox 3">
+            <a:extLst>
+              <a:ext uri="{FF2B5EF4-FFF2-40B4-BE49-F238E27FC236}">
+                <a16:creationId xmlns:a16="http://schemas.microsoft.com/office/drawing/2014/main" id="{B1425EED-8581-8168-9BBB-C309B93722E5}"/>
+              </a:ext>
+            </a:extLst>
+          </p:cNvPr>
+          <p:cNvSpPr txBox="1"/>
+          <p:nvPr/>
+        </p:nvSpPr>
+        <p:spPr>
+          <a:xfrm>
+            <a:off x="3593527" y="220980"/>
+            <a:ext cx="1956946" cy="369332"/>
+          </a:xfrm>
+          <a:prstGeom prst="rect">
+            <a:avLst/>
+          </a:prstGeom>
+          <a:noFill/>
+        </p:spPr>
+        <p:txBody>
+          <a:bodyPr wrap="none" rtlCol="0">
+            <a:spAutoFit/>
+          </a:bodyPr>
+          <a:lstStyle/>
+          <a:p>
+            <a:r>
+              <a:rPr lang="en-IN" dirty="0"/>
+              <a:t>Spar/Stiff = ½ = 0.5</a:t>
+            </a:r>
+          </a:p>
+        </p:txBody>
+      </p:sp>
+    </p:spTree>
+    <p:extLst>
+      <p:ext uri="{BB962C8B-B14F-4D97-AF65-F5344CB8AC3E}">
+        <p14:creationId xmlns:p14="http://schemas.microsoft.com/office/powerpoint/2010/main" val="733238434"/>
+      </p:ext>
+    </p:extLst>
+  </p:cSld>
+  <p:clrMapOvr>
+    <a:masterClrMapping/>
+  </p:clrMapOvr>
+</p:sld>
+</file>
+
+<file path=ppt/slides/slide41.xml><?xml version="1.0" encoding="utf-8"?>
+<p:sld xmlns:a="http://schemas.openxmlformats.org/drawingml/2006/main" xmlns:r="http://schemas.openxmlformats.org/officeDocument/2006/relationships" xmlns:p="http://schemas.openxmlformats.org/presentationml/2006/main">
+  <p:cSld>
+    <p:spTree>
+      <p:nvGrpSpPr>
+        <p:cNvPr id="1" name=""/>
+        <p:cNvGrpSpPr/>
+        <p:nvPr/>
+      </p:nvGrpSpPr>
+      <p:grpSpPr>
+        <a:xfrm>
+          <a:off x="0" y="0"/>
+          <a:ext cx="0" cy="0"/>
+          <a:chOff x="0" y="0"/>
+          <a:chExt cx="0" cy="0"/>
+        </a:xfrm>
+      </p:grpSpPr>
+      <p:pic>
+        <p:nvPicPr>
+          <p:cNvPr id="3" name="Picture 2">
+            <a:extLst>
+              <a:ext uri="{FF2B5EF4-FFF2-40B4-BE49-F238E27FC236}">
+                <a16:creationId xmlns:a16="http://schemas.microsoft.com/office/drawing/2014/main" id="{F1514F8E-7DB0-DE2D-AFC4-06478264DDD1}"/>
+              </a:ext>
+            </a:extLst>
+          </p:cNvPr>
+          <p:cNvPicPr>
+            <a:picLocks noChangeAspect="1"/>
+          </p:cNvPicPr>
+          <p:nvPr/>
+        </p:nvPicPr>
+        <p:blipFill>
+          <a:blip r:embed="rId2"/>
+          <a:stretch>
+            <a:fillRect/>
+          </a:stretch>
+        </p:blipFill>
+        <p:spPr>
+          <a:xfrm>
+            <a:off x="0" y="771525"/>
+            <a:ext cx="9144000" cy="4371975"/>
+          </a:xfrm>
+          <a:prstGeom prst="rect">
+            <a:avLst/>
+          </a:prstGeom>
+        </p:spPr>
+      </p:pic>
+      <p:sp>
+        <p:nvSpPr>
+          <p:cNvPr id="4" name="TextBox 3">
+            <a:extLst>
+              <a:ext uri="{FF2B5EF4-FFF2-40B4-BE49-F238E27FC236}">
+                <a16:creationId xmlns:a16="http://schemas.microsoft.com/office/drawing/2014/main" id="{95F1FC96-E114-C7AF-FDB7-86D97CB82DE9}"/>
+              </a:ext>
+            </a:extLst>
+          </p:cNvPr>
+          <p:cNvSpPr txBox="1"/>
+          <p:nvPr/>
+        </p:nvSpPr>
+        <p:spPr>
+          <a:xfrm>
+            <a:off x="3595610" y="228600"/>
+            <a:ext cx="1952779" cy="369332"/>
+          </a:xfrm>
+          <a:prstGeom prst="rect">
+            <a:avLst/>
+          </a:prstGeom>
+          <a:noFill/>
+        </p:spPr>
+        <p:txBody>
+          <a:bodyPr wrap="none" rtlCol="0">
+            <a:spAutoFit/>
+          </a:bodyPr>
+          <a:lstStyle/>
+          <a:p>
+            <a:r>
+              <a:rPr lang="en-IN" dirty="0"/>
+              <a:t>Spar/Stiff = 1/1 = 1</a:t>
+            </a:r>
+          </a:p>
+        </p:txBody>
+      </p:sp>
+    </p:spTree>
+    <p:extLst>
+      <p:ext uri="{BB962C8B-B14F-4D97-AF65-F5344CB8AC3E}">
+        <p14:creationId xmlns:p14="http://schemas.microsoft.com/office/powerpoint/2010/main" val="1803610564"/>
+      </p:ext>
+    </p:extLst>
+  </p:cSld>
+  <p:clrMapOvr>
+    <a:masterClrMapping/>
+  </p:clrMapOvr>
+</p:sld>
+</file>
+
+<file path=ppt/slides/slide42.xml><?xml version="1.0" encoding="utf-8"?>
+<p:sld xmlns:a="http://schemas.openxmlformats.org/drawingml/2006/main" xmlns:r="http://schemas.openxmlformats.org/officeDocument/2006/relationships" xmlns:p="http://schemas.openxmlformats.org/presentationml/2006/main">
+  <p:cSld>
+    <p:spTree>
+      <p:nvGrpSpPr>
+        <p:cNvPr id="1" name=""/>
+        <p:cNvGrpSpPr/>
+        <p:nvPr/>
+      </p:nvGrpSpPr>
+      <p:grpSpPr>
+        <a:xfrm>
+          <a:off x="0" y="0"/>
+          <a:ext cx="0" cy="0"/>
+          <a:chOff x="0" y="0"/>
+          <a:chExt cx="0" cy="0"/>
+        </a:xfrm>
+      </p:grpSpPr>
+      <p:pic>
+        <p:nvPicPr>
+          <p:cNvPr id="3" name="Picture 2">
+            <a:extLst>
+              <a:ext uri="{FF2B5EF4-FFF2-40B4-BE49-F238E27FC236}">
+                <a16:creationId xmlns:a16="http://schemas.microsoft.com/office/drawing/2014/main" id="{893FA443-A6C1-AAA1-0B3F-A366096F542C}"/>
+              </a:ext>
+            </a:extLst>
+          </p:cNvPr>
+          <p:cNvPicPr>
+            <a:picLocks noChangeAspect="1"/>
+          </p:cNvPicPr>
+          <p:nvPr/>
+        </p:nvPicPr>
+        <p:blipFill>
+          <a:blip r:embed="rId2"/>
+          <a:stretch>
+            <a:fillRect/>
+          </a:stretch>
+        </p:blipFill>
+        <p:spPr>
+          <a:xfrm>
+            <a:off x="0" y="771525"/>
+            <a:ext cx="9144000" cy="4371975"/>
+          </a:xfrm>
+          <a:prstGeom prst="rect">
+            <a:avLst/>
+          </a:prstGeom>
+        </p:spPr>
+      </p:pic>
+      <p:sp>
+        <p:nvSpPr>
+          <p:cNvPr id="4" name="TextBox 3">
+            <a:extLst>
+              <a:ext uri="{FF2B5EF4-FFF2-40B4-BE49-F238E27FC236}">
+                <a16:creationId xmlns:a16="http://schemas.microsoft.com/office/drawing/2014/main" id="{2A647952-3748-4ED1-0838-BF7D0CD64388}"/>
+              </a:ext>
+            </a:extLst>
+          </p:cNvPr>
+          <p:cNvSpPr txBox="1"/>
+          <p:nvPr/>
+        </p:nvSpPr>
+        <p:spPr>
+          <a:xfrm>
+            <a:off x="3422005" y="236220"/>
+            <a:ext cx="2299989" cy="369332"/>
+          </a:xfrm>
+          <a:prstGeom prst="rect">
+            <a:avLst/>
+          </a:prstGeom>
+          <a:noFill/>
+        </p:spPr>
+        <p:txBody>
+          <a:bodyPr wrap="none" rtlCol="0">
+            <a:spAutoFit/>
+          </a:bodyPr>
+          <a:lstStyle/>
+          <a:p>
+            <a:r>
+              <a:rPr lang="en-IN" dirty="0"/>
+              <a:t>Spar/Stiff = 1.5/1 = 1.5</a:t>
+            </a:r>
+          </a:p>
+        </p:txBody>
+      </p:sp>
+    </p:spTree>
+    <p:extLst>
+      <p:ext uri="{BB962C8B-B14F-4D97-AF65-F5344CB8AC3E}">
+        <p14:creationId xmlns:p14="http://schemas.microsoft.com/office/powerpoint/2010/main" val="4108400854"/>
+      </p:ext>
+    </p:extLst>
+  </p:cSld>
+  <p:clrMapOvr>
+    <a:masterClrMapping/>
+  </p:clrMapOvr>
+</p:sld>
+</file>
+
+<file path=ppt/slides/slide43.xml><?xml version="1.0" encoding="utf-8"?>
+<p:sld xmlns:a="http://schemas.openxmlformats.org/drawingml/2006/main" xmlns:r="http://schemas.openxmlformats.org/officeDocument/2006/relationships" xmlns:p="http://schemas.openxmlformats.org/presentationml/2006/main">
+  <p:cSld>
+    <p:spTree>
+      <p:nvGrpSpPr>
+        <p:cNvPr id="1" name=""/>
+        <p:cNvGrpSpPr/>
+        <p:nvPr/>
+      </p:nvGrpSpPr>
+      <p:grpSpPr>
+        <a:xfrm>
+          <a:off x="0" y="0"/>
+          <a:ext cx="0" cy="0"/>
+          <a:chOff x="0" y="0"/>
+          <a:chExt cx="0" cy="0"/>
+        </a:xfrm>
+      </p:grpSpPr>
+      <p:pic>
+        <p:nvPicPr>
+          <p:cNvPr id="3" name="Picture 2">
+            <a:extLst>
+              <a:ext uri="{FF2B5EF4-FFF2-40B4-BE49-F238E27FC236}">
+                <a16:creationId xmlns:a16="http://schemas.microsoft.com/office/drawing/2014/main" id="{EAAD966E-F439-8661-3508-EA4DBB7362D4}"/>
+              </a:ext>
+            </a:extLst>
+          </p:cNvPr>
+          <p:cNvPicPr>
+            <a:picLocks noChangeAspect="1"/>
+          </p:cNvPicPr>
+          <p:nvPr/>
+        </p:nvPicPr>
+        <p:blipFill>
+          <a:blip r:embed="rId2"/>
+          <a:stretch>
+            <a:fillRect/>
+          </a:stretch>
+        </p:blipFill>
+        <p:spPr>
+          <a:xfrm>
+            <a:off x="0" y="771525"/>
+            <a:ext cx="9144000" cy="4371975"/>
+          </a:xfrm>
+          <a:prstGeom prst="rect">
+            <a:avLst/>
+          </a:prstGeom>
+        </p:spPr>
+      </p:pic>
+      <p:sp>
+        <p:nvSpPr>
+          <p:cNvPr id="4" name="TextBox 3">
+            <a:extLst>
+              <a:ext uri="{FF2B5EF4-FFF2-40B4-BE49-F238E27FC236}">
+                <a16:creationId xmlns:a16="http://schemas.microsoft.com/office/drawing/2014/main" id="{E59FE430-A9CF-6BAA-21B0-C4710AF58EBF}"/>
+              </a:ext>
+            </a:extLst>
+          </p:cNvPr>
+          <p:cNvSpPr txBox="1"/>
+          <p:nvPr/>
+        </p:nvSpPr>
+        <p:spPr>
+          <a:xfrm>
+            <a:off x="3570283" y="220980"/>
+            <a:ext cx="2003434" cy="369332"/>
+          </a:xfrm>
+          <a:prstGeom prst="rect">
+            <a:avLst/>
+          </a:prstGeom>
+          <a:noFill/>
+        </p:spPr>
+        <p:txBody>
+          <a:bodyPr wrap="none" rtlCol="0">
+            <a:spAutoFit/>
+          </a:bodyPr>
+          <a:lstStyle/>
+          <a:p>
+            <a:r>
+              <a:rPr lang="en-IN" dirty="0"/>
+              <a:t>Spar/ Stiff = 2/1 = 2</a:t>
+            </a:r>
+          </a:p>
+        </p:txBody>
+      </p:sp>
+    </p:spTree>
+    <p:extLst>
+      <p:ext uri="{BB962C8B-B14F-4D97-AF65-F5344CB8AC3E}">
+        <p14:creationId xmlns:p14="http://schemas.microsoft.com/office/powerpoint/2010/main" val="4245694713"/>
+      </p:ext>
+    </p:extLst>
+  </p:cSld>
+  <p:clrMapOvr>
+    <a:masterClrMapping/>
+  </p:clrMapOvr>
+</p:sld>
+</file>
+
+<file path=ppt/slides/slide44.xml><?xml version="1.0" encoding="utf-8"?>
+<p:sld xmlns:a="http://schemas.openxmlformats.org/drawingml/2006/main" xmlns:r="http://schemas.openxmlformats.org/officeDocument/2006/relationships" xmlns:p="http://schemas.openxmlformats.org/presentationml/2006/main">
+  <p:cSld>
+    <p:spTree>
+      <p:nvGrpSpPr>
+        <p:cNvPr id="1" name=""/>
+        <p:cNvGrpSpPr/>
+        <p:nvPr/>
+      </p:nvGrpSpPr>
+      <p:grpSpPr>
+        <a:xfrm>
+          <a:off x="0" y="0"/>
+          <a:ext cx="0" cy="0"/>
+          <a:chOff x="0" y="0"/>
+          <a:chExt cx="0" cy="0"/>
+        </a:xfrm>
+      </p:grpSpPr>
+      <p:pic>
+        <p:nvPicPr>
+          <p:cNvPr id="3" name="Picture 2">
+            <a:extLst>
+              <a:ext uri="{FF2B5EF4-FFF2-40B4-BE49-F238E27FC236}">
+                <a16:creationId xmlns:a16="http://schemas.microsoft.com/office/drawing/2014/main" id="{2DCC8FC2-77F0-4689-DE82-CD90F15EB779}"/>
+              </a:ext>
+            </a:extLst>
+          </p:cNvPr>
+          <p:cNvPicPr>
+            <a:picLocks noChangeAspect="1"/>
+          </p:cNvPicPr>
+          <p:nvPr/>
+        </p:nvPicPr>
+        <p:blipFill>
+          <a:blip r:embed="rId2"/>
+          <a:stretch>
+            <a:fillRect/>
+          </a:stretch>
+        </p:blipFill>
+        <p:spPr>
+          <a:xfrm>
+            <a:off x="0" y="771525"/>
+            <a:ext cx="9144000" cy="4371975"/>
+          </a:xfrm>
+          <a:prstGeom prst="rect">
+            <a:avLst/>
+          </a:prstGeom>
+        </p:spPr>
+      </p:pic>
+      <p:sp>
+        <p:nvSpPr>
+          <p:cNvPr id="4" name="TextBox 3">
+            <a:extLst>
+              <a:ext uri="{FF2B5EF4-FFF2-40B4-BE49-F238E27FC236}">
+                <a16:creationId xmlns:a16="http://schemas.microsoft.com/office/drawing/2014/main" id="{44F33CA3-1F2B-7B67-18F4-6CA1C19CF744}"/>
+              </a:ext>
+            </a:extLst>
+          </p:cNvPr>
+          <p:cNvSpPr txBox="1"/>
+          <p:nvPr/>
+        </p:nvSpPr>
+        <p:spPr>
+          <a:xfrm>
+            <a:off x="3596733" y="205740"/>
+            <a:ext cx="1950534" cy="369332"/>
+          </a:xfrm>
+          <a:prstGeom prst="rect">
+            <a:avLst/>
+          </a:prstGeom>
+          <a:noFill/>
+        </p:spPr>
+        <p:txBody>
+          <a:bodyPr wrap="none" rtlCol="0">
+            <a:spAutoFit/>
+          </a:bodyPr>
+          <a:lstStyle/>
+          <a:p>
+            <a:r>
+              <a:rPr lang="en-IN" dirty="0"/>
+              <a:t>Spar/Stiff = 2/2 = 2</a:t>
+            </a:r>
+          </a:p>
+        </p:txBody>
+      </p:sp>
+    </p:spTree>
+    <p:extLst>
+      <p:ext uri="{BB962C8B-B14F-4D97-AF65-F5344CB8AC3E}">
+        <p14:creationId xmlns:p14="http://schemas.microsoft.com/office/powerpoint/2010/main" val="2729638649"/>
+      </p:ext>
+    </p:extLst>
+  </p:cSld>
+  <p:clrMapOvr>
+    <a:masterClrMapping/>
+  </p:clrMapOvr>
+</p:sld>
+</file>
+
+<file path=ppt/slides/slide45.xml><?xml version="1.0" encoding="utf-8"?>
+<p:sld xmlns:a="http://schemas.openxmlformats.org/drawingml/2006/main" xmlns:r="http://schemas.openxmlformats.org/officeDocument/2006/relationships" xmlns:p="http://schemas.openxmlformats.org/presentationml/2006/main">
+  <p:cSld name="Slide 10">
+    <p:bg>
+      <p:bgPr>
+        <a:solidFill>
+          <a:srgbClr val="1E1E2E"/>
+        </a:solidFill>
+        <a:effectLst/>
+      </p:bgPr>
+    </p:bg>
+    <p:spTree>
+      <p:nvGrpSpPr>
+        <p:cNvPr id="1" name=""/>
+        <p:cNvGrpSpPr/>
+        <p:nvPr/>
+      </p:nvGrpSpPr>
+      <p:grpSpPr>
+        <a:xfrm>
+          <a:off x="0" y="0"/>
+          <a:ext cx="0" cy="0"/>
+          <a:chOff x="0" y="0"/>
+          <a:chExt cx="0" cy="0"/>
+        </a:xfrm>
+      </p:grpSpPr>
+      <p:sp>
+        <p:nvSpPr>
+          <p:cNvPr id="2" name="Shape 0"/>
+          <p:cNvSpPr/>
+          <p:nvPr/>
+        </p:nvSpPr>
+        <p:spPr>
+          <a:xfrm>
+            <a:off x="0" y="0"/>
+            <a:ext cx="9144000" cy="54864"/>
+          </a:xfrm>
+          <a:prstGeom prst="rect">
+            <a:avLst/>
+          </a:prstGeom>
+          <a:solidFill>
+            <a:srgbClr val="4A90D9"/>
+          </a:solidFill>
+          <a:ln w="12700">
+            <a:solidFill>
+              <a:srgbClr val="4A90D9"/>
+            </a:solidFill>
+            <a:prstDash val="solid"/>
+          </a:ln>
+        </p:spPr>
+      </p:sp>
+      <p:sp>
+        <p:nvSpPr>
+          <p:cNvPr id="3" name="Text 1"/>
+          <p:cNvSpPr/>
+          <p:nvPr/>
+        </p:nvSpPr>
+        <p:spPr>
+          <a:xfrm>
+            <a:off x="548640" y="1371600"/>
+            <a:ext cx="8046720" cy="1005840"/>
+          </a:xfrm>
+          <a:prstGeom prst="rect">
+            <a:avLst/>
+          </a:prstGeom>
+          <a:noFill/>
+          <a:ln/>
+        </p:spPr>
+        <p:txBody>
+          <a:bodyPr wrap="square" rtlCol="0" anchor="ctr"/>
+          <a:lstStyle/>
+          <a:p>
+            <a:pPr marL="0" indent="0" algn="ctr">
+              <a:buNone/>
+            </a:pPr>
+            <a:r>
+              <a:rPr lang="en-US" sz="5200" b="1" dirty="0">
+                <a:solidFill>
+                  <a:srgbClr val="FFFFFF"/>
+                </a:solidFill>
+                <a:latin typeface="Calibri" pitchFamily="34" charset="0"/>
+                <a:ea typeface="Calibri" pitchFamily="34" charset="-122"/>
+                <a:cs typeface="Calibri" pitchFamily="34" charset="-120"/>
+              </a:rPr>
+              <a:t>Thank You</a:t>
+            </a:r>
+            <a:endParaRPr lang="en-US" sz="5200" dirty="0"/>
+          </a:p>
+        </p:txBody>
+      </p:sp>
+      <p:sp>
+        <p:nvSpPr>
+          <p:cNvPr id="4" name="Text 2"/>
+          <p:cNvSpPr/>
+          <p:nvPr/>
+        </p:nvSpPr>
+        <p:spPr>
+          <a:xfrm>
+            <a:off x="548640" y="2377440"/>
+            <a:ext cx="8046720" cy="411480"/>
+          </a:xfrm>
+          <a:prstGeom prst="rect">
+            <a:avLst/>
+          </a:prstGeom>
+          <a:noFill/>
+          <a:ln/>
+        </p:spPr>
+        <p:txBody>
+          <a:bodyPr wrap="square" rtlCol="0" anchor="ctr"/>
+          <a:lstStyle/>
+          <a:p>
+            <a:pPr marL="0" indent="0" algn="ctr">
+              <a:buNone/>
+            </a:pPr>
+            <a:r>
+              <a:rPr lang="en-US" sz="1600" dirty="0">
+                <a:solidFill>
+                  <a:srgbClr val="9CA3AF"/>
+                </a:solidFill>
+                <a:latin typeface="Calibri" pitchFamily="34" charset="0"/>
+                <a:ea typeface="Calibri" pitchFamily="34" charset="-122"/>
+                <a:cs typeface="Calibri" pitchFamily="34" charset="-120"/>
+              </a:rPr>
+              <a:t>for your time and attention</a:t>
+            </a:r>
+            <a:endParaRPr lang="en-US" sz="1600" dirty="0"/>
+          </a:p>
+        </p:txBody>
+      </p:sp>
+      <p:sp>
+        <p:nvSpPr>
+          <p:cNvPr id="5" name="Shape 3"/>
+          <p:cNvSpPr/>
+          <p:nvPr/>
+        </p:nvSpPr>
+        <p:spPr>
+          <a:xfrm>
+            <a:off x="3200400" y="2971800"/>
+            <a:ext cx="2743200" cy="36576"/>
+          </a:xfrm>
+          <a:prstGeom prst="rect">
+            <a:avLst/>
+          </a:prstGeom>
+          <a:solidFill>
+            <a:srgbClr val="4A90D9"/>
+          </a:solidFill>
+          <a:ln w="12700">
+            <a:solidFill>
+              <a:srgbClr val="4A90D9"/>
+            </a:solidFill>
+            <a:prstDash val="solid"/>
+          </a:ln>
+        </p:spPr>
+      </p:sp>
+      <p:sp>
+        <p:nvSpPr>
+          <p:cNvPr id="6" name="Text 4"/>
+          <p:cNvSpPr/>
+          <p:nvPr/>
+        </p:nvSpPr>
+        <p:spPr>
+          <a:xfrm>
+            <a:off x="548640" y="3200400"/>
+            <a:ext cx="8046720" cy="822960"/>
+          </a:xfrm>
+          <a:prstGeom prst="rect">
+            <a:avLst/>
+          </a:prstGeom>
+          <a:noFill/>
+          <a:ln/>
+        </p:spPr>
+        <p:txBody>
+          <a:bodyPr wrap="square" rtlCol="0" anchor="ctr"/>
+          <a:lstStyle/>
+          <a:p>
+            <a:pPr marL="0" indent="0" algn="ctr">
+              <a:buNone/>
+            </a:pPr>
+            <a:r>
+              <a:rPr lang="en-US" sz="1200" b="1" dirty="0">
+                <a:solidFill>
+                  <a:srgbClr val="D1D5DB"/>
+                </a:solidFill>
+                <a:latin typeface="Calibri" pitchFamily="34" charset="0"/>
+                <a:ea typeface="Calibri" pitchFamily="34" charset="-122"/>
+                <a:cs typeface="Calibri" pitchFamily="34" charset="-120"/>
+              </a:rPr>
+              <a:t>Anoop Patel  |  Intern
+</a:t>
+            </a:r>
+            <a:r>
+              <a:rPr lang="en-US" sz="1200" dirty="0">
+                <a:solidFill>
+                  <a:srgbClr val="D1D5DB"/>
+                </a:solidFill>
+                <a:latin typeface="Calibri" pitchFamily="34" charset="0"/>
+                <a:ea typeface="Calibri" pitchFamily="34" charset="-122"/>
+                <a:cs typeface="Calibri" pitchFamily="34" charset="-120"/>
+              </a:rPr>
+              <a:t>Mechanical Engineering, NIT Sikkim
+</a:t>
+            </a:r>
+            <a:r>
+              <a:rPr lang="en-US" sz="1200" dirty="0">
+                <a:solidFill>
+                  <a:srgbClr val="9CA3AF"/>
+                </a:solidFill>
+                <a:latin typeface="Calibri" pitchFamily="34" charset="0"/>
+                <a:ea typeface="Calibri" pitchFamily="34" charset="-122"/>
+                <a:cs typeface="Calibri" pitchFamily="34" charset="-120"/>
+              </a:rPr>
+              <a:t>Guide: Dr Sai Sidhardh</a:t>
+            </a:r>
+            <a:endParaRPr lang="en-US" sz="1200" dirty="0"/>
+          </a:p>
+        </p:txBody>
+      </p:sp>
+      <p:sp>
+        <p:nvSpPr>
+          <p:cNvPr id="7" name="Text 5"/>
+          <p:cNvSpPr/>
+          <p:nvPr/>
+        </p:nvSpPr>
+        <p:spPr>
+          <a:xfrm>
+            <a:off x="548640" y="4297680"/>
+            <a:ext cx="8046720" cy="320040"/>
+          </a:xfrm>
+          <a:prstGeom prst="rect">
+            <a:avLst/>
+          </a:prstGeom>
+          <a:noFill/>
+          <a:ln/>
+        </p:spPr>
+        <p:txBody>
+          <a:bodyPr wrap="square" rtlCol="0" anchor="ctr"/>
+          <a:lstStyle/>
+          <a:p>
+            <a:pPr marL="0" indent="0" algn="ctr">
+              <a:buNone/>
+            </a:pPr>
+            <a:r>
+              <a:rPr lang="en-US" sz="1100" dirty="0">
+                <a:solidFill>
+                  <a:srgbClr val="6B7280"/>
+                </a:solidFill>
+                <a:latin typeface="Calibri" pitchFamily="34" charset="0"/>
+                <a:ea typeface="Calibri" pitchFamily="34" charset="-122"/>
+                <a:cs typeface="Calibri" pitchFamily="34" charset="-120"/>
+              </a:rPr>
+              <a:t>Reference: Y. Chen, PhD Thesis — Harvard University, 2017</a:t>
+            </a:r>
+            <a:endParaRPr lang="en-US" sz="1100" dirty="0"/>
+          </a:p>
+        </p:txBody>
+      </p:sp>
+      <p:sp>
+        <p:nvSpPr>
+          <p:cNvPr id="8" name="Shape 6"/>
+          <p:cNvSpPr/>
+          <p:nvPr/>
+        </p:nvSpPr>
+        <p:spPr>
+          <a:xfrm>
+            <a:off x="0" y="5088636"/>
+            <a:ext cx="9144000" cy="54864"/>
+          </a:xfrm>
+          <a:prstGeom prst="rect">
+            <a:avLst/>
+          </a:prstGeom>
+          <a:solidFill>
+            <a:srgbClr val="4A90D9"/>
+          </a:solidFill>
+          <a:ln w="12700">
+            <a:solidFill>
+              <a:srgbClr val="4A90D9"/>
+            </a:solidFill>
+            <a:prstDash val="solid"/>
+          </a:ln>
+        </p:spPr>
+      </p:sp>
+    </p:spTree>
   </p:cSld>
   <p:clrMapOvr>
     <a:masterClrMapping/>

</xml_diff>